<commit_message>
Make ChatGPT Codex the course's primary agent
Lesson 2 now teaches Codex cloud: AGENTS.md as the single context file
(Exercise 1 improves the Lesson 1 draft), Codex setup at
chatgpt.com/codex, tasks instead of sessions, codex/ branches, and
@codex PR comments for fixes. Claude Code stays on the tool-options
slide as an alternative. Edited in place; layouts and notes kept.
Lesson 1 drops one CLAUDE.md speaker note.

The README syllabus names Codex for Lessons 2-5. The repo's own agent
guidance moves to AGENTS.md; CLAUDE.md now imports it.

Co-Authored-By: Claude Opus 5.5 <noreply@anthropic.com>
Claude-Session: https://claude.ai/code/session_01EceYBcFXTaBjFSFEfqpJfg
</commit_message>
<xml_diff>
--- a/Lesson Material/LSN 2 - Introduction to Agentic AI for Coding/Agentic_AI_for_Engineering_Lesson_2.pptx
+++ b/Lesson Material/LSN 2 - Introduction to Agentic AI for Coding/Agentic_AI_for_Engineering_Lesson_2.pptx
@@ -522,8 +522,7 @@
           <a:lstStyle/>
           <a:p>
             <a:r>
-              <a:rPr lang="en-US" dirty="0"/>
-              <a:t>Lesson 2 connects the repo from Lesson 1 to a coding agent. The goal is a repeatable loop: specify a verifiable change, let the agent generate it on a branch, and verify it yourself before it reaches main. Everything we do today with beam-calc applies to your own course code in Exercise 7.</a:t>
+              <a:t>Lesson 2 connects the repo from Lesson 1 to a coding agent, ChatGPT Codex. The goal is a repeatable loop: specify a verifiable change, let the agent generate it on a branch, and verify it yourself before it reaches main. Everything we do today with beam-calc applies to your own course code in Exercise 7.</a:t>
             </a:r>
           </a:p>
         </p:txBody>
@@ -581,8 +580,7 @@
           <a:lstStyle/>
           <a:p>
             <a:r>
-              <a:rPr lang="en-US" dirty="0"/>
-              <a:t>The orientation prompt costs one message and tells you whether the agent understands the code. A good answer names the formula, the units, the test, and its own limits. If the summary is wrong, fix CLAUDE.md before going further.</a:t>
+              <a:t>The orientation prompt costs one message and tells you whether the agent understands the code. If the Codex interface offers an Ask (question-only) mode, use it here. A good answer names the formula, the units, the test, and its own limits. If the summary is wrong, fix AGENTS.md before going further.</a:t>
             </a:r>
           </a:p>
         </p:txBody>
@@ -699,8 +697,7 @@
           <a:lstStyle/>
           <a:p>
             <a:r>
-              <a:rPr lang="en-US" dirty="0"/>
-              <a:t>The agent pushes to a new claude/ branch, never directly to main. Walk through the diff line by line. Look hardest at the test: an agent that writes both the code and its test can make them agree with each other and still be wrong. Here the expected value 2.40e-3 m comes from our hand calculation, not from the code. The ... in the fprintf lines is shortened for the slide.</a:t>
+              <a:t>Codex works on its own branch, never directly on main. Codex names the branch when you create the pull request, so yours will differ from codex/udl-deflection. Walk through the diff line by line. Look hardest at the test: an agent that writes both the code and its test can make them agree with each other and still be wrong. Here the expected value 2.40e-3 m comes from our hand calculation, not from the code. The ... in the fprintf lines is shortened for the slide.</a:t>
             </a:r>
           </a:p>
         </p:txBody>
@@ -758,8 +755,7 @@
           <a:lstStyle/>
           <a:p>
             <a:r>
-              <a:rPr lang="en-US" dirty="0"/>
-              <a:t>Same branches and pull requests as Lesson 1, with the agent as the other contributor. The agent never commits to main. Each session gets its own branch, and every commit in that session, including fixes, goes there. The pull request is where the review happens, and where the change is merged after the test passes.</a:t>
+              <a:t>Same branches and pull requests as Lesson 1, with the agent as the other contributor. Codex never commits to main. The pull request is where the review happens, and where the change is merged after the test passes. To get a fix onto the same pull request, comment on it with @codex and the request; Codex starts a task with the PR as context and can push to its branch. Follow-ups inside the original task may or may not update the PR, depending on the current Codex interface.</a:t>
             </a:r>
           </a:p>
         </p:txBody>
@@ -876,8 +872,7 @@
           <a:lstStyle/>
           <a:p>
             <a:r>
-              <a:rPr lang="en-US" dirty="0"/>
-              <a:t>Failure reports should contain observations and logs, not just ‘it doesn’t work’. Asking for an explanation before a fix keeps the engineer in the loop and often exposes a wrong assumption (here, a section dimension entered in mm). One requirement per session keeps context small and commits easy to review.</a:t>
+              <a:t>Failure reports should contain observations and logs, not just ‘it doesn’t work’. Commenting @codex on the pull request keeps the fix on the same branch and the discussion on the PR, where reviewers can see it. Asking for an explanation before a fix keeps the engineer in the loop and often exposes a wrong assumption (here, a section dimension entered in mm). One requirement per task keeps context small and commits easy to review.</a:t>
             </a:r>
           </a:p>
         </p:txBody>
@@ -994,8 +989,7 @@
           <a:lstStyle/>
           <a:p>
             <a:r>
-              <a:rPr lang="en-US" dirty="0"/>
-              <a:t>Instructors who document their own agent use are better placed to set and grade the same expectation for cadets. An AI_LOG.md, one entry per session, records how GenAI contributed and what the human did to evaluate it. Check the current USAFA and department GenAI policy for the exact wording your course requires.</a:t>
+              <a:t>Instructors who document their own agent use are better placed to set and grade the same expectation for cadets. An AI_LOG.md, one entry per Codex task, records how GenAI contributed and what the human did to evaluate it. Check the current USAFA and department GenAI policy for the exact wording your course requires.</a:t>
             </a:r>
           </a:p>
         </p:txBody>
@@ -1053,8 +1047,7 @@
           <a:lstStyle/>
           <a:p>
             <a:r>
-              <a:rPr lang="en-US" dirty="0"/>
-              <a:t>Move from the shared example to each instructor’s own project. Coach toward small, checkable requirements; the first session is about learning the loop, not shipping a large feature. Walk the room and look at requirements before people open sessions: a requirement with no verification is the most common problem.</a:t>
+              <a:t>Move from the shared example to each instructor’s own project. Coach toward small, checkable requirements; the first task is about learning the loop, not shipping a large feature. Walk the room and look at requirements before people start tasks: a requirement with no verification is the most common problem.</a:t>
             </a:r>
           </a:p>
         </p:txBody>
@@ -1112,8 +1105,7 @@
           <a:lstStyle/>
           <a:p>
             <a:r>
-              <a:rPr lang="en-US" dirty="0"/>
-              <a:t>When you bring this to a course, decide the team model up front. A session belongs to one account; teammates cannot join it live, so the repo is where collaboration happens. Grading the artifacts of the process (requirement, plan, review, verification, log) rewards the engineering judgment we care about rather than the volume of generated code.</a:t>
+              <a:t>When you bring this to a course, decide the team model up front. A Codex task belongs to one ChatGPT account; teammates cannot join it, so the repo is where collaboration happens. Grading the artifacts of the process (requirement, plan, review, verification, log) rewards the engineering judgment we care about rather than the volume of generated code.</a:t>
             </a:r>
           </a:p>
         </p:txBody>
@@ -1230,8 +1222,7 @@
           <a:lstStyle/>
           <a:p>
             <a:r>
-              <a:rPr lang="en-US" dirty="0"/>
-              <a:t>These are the problems instructors hit most often in a first session. Most come back to two ideas: GitHub is the hand-off point, so fetch before you look for agent work; and the agent cannot run MATLAB, so verification is always yours.</a:t>
+              <a:t>These are the problems instructors hit most often in a first Codex task. Most come back to two ideas: GitHub is the hand-off point, so the agent’s work only reaches your laptop after it is on a branch and you fetch; and the agent cannot run MATLAB, so verification is always yours.</a:t>
             </a:r>
           </a:p>
         </p:txBody>
@@ -1348,8 +1339,7 @@
           <a:lstStyle/>
           <a:p>
             <a:r>
-              <a:rPr lang="en-US" dirty="0"/>
-              <a:t>Expected answers. 1: it reads the repo, edits files, runs commands, and commits; you move from integrator to specifier, reviewer, and tester. 2: project context, environment limits, and rules; CLAUDE.md can import AGENTS.md so every agent shares one set of rules. 3: it catches wrong assumptions and open questions cheaply, before code exists. 4: verify it yourself; the agent cannot run MATLAB. 5: not without an independent reason the old value was wrong; a test edited to pass is not evidence.</a:t>
+              <a:t>Expected answers. 1: it reads the repo, edits files, runs commands, and commits; you move from integrator to specifier, reviewer, and tester. 2: project context, environment limits, conventions, and rules; short because Codex reads it every task and long files bury the rules that matter. 3: it catches wrong assumptions and open questions cheaply, before code exists. 4: verify it yourself; the agent cannot run MATLAB. 5: not without an independent reason the old value was wrong; a test edited to pass is not evidence.</a:t>
             </a:r>
           </a:p>
         </p:txBody>
@@ -1407,8 +1397,7 @@
           <a:lstStyle/>
           <a:p>
             <a:r>
-              <a:rPr lang="en-US" dirty="0"/>
-              <a:t>The agent account is the usual blocker; sort it out before class. Use whatever account type your organization directs. MATLAB is optional but strongly recommended: the agent cannot run MATLAB in its cloud sandbox, so the instructor is the only one who can execute the tests. That gap is the point of the Adjudicate step.</a:t>
+              <a:t>The agent account is the usual blocker; sort it out before class. Codex cloud comes with ChatGPT Plus and higher, including Business, Edu, and Enterprise workspaces; use whatever account type your organization directs. MATLAB is optional but strongly recommended: the agent cannot run MATLAB in its cloud environment, so the instructor is the only one who can execute the tests. That gap is the point of the Adjudicate step.</a:t>
             </a:r>
           </a:p>
         </p:txBody>
@@ -1584,8 +1573,7 @@
           <a:lstStyle/>
           <a:p>
             <a:r>
-              <a:rPr lang="en-US" dirty="0"/>
-              <a:t>Claude Code on the web is the worked example because it runs entirely from a GitHub repo, which is what Lesson 1 set up. The method transfers to any agent. Codex reads AGENTS.md, which is why the beam-calc repo already has one; CLAUDE.md can import it. Verify current plans before recommending a tool to colleagues or cadets.</a:t>
+              <a:t>Codex cloud is the worked example because it runs entirely from a GitHub repo, which is what Lesson 1 set up, and because it reads AGENTS.md, which the beam-calc repo already has. The method transfers to any agent: Claude Code reads CLAUDE.md, which can import AGENTS.md with an @AGENTS.md line; Copilot reads its own instructions file. Lesson 4 uses Codex locally, in the VS Code extension. Verify current plans before recommending a tool to colleagues or cadets.</a:t>
             </a:r>
           </a:p>
         </p:txBody>
@@ -1702,8 +1690,7 @@
           <a:lstStyle/>
           <a:p>
             <a:r>
-              <a:rPr lang="en-US" dirty="0"/>
-              <a:t>CLAUDE.md is the most effective single thing you can do to improve agent output. It is plain Markdown at the repo root. The @AGENTS.md line pulls in the Lesson 1 file, so Codex and Claude Code follow the same conventions without duplicating them. Alternative: type /init in a session and the agent drafts CLAUDE.md by scanning the repo; then correct it and add what it can’t see, like the fact that it can’t run MATLAB. About me sets the explanation level; in any prompt you can also ask it to explain like you are new to Git.</a:t>
+              <a:t>AGENTS.md is the most effective single thing you can do to improve agent output. It is plain Markdown at the repo root, and instructors already wrote a first draft in Lesson 1; today they make it useful. About me sets the explanation level. The Environment and checks section matters most: Codex cannot run MATLAB in its cloud environment, so it should say what it could not verify instead of claiming the tests pass. Claude Code users can add a one-line CLAUDE.md containing @AGENTS.md to share the same rules.</a:t>
             </a:r>
           </a:p>
         </p:txBody>
@@ -1761,8 +1748,7 @@
           <a:lstStyle/>
           <a:p>
             <a:r>
-              <a:rPr lang="en-US" dirty="0"/>
-              <a:t>Emphasize the architecture: the agent never touches the laptop. GitHub is the hand-off point between the cloud session and your machine, which is why Lesson 1 spent so long on push, fetch, and pull. Grant the GitHub App access to selected repositories only, not your whole account.</a:t>
+              <a:t>Emphasize the architecture: the agent never touches the laptop. GitHub is the hand-off point between the Codex cloud environment and your machine, which is why Lesson 1 spent so long on push, fetch, and pull. Grant the GitHub connection access to selected repositories only, not your whole account. The Codex interface changes often; check the labels before class, but the steps stay the same: sign in, connect GitHub, set up an environment for the repo, start a task.</a:t>
             </a:r>
           </a:p>
         </p:txBody>
@@ -3727,7 +3713,7 @@
           <a:p>
             <a:r>
               <a:rPr lang="en-US" dirty="0"/>
-              <a:t>Hands-on with Claude Code on the web</a:t>
+              <a:t>Hands-on with ChatGPT Codex</a:t>
             </a:r>
             <a:endParaRPr lang="en-US" dirty="0"/>
           </a:p>
@@ -3848,6 +3834,10 @@
           </a:solidFill>
           <a:ln/>
         </p:spPr>
+        <p:txBody>
+          <a:bodyPr/>
+          <a:p/>
+        </p:txBody>
       </p:sp>
       <p:sp xmlns:p="http://schemas.openxmlformats.org/presentationml/2006/main" xmlns:a="http://schemas.openxmlformats.org/drawingml/2006/main" xmlns:r="http://schemas.openxmlformats.org/officeDocument/2006/relationships">
         <p:nvSpPr>
@@ -3952,6 +3942,10 @@
           </a:solidFill>
           <a:ln/>
         </p:spPr>
+        <p:txBody>
+          <a:bodyPr/>
+          <a:p/>
+        </p:txBody>
       </p:sp>
       <p:sp xmlns:p="http://schemas.openxmlformats.org/presentationml/2006/main" xmlns:a="http://schemas.openxmlformats.org/drawingml/2006/main" xmlns:r="http://schemas.openxmlformats.org/officeDocument/2006/relationships">
         <p:nvSpPr>
@@ -4032,7 +4026,7 @@
                 <a:ea typeface="+mn-ea"/>
                 <a:cs typeface="+mn-cs"/>
               </a:rPr>
-              <a:t>Read CLAUDE.md, AGENTS.md, beam.m, and tests/testBeam.m. Summarize what the code computes, its units, and how it is tested. Don’t change any files.</a:t>
+              <a:t>Read AGENTS.md, beam.m, and tests/testBeam.m. Summarize what the code computes, its units, and how it is tested. Don’t change any files.</a:t>
             </a:r>
             <a:endParaRPr lang="en-US" sz="1800" dirty="0"/>
           </a:p>
@@ -4059,6 +4053,10 @@
           </a:solidFill>
           <a:ln/>
         </p:spPr>
+        <p:txBody>
+          <a:bodyPr/>
+          <a:p/>
+        </p:txBody>
       </p:sp>
       <p:sp xmlns:p="http://schemas.openxmlformats.org/presentationml/2006/main" xmlns:a="http://schemas.openxmlformats.org/drawingml/2006/main" xmlns:r="http://schemas.openxmlformats.org/officeDocument/2006/relationships">
         <p:nvSpPr>
@@ -5018,6 +5016,10 @@
           </a:solidFill>
           <a:ln/>
         </p:spPr>
+        <p:txBody>
+          <a:bodyPr/>
+          <a:p/>
+        </p:txBody>
       </p:sp>
       <p:sp xmlns:p="http://schemas.openxmlformats.org/presentationml/2006/main" xmlns:a="http://schemas.openxmlformats.org/drawingml/2006/main" xmlns:r="http://schemas.openxmlformats.org/officeDocument/2006/relationships">
         <p:nvSpPr>
@@ -5057,7 +5059,7 @@
                 <a:ea typeface="Consolas" pitchFamily="34" charset="-122"/>
                 <a:cs typeface="Consolas" pitchFamily="34" charset="-120"/>
               </a:rPr>
-              <a:t>claude/udl-deflection · 3 files  +12 −0</a:t>
+              <a:t>codex/udl-deflection · 3 files  +12 −0</a:t>
             </a:r>
             <a:endParaRPr lang="en-US" sz="1500" dirty="0"/>
           </a:p>
@@ -5404,6 +5406,10 @@
           </a:solidFill>
           <a:ln/>
         </p:spPr>
+        <p:txBody>
+          <a:bodyPr/>
+          <a:p/>
+        </p:txBody>
       </p:sp>
       <p:sp xmlns:p="http://schemas.openxmlformats.org/presentationml/2006/main" xmlns:a="http://schemas.openxmlformats.org/drawingml/2006/main" xmlns:r="http://schemas.openxmlformats.org/officeDocument/2006/relationships">
         <p:nvSpPr>
@@ -5759,7 +5765,7 @@
                 <a:ea typeface="+mn-ea"/>
                 <a:cs typeface="+mn-cs"/>
               </a:rPr>
-              <a:t xml:space="preserve">Select </a:t>
+              <a:t xml:space="preserve">Create the </a:t>
             </a:r>
             <a:r>
               <a:rPr lang="en-US" sz="1875" b="1" dirty="0">
@@ -5770,7 +5776,7 @@
                 <a:ea typeface="+mn-ea"/>
                 <a:cs typeface="+mn-cs"/>
               </a:rPr>
-              <a:t>Create PR</a:t>
+              <a:t>pull request</a:t>
             </a:r>
             <a:r>
               <a:rPr lang="en-US" sz="1875" dirty="0">
@@ -5781,7 +5787,7 @@
                 <a:ea typeface="+mn-ea"/>
                 <a:cs typeface="+mn-cs"/>
               </a:rPr>
-              <a:t xml:space="preserve"> in the session.</a:t>
+              <a:t xml:space="preserve"> from the task.</a:t>
             </a:r>
             <a:endParaRPr lang="en-US" sz="1875" dirty="0"/>
           </a:p>
@@ -5990,6 +5996,10 @@
           </a:solidFill>
           <a:ln/>
         </p:spPr>
+        <p:txBody>
+          <a:bodyPr/>
+          <a:p/>
+        </p:txBody>
       </p:sp>
       <p:sp xmlns:p="http://schemas.openxmlformats.org/presentationml/2006/main" xmlns:a="http://schemas.openxmlformats.org/drawingml/2006/main" xmlns:r="http://schemas.openxmlformats.org/officeDocument/2006/relationships">
         <p:nvSpPr>
@@ -6010,6 +6020,10 @@
           </a:solidFill>
           <a:ln/>
         </p:spPr>
+        <p:txBody>
+          <a:bodyPr/>
+          <a:p/>
+        </p:txBody>
       </p:sp>
       <p:sp xmlns:p="http://schemas.openxmlformats.org/presentationml/2006/main" xmlns:a="http://schemas.openxmlformats.org/drawingml/2006/main" xmlns:r="http://schemas.openxmlformats.org/officeDocument/2006/relationships">
         <p:nvSpPr>
@@ -6030,6 +6044,10 @@
           </a:solidFill>
           <a:ln/>
         </p:spPr>
+        <p:txBody>
+          <a:bodyPr/>
+          <a:p/>
+        </p:txBody>
       </p:sp>
       <p:sp xmlns:p="http://schemas.openxmlformats.org/presentationml/2006/main" xmlns:a="http://schemas.openxmlformats.org/drawingml/2006/main" xmlns:r="http://schemas.openxmlformats.org/officeDocument/2006/relationships">
         <p:nvSpPr>
@@ -6050,6 +6068,10 @@
           </a:solidFill>
           <a:ln/>
         </p:spPr>
+        <p:txBody>
+          <a:bodyPr/>
+          <a:p/>
+        </p:txBody>
       </p:sp>
       <p:sp xmlns:p="http://schemas.openxmlformats.org/presentationml/2006/main" xmlns:a="http://schemas.openxmlformats.org/drawingml/2006/main" xmlns:r="http://schemas.openxmlformats.org/officeDocument/2006/relationships">
         <p:nvSpPr>
@@ -6075,6 +6097,10 @@
             <a:prstDash val="solid"/>
           </a:ln>
         </p:spPr>
+        <p:txBody>
+          <a:bodyPr/>
+          <a:p/>
+        </p:txBody>
       </p:sp>
       <p:sp xmlns:p="http://schemas.openxmlformats.org/presentationml/2006/main" xmlns:a="http://schemas.openxmlformats.org/drawingml/2006/main" xmlns:r="http://schemas.openxmlformats.org/officeDocument/2006/relationships">
         <p:nvSpPr>
@@ -6182,6 +6208,10 @@
             <a:prstDash val="solid"/>
           </a:ln>
         </p:spPr>
+        <p:txBody>
+          <a:bodyPr/>
+          <a:p/>
+        </p:txBody>
       </p:sp>
       <p:sp xmlns:p="http://schemas.openxmlformats.org/presentationml/2006/main" xmlns:a="http://schemas.openxmlformats.org/drawingml/2006/main" xmlns:r="http://schemas.openxmlformats.org/officeDocument/2006/relationships">
         <p:nvSpPr>
@@ -6284,6 +6314,10 @@
           </a:solidFill>
           <a:ln/>
         </p:spPr>
+        <p:txBody>
+          <a:bodyPr/>
+          <a:p/>
+        </p:txBody>
       </p:sp>
       <p:sp xmlns:p="http://schemas.openxmlformats.org/presentationml/2006/main" xmlns:a="http://schemas.openxmlformats.org/drawingml/2006/main" xmlns:r="http://schemas.openxmlformats.org/officeDocument/2006/relationships">
         <p:nvSpPr>
@@ -6386,6 +6420,10 @@
           </a:solidFill>
           <a:ln/>
         </p:spPr>
+        <p:txBody>
+          <a:bodyPr/>
+          <a:p/>
+        </p:txBody>
       </p:sp>
       <p:sp xmlns:p="http://schemas.openxmlformats.org/presentationml/2006/main" xmlns:a="http://schemas.openxmlformats.org/drawingml/2006/main" xmlns:r="http://schemas.openxmlformats.org/officeDocument/2006/relationships">
         <p:nvSpPr>
@@ -6504,7 +6542,7 @@
                 <a:ea typeface="+mn-ea"/>
                 <a:cs typeface="+mn-cs"/>
               </a:rPr>
-              <a:t>claude/…</a:t>
+              <a:t>codex/…</a:t>
             </a:r>
             <a:endParaRPr lang="en-US" sz="1500" dirty="0"/>
           </a:p>
@@ -6630,7 +6668,7 @@
                 <a:ea typeface="+mn-ea"/>
                 <a:cs typeface="+mn-cs"/>
               </a:rPr>
-              <a:t>Each session creates its own claude/… branch and pushes every commit there, including fixes.</a:t>
+              <a:t>Codex puts each task’s changes on their own codex/… branch when you create the pull request.</a:t>
             </a:r>
             <a:endParaRPr lang="en-US" sz="1875" dirty="0"/>
           </a:p>
@@ -6650,7 +6688,7 @@
                 <a:ea typeface="+mn-ea"/>
                 <a:cs typeface="+mn-cs"/>
               </a:rPr>
-              <a:t>main is unchanged until you merge.</a:t>
+              <a:t>For fixes, ask in the task or comment @codex on the PR. main is unchanged until you merge.</a:t>
             </a:r>
             <a:endParaRPr lang="en-US" sz="1875" dirty="0"/>
           </a:p>
@@ -6779,7 +6817,7 @@
                 <a:ea typeface="+mn-ea"/>
                 <a:cs typeface="+mn-cs"/>
               </a:rPr>
-              <a:t xml:space="preserve">Select </a:t>
+              <a:t xml:space="preserve">Create the </a:t>
             </a:r>
             <a:r>
               <a:rPr lang="en-US" sz="1875" b="1" dirty="0">
@@ -6790,7 +6828,7 @@
                 <a:ea typeface="+mn-ea"/>
                 <a:cs typeface="+mn-cs"/>
               </a:rPr>
-              <a:t>Create PR</a:t>
+              <a:t>pull request</a:t>
             </a:r>
             <a:r>
               <a:rPr lang="en-US" sz="1875" dirty="0">
@@ -6801,7 +6839,7 @@
                 <a:ea typeface="+mn-ea"/>
                 <a:cs typeface="+mn-cs"/>
               </a:rPr>
-              <a:t xml:space="preserve"> in the session.</a:t>
+              <a:t xml:space="preserve"> from the task.</a:t>
             </a:r>
             <a:endParaRPr lang="en-US" sz="1875" dirty="0"/>
           </a:p>
@@ -7257,6 +7295,10 @@
           </a:solidFill>
           <a:ln/>
         </p:spPr>
+        <p:txBody>
+          <a:bodyPr/>
+          <a:p/>
+        </p:txBody>
       </p:sp>
       <p:sp xmlns:p="http://schemas.openxmlformats.org/presentationml/2006/main" xmlns:a="http://schemas.openxmlformats.org/drawingml/2006/main" xmlns:r="http://schemas.openxmlformats.org/officeDocument/2006/relationships">
         <p:nvSpPr>
@@ -7414,7 +7456,7 @@
                 <a:ea typeface="+mn-ea"/>
                 <a:cs typeface="+mn-cs"/>
               </a:rPr>
-              <a:t>claude/udl-deflection</a:t>
+              <a:t>codex/udl-deflection</a:t>
             </a:r>
             <a:r>
               <a:rPr lang="en-US" sz="1950" dirty="0">
@@ -7714,6 +7756,10 @@
             <a:prstDash val="solid"/>
           </a:ln>
         </p:spPr>
+        <p:txBody>
+          <a:bodyPr/>
+          <a:p/>
+        </p:txBody>
       </p:sp>
       <p:sp xmlns:p="http://schemas.openxmlformats.org/presentationml/2006/main" xmlns:a="http://schemas.openxmlformats.org/drawingml/2006/main" xmlns:r="http://schemas.openxmlformats.org/officeDocument/2006/relationships">
         <p:nvSpPr>
@@ -7797,6 +7843,10 @@
           </a:solidFill>
           <a:ln/>
         </p:spPr>
+        <p:txBody>
+          <a:bodyPr/>
+          <a:p/>
+        </p:txBody>
       </p:sp>
       <p:sp xmlns:p="http://schemas.openxmlformats.org/presentationml/2006/main" xmlns:a="http://schemas.openxmlformats.org/drawingml/2006/main" xmlns:r="http://schemas.openxmlformats.org/officeDocument/2006/relationships">
         <p:nvSpPr>
@@ -7820,6 +7870,10 @@
             <a:prstDash val="solid"/>
           </a:ln>
         </p:spPr>
+        <p:txBody>
+          <a:bodyPr/>
+          <a:p/>
+        </p:txBody>
       </p:sp>
       <p:sp xmlns:p="http://schemas.openxmlformats.org/presentationml/2006/main" xmlns:a="http://schemas.openxmlformats.org/drawingml/2006/main" xmlns:r="http://schemas.openxmlformats.org/officeDocument/2006/relationships">
         <p:nvSpPr>
@@ -7903,6 +7957,10 @@
           </a:solidFill>
           <a:ln/>
         </p:spPr>
+        <p:txBody>
+          <a:bodyPr/>
+          <a:p/>
+        </p:txBody>
       </p:sp>
       <p:sp xmlns:p="http://schemas.openxmlformats.org/presentationml/2006/main" xmlns:a="http://schemas.openxmlformats.org/drawingml/2006/main" xmlns:r="http://schemas.openxmlformats.org/officeDocument/2006/relationships">
         <p:nvSpPr>
@@ -7926,6 +7984,10 @@
             <a:prstDash val="solid"/>
           </a:ln>
         </p:spPr>
+        <p:txBody>
+          <a:bodyPr/>
+          <a:p/>
+        </p:txBody>
       </p:sp>
       <p:sp xmlns:p="http://schemas.openxmlformats.org/presentationml/2006/main" xmlns:a="http://schemas.openxmlformats.org/drawingml/2006/main" xmlns:r="http://schemas.openxmlformats.org/officeDocument/2006/relationships">
         <p:nvSpPr>
@@ -8009,6 +8071,10 @@
           </a:solidFill>
           <a:ln/>
         </p:spPr>
+        <p:txBody>
+          <a:bodyPr/>
+          <a:p/>
+        </p:txBody>
       </p:sp>
       <p:sp xmlns:p="http://schemas.openxmlformats.org/presentationml/2006/main" xmlns:a="http://schemas.openxmlformats.org/drawingml/2006/main" xmlns:r="http://schemas.openxmlformats.org/officeDocument/2006/relationships">
         <p:nvSpPr>
@@ -8032,6 +8098,10 @@
             <a:prstDash val="solid"/>
           </a:ln>
         </p:spPr>
+        <p:txBody>
+          <a:bodyPr/>
+          <a:p/>
+        </p:txBody>
       </p:sp>
       <p:sp xmlns:p="http://schemas.openxmlformats.org/presentationml/2006/main" xmlns:a="http://schemas.openxmlformats.org/drawingml/2006/main" xmlns:r="http://schemas.openxmlformats.org/officeDocument/2006/relationships">
         <p:nvSpPr>
@@ -8093,6 +8163,10 @@
           </a:solidFill>
           <a:ln/>
         </p:spPr>
+        <p:txBody>
+          <a:bodyPr/>
+          <a:p/>
+        </p:txBody>
       </p:sp>
       <p:sp xmlns:p="http://schemas.openxmlformats.org/presentationml/2006/main" xmlns:a="http://schemas.openxmlformats.org/drawingml/2006/main" xmlns:r="http://schemas.openxmlformats.org/officeDocument/2006/relationships">
         <p:nvSpPr>
@@ -8113,6 +8187,10 @@
           </a:solidFill>
           <a:ln/>
         </p:spPr>
+        <p:txBody>
+          <a:bodyPr/>
+          <a:p/>
+        </p:txBody>
       </p:sp>
       <p:sp xmlns:p="http://schemas.openxmlformats.org/presentationml/2006/main" xmlns:a="http://schemas.openxmlformats.org/drawingml/2006/main" xmlns:r="http://schemas.openxmlformats.org/officeDocument/2006/relationships">
         <p:nvSpPr>
@@ -8319,6 +8397,10 @@
           </a:solidFill>
           <a:ln/>
         </p:spPr>
+        <p:txBody>
+          <a:bodyPr/>
+          <a:p/>
+        </p:txBody>
       </p:sp>
       <p:sp xmlns:p="http://schemas.openxmlformats.org/presentationml/2006/main" xmlns:a="http://schemas.openxmlformats.org/drawingml/2006/main" xmlns:r="http://schemas.openxmlformats.org/officeDocument/2006/relationships">
         <p:nvSpPr>
@@ -8437,7 +8519,7 @@
                 <a:ea typeface="+mn-ea"/>
                 <a:cs typeface="+mn-cs"/>
               </a:rPr>
-              <a:t>Report what you observed and paste the output.</a:t>
+              <a:t>Comment @codex on the PR with what you saw.</a:t>
             </a:r>
             <a:endParaRPr lang="en-US" sz="1875" dirty="0"/>
           </a:p>
@@ -8464,6 +8546,10 @@
           </a:solidFill>
           <a:ln/>
         </p:spPr>
+        <p:txBody>
+          <a:bodyPr/>
+          <a:p/>
+        </p:txBody>
       </p:sp>
       <p:sp xmlns:p="http://schemas.openxmlformats.org/presentationml/2006/main" xmlns:a="http://schemas.openxmlformats.org/drawingml/2006/main" xmlns:r="http://schemas.openxmlformats.org/officeDocument/2006/relationships">
         <p:nvSpPr>
@@ -8544,7 +8630,7 @@
                 <a:ea typeface="+mn-ea"/>
                 <a:cs typeface="+mn-cs"/>
               </a:rPr>
-              <a:t>testUDLHandCalc fails: expected 2.4000e-03, got 2.4000e-06. Output below. Find the cause and explain it before changing code.</a:t>
+              <a:t>@codex testUDLHandCalc fails: expected 2.4000e-03, got 2.4000e-06. Output below. Find the cause and explain it before changing code.</a:t>
             </a:r>
             <a:endParaRPr lang="en-US" sz="1725" dirty="0"/>
           </a:p>
@@ -8605,7 +8691,7 @@
                 <a:ea typeface="+mn-ea"/>
                 <a:cs typeface="+mn-cs"/>
               </a:rPr>
-              <a:t>The agent pushes a new commit to the same branch. Fetch, rerun, retest.</a:t>
+              <a:t>Codex pushes a fix to the PR’s branch. Fetch, rerun, retest.</a:t>
             </a:r>
             <a:endParaRPr lang="en-US" sz="1875" dirty="0"/>
           </a:p>
@@ -8932,7 +9018,7 @@
                 <a:ea typeface="+mn-ea"/>
                 <a:cs typeface="+mn-cs"/>
               </a:rPr>
-              <a:t>Start a new session for the next requirement.</a:t>
+              <a:t>Start a new task for the next requirement.</a:t>
             </a:r>
             <a:endParaRPr lang="en-US" sz="1875" dirty="0"/>
           </a:p>
@@ -9020,7 +9106,7 @@
                 <a:ea typeface="+mn-ea"/>
                 <a:cs typeface="+mn-cs"/>
               </a:rPr>
-              <a:t>Add a rule to CLAUDE.md for any mistake the agent made twice.</a:t>
+              <a:t>Add a rule to AGENTS.md for any mistake the agent made twice.</a:t>
             </a:r>
             <a:endParaRPr lang="en-US" sz="1875" dirty="0"/>
           </a:p>
@@ -10691,7 +10777,7 @@
                 <a:ea typeface="+mn-ea"/>
                 <a:cs typeface="+mn-cs"/>
               </a:rPr>
-              <a:t xml:space="preserve"> in the repo, with one entry per session:</a:t>
+              <a:t xml:space="preserve"> in the repo, with one entry per task:</a:t>
             </a:r>
             <a:endParaRPr lang="en-US" sz="2025" dirty="0"/>
           </a:p>
@@ -10718,6 +10804,10 @@
           </a:solidFill>
           <a:ln/>
         </p:spPr>
+        <p:txBody>
+          <a:bodyPr/>
+          <a:p/>
+        </p:txBody>
       </p:sp>
       <p:sp xmlns:p="http://schemas.openxmlformats.org/presentationml/2006/main" xmlns:a="http://schemas.openxmlformats.org/drawingml/2006/main" xmlns:r="http://schemas.openxmlformats.org/officeDocument/2006/relationships">
         <p:nvSpPr>
@@ -10777,7 +10867,7 @@
                 <a:ea typeface="Consolas" pitchFamily="34" charset="-122"/>
                 <a:cs typeface="Consolas" pitchFamily="34" charset="-120"/>
               </a:rPr>
-              <a:t>Session:      claude.ai/code link</a:t>
+              <a:t>Task:         chatgpt.com/codex link</a:t>
             </a:r>
             <a:endParaRPr lang="en-US" sz="1725" dirty="0"/>
           </a:p>
@@ -11088,6 +11178,10 @@
           </a:solidFill>
           <a:ln/>
         </p:spPr>
+        <p:txBody>
+          <a:bodyPr/>
+          <a:p/>
+        </p:txBody>
       </p:sp>
       <p:sp xmlns:p="http://schemas.openxmlformats.org/presentationml/2006/main" xmlns:a="http://schemas.openxmlformats.org/drawingml/2006/main" xmlns:r="http://schemas.openxmlformats.org/officeDocument/2006/relationships">
         <p:nvSpPr>
@@ -11322,7 +11416,7 @@
                 <a:ea typeface="+mn-ea"/>
                 <a:cs typeface="+mn-cs"/>
               </a:rPr>
-              <a:t>, before opening a session.</a:t>
+              <a:t>, before starting a task.</a:t>
             </a:r>
             <a:endParaRPr lang="en-US" sz="1950" dirty="0"/>
           </a:p>
@@ -11410,7 +11504,7 @@
                 <a:ea typeface="+mn-ea"/>
                 <a:cs typeface="+mn-cs"/>
               </a:rPr>
-              <a:t xml:space="preserve">Add CLAUDE.md, or run </a:t>
+              <a:t xml:space="preserve">Improve </a:t>
             </a:r>
             <a:r>
               <a:rPr lang="en-US" sz="1950" b="1" dirty="0">
@@ -11421,7 +11515,7 @@
                 <a:ea typeface="+mn-ea"/>
                 <a:cs typeface="+mn-cs"/>
               </a:rPr>
-              <a:t>/init</a:t>
+              <a:t>AGENTS.md</a:t>
             </a:r>
             <a:r>
               <a:rPr lang="en-US" sz="1950" dirty="0">
@@ -11432,7 +11526,7 @@
                 <a:ea typeface="+mn-ea"/>
                 <a:cs typeface="+mn-cs"/>
               </a:rPr>
-              <a:t xml:space="preserve"> and correct it.</a:t>
+              <a:t xml:space="preserve">, or have Codex draft one.</a:t>
             </a:r>
             <a:endParaRPr lang="en-US" sz="1950" dirty="0"/>
           </a:p>
@@ -11721,6 +11815,10 @@
           </a:solidFill>
           <a:ln/>
         </p:spPr>
+        <p:txBody>
+          <a:bodyPr/>
+          <a:p/>
+        </p:txBody>
       </p:sp>
       <p:sp xmlns:p="http://schemas.openxmlformats.org/presentationml/2006/main" xmlns:a="http://schemas.openxmlformats.org/drawingml/2006/main" xmlns:r="http://schemas.openxmlformats.org/officeDocument/2006/relationships">
         <p:nvSpPr>
@@ -11886,6 +11984,10 @@
           </a:solidFill>
           <a:ln/>
         </p:spPr>
+        <p:txBody>
+          <a:bodyPr/>
+          <a:p/>
+        </p:txBody>
       </p:sp>
       <p:sp xmlns:p="http://schemas.openxmlformats.org/presentationml/2006/main" xmlns:a="http://schemas.openxmlformats.org/drawingml/2006/main" xmlns:r="http://schemas.openxmlformats.org/officeDocument/2006/relationships">
         <p:nvSpPr>
@@ -12170,7 +12272,7 @@
                 <a:ea typeface="+mn-ea"/>
                 <a:cs typeface="+mn-cs"/>
               </a:rPr>
-              <a:t>An agent session belongs to one account; teammates can’t join it. The GitHub repo is the team’s shared workspace.</a:t>
+              <a:t>A Codex task belongs to one ChatGPT account; teammates can’t join it. The GitHub repo is the team’s shared workspace.</a:t>
             </a:r>
             <a:endParaRPr lang="en-US" sz="2025" dirty="0"/>
           </a:p>
@@ -12195,6 +12297,10 @@
           </a:solidFill>
           <a:ln/>
         </p:spPr>
+        <p:txBody>
+          <a:bodyPr/>
+          <a:p/>
+        </p:txBody>
       </p:sp>
       <p:sp xmlns:p="http://schemas.openxmlformats.org/presentationml/2006/main" xmlns:a="http://schemas.openxmlformats.org/drawingml/2006/main" xmlns:r="http://schemas.openxmlformats.org/officeDocument/2006/relationships">
         <p:nvSpPr>
@@ -12316,7 +12422,7 @@
                 <a:ea typeface="+mn-ea"/>
                 <a:cs typeface="+mn-cs"/>
               </a:rPr>
-              <a:t>One cadet with agent access runs the sessions.</a:t>
+              <a:t>One cadet with agent access runs the tasks.</a:t>
             </a:r>
             <a:endParaRPr lang="en-US" sz="1800" dirty="0"/>
           </a:p>
@@ -12381,6 +12487,10 @@
           </a:solidFill>
           <a:ln/>
         </p:spPr>
+        <p:txBody>
+          <a:bodyPr/>
+          <a:p/>
+        </p:txBody>
       </p:sp>
       <p:sp xmlns:p="http://schemas.openxmlformats.org/presentationml/2006/main" xmlns:a="http://schemas.openxmlformats.org/drawingml/2006/main" xmlns:r="http://schemas.openxmlformats.org/officeDocument/2006/relationships">
         <p:nvSpPr>
@@ -12502,7 +12612,7 @@
                 <a:ea typeface="+mn-ea"/>
                 <a:cs typeface="+mn-cs"/>
               </a:rPr>
-              <a:t>Each cadet runs sessions on their own requirement and branch.</a:t>
+              <a:t>Each cadet runs tasks on their own requirement and branch.</a:t>
             </a:r>
             <a:endParaRPr lang="en-US" sz="1800" dirty="0"/>
           </a:p>
@@ -12542,7 +12652,7 @@
                 <a:ea typeface="+mn-ea"/>
                 <a:cs typeface="+mn-cs"/>
               </a:rPr>
-              <a:t>Don’t let two sessions edit the same function.</a:t>
+              <a:t>Don’t let two tasks edit the same function.</a:t>
             </a:r>
             <a:endParaRPr lang="en-US" sz="1800" dirty="0"/>
           </a:p>
@@ -12567,6 +12677,10 @@
           </a:solidFill>
           <a:ln/>
         </p:spPr>
+        <p:txBody>
+          <a:bodyPr/>
+          <a:p/>
+        </p:txBody>
       </p:sp>
       <p:sp xmlns:p="http://schemas.openxmlformats.org/presentationml/2006/main" xmlns:a="http://schemas.openxmlformats.org/drawingml/2006/main" xmlns:r="http://schemas.openxmlformats.org/officeDocument/2006/relationships">
         <p:nvSpPr>
@@ -12997,7 +13111,7 @@
                 <a:ea typeface="+mn-ea"/>
                 <a:cs typeface="+mn-cs"/>
               </a:rPr>
-              <a:t>Give an agent your project’s context with CLAUDE.md (and AGENTS.md)</a:t>
+              <a:t>Give an agent your project’s context with AGENTS.md</a:t>
             </a:r>
             <a:endParaRPr lang="en-US" sz="2100" dirty="0"/>
           </a:p>
@@ -13327,6 +13441,10 @@
           </a:solidFill>
           <a:ln/>
         </p:spPr>
+        <p:txBody>
+          <a:bodyPr/>
+          <a:p/>
+        </p:txBody>
       </p:sp>
       <p:sp xmlns:p="http://schemas.openxmlformats.org/presentationml/2006/main" xmlns:a="http://schemas.openxmlformats.org/drawingml/2006/main" xmlns:r="http://schemas.openxmlformats.org/officeDocument/2006/relationships">
         <p:nvSpPr>
@@ -13429,6 +13547,10 @@
           </a:solidFill>
           <a:ln/>
         </p:spPr>
+        <p:txBody>
+          <a:bodyPr/>
+          <a:p/>
+        </p:txBody>
       </p:sp>
       <p:sp xmlns:p="http://schemas.openxmlformats.org/presentationml/2006/main" xmlns:a="http://schemas.openxmlformats.org/drawingml/2006/main" xmlns:r="http://schemas.openxmlformats.org/officeDocument/2006/relationships">
         <p:nvSpPr>
@@ -13506,7 +13628,7 @@
                 <a:ea typeface="+mn-ea"/>
                 <a:cs typeface="+mn-cs"/>
               </a:rPr>
-              <a:t>Guided exercises in Claude Code</a:t>
+              <a:t>Guided exercises in Codex</a:t>
             </a:r>
             <a:endParaRPr lang="en-US" sz="1800" dirty="0"/>
           </a:p>
@@ -13531,6 +13653,10 @@
           </a:solidFill>
           <a:ln/>
         </p:spPr>
+        <p:txBody>
+          <a:bodyPr/>
+          <a:p/>
+        </p:txBody>
       </p:sp>
       <p:sp xmlns:p="http://schemas.openxmlformats.org/presentationml/2006/main" xmlns:a="http://schemas.openxmlformats.org/drawingml/2006/main" xmlns:r="http://schemas.openxmlformats.org/officeDocument/2006/relationships">
         <p:nvSpPr>
@@ -13776,6 +13902,10 @@
           </a:solidFill>
           <a:ln/>
         </p:spPr>
+        <p:txBody>
+          <a:bodyPr/>
+          <a:p/>
+        </p:txBody>
       </p:sp>
       <p:sp xmlns:p="http://schemas.openxmlformats.org/presentationml/2006/main" xmlns:a="http://schemas.openxmlformats.org/drawingml/2006/main" xmlns:r="http://schemas.openxmlformats.org/officeDocument/2006/relationships">
         <p:nvSpPr>
@@ -13837,6 +13967,10 @@
           </a:solidFill>
           <a:ln/>
         </p:spPr>
+        <p:txBody>
+          <a:bodyPr/>
+          <a:p/>
+        </p:txBody>
       </p:sp>
       <p:sp xmlns:p="http://schemas.openxmlformats.org/presentationml/2006/main" xmlns:a="http://schemas.openxmlformats.org/drawingml/2006/main" xmlns:r="http://schemas.openxmlformats.org/officeDocument/2006/relationships">
         <p:nvSpPr>
@@ -13914,7 +14048,7 @@
                 <a:ea typeface="+mn-ea"/>
                 <a:cs typeface="+mn-cs"/>
               </a:rPr>
-              <a:t>Repo missing from the session list</a:t>
+              <a:t>Repo missing in Codex</a:t>
             </a:r>
             <a:endParaRPr lang="en-US" sz="1800" dirty="0"/>
           </a:p>
@@ -13939,6 +14073,10 @@
           </a:solidFill>
           <a:ln/>
         </p:spPr>
+        <p:txBody>
+          <a:bodyPr/>
+          <a:p/>
+        </p:txBody>
       </p:sp>
       <p:sp xmlns:p="http://schemas.openxmlformats.org/presentationml/2006/main" xmlns:a="http://schemas.openxmlformats.org/drawingml/2006/main" xmlns:r="http://schemas.openxmlformats.org/officeDocument/2006/relationships">
         <p:nvSpPr>
@@ -13975,7 +14113,7 @@
                 <a:ea typeface="+mn-ea"/>
                 <a:cs typeface="+mn-cs"/>
               </a:rPr>
-              <a:t>Grant the Claude GitHub App access to that repo (GitHub › Settings › Applications).</a:t>
+              <a:t>Give ChatGPT’s GitHub app access to that repo (GitHub › Settings › Applications).</a:t>
             </a:r>
             <a:endParaRPr lang="en-US" sz="1800" dirty="0"/>
           </a:p>
@@ -14000,6 +14138,10 @@
           </a:solidFill>
           <a:ln/>
         </p:spPr>
+        <p:txBody>
+          <a:bodyPr/>
+          <a:p/>
+        </p:txBody>
       </p:sp>
       <p:sp xmlns:p="http://schemas.openxmlformats.org/presentationml/2006/main" xmlns:a="http://schemas.openxmlformats.org/drawingml/2006/main" xmlns:r="http://schemas.openxmlformats.org/officeDocument/2006/relationships">
         <p:nvSpPr>
@@ -14061,6 +14203,10 @@
           </a:solidFill>
           <a:ln/>
         </p:spPr>
+        <p:txBody>
+          <a:bodyPr/>
+          <a:p/>
+        </p:txBody>
       </p:sp>
       <p:sp xmlns:p="http://schemas.openxmlformats.org/presentationml/2006/main" xmlns:a="http://schemas.openxmlformats.org/drawingml/2006/main" xmlns:r="http://schemas.openxmlformats.org/officeDocument/2006/relationships">
         <p:nvSpPr>
@@ -14097,7 +14243,7 @@
                 <a:ea typeface="+mn-ea"/>
                 <a:cs typeface="+mn-cs"/>
               </a:rPr>
-              <a:t>Check CLAUDE.md is at the repo root on the branch the session uses. Shorten it.</a:t>
+              <a:t>Check AGENTS.md is at the repo root on the branch the task uses. Shorten it.</a:t>
             </a:r>
             <a:endParaRPr lang="en-US" sz="1800" dirty="0"/>
           </a:p>
@@ -14122,6 +14268,10 @@
           </a:solidFill>
           <a:ln/>
         </p:spPr>
+        <p:txBody>
+          <a:bodyPr/>
+          <a:p/>
+        </p:txBody>
       </p:sp>
       <p:sp xmlns:p="http://schemas.openxmlformats.org/presentationml/2006/main" xmlns:a="http://schemas.openxmlformats.org/drawingml/2006/main" xmlns:r="http://schemas.openxmlformats.org/officeDocument/2006/relationships">
         <p:nvSpPr>
@@ -14183,6 +14333,10 @@
           </a:solidFill>
           <a:ln/>
         </p:spPr>
+        <p:txBody>
+          <a:bodyPr/>
+          <a:p/>
+        </p:txBody>
       </p:sp>
       <p:sp xmlns:p="http://schemas.openxmlformats.org/presentationml/2006/main" xmlns:a="http://schemas.openxmlformats.org/drawingml/2006/main" xmlns:r="http://schemas.openxmlformats.org/officeDocument/2006/relationships">
         <p:nvSpPr>
@@ -14219,7 +14373,7 @@
                 <a:ea typeface="+mn-ea"/>
                 <a:cs typeface="+mn-cs"/>
               </a:rPr>
-              <a:t>Fetch origin first, then open the Current branch menu.</a:t>
+              <a:t>Create the pull request first, then Fetch origin.</a:t>
             </a:r>
             <a:endParaRPr lang="en-US" sz="1800" dirty="0"/>
           </a:p>
@@ -14244,6 +14398,10 @@
           </a:solidFill>
           <a:ln/>
         </p:spPr>
+        <p:txBody>
+          <a:bodyPr/>
+          <a:p/>
+        </p:txBody>
       </p:sp>
       <p:sp xmlns:p="http://schemas.openxmlformats.org/presentationml/2006/main" xmlns:a="http://schemas.openxmlformats.org/drawingml/2006/main" xmlns:r="http://schemas.openxmlformats.org/officeDocument/2006/relationships">
         <p:nvSpPr>
@@ -14305,6 +14463,10 @@
           </a:solidFill>
           <a:ln/>
         </p:spPr>
+        <p:txBody>
+          <a:bodyPr/>
+          <a:p/>
+        </p:txBody>
       </p:sp>
       <p:sp xmlns:p="http://schemas.openxmlformats.org/presentationml/2006/main" xmlns:a="http://schemas.openxmlformats.org/drawingml/2006/main" xmlns:r="http://schemas.openxmlformats.org/officeDocument/2006/relationships">
         <p:nvSpPr>
@@ -14366,6 +14528,10 @@
           </a:solidFill>
           <a:ln/>
         </p:spPr>
+        <p:txBody>
+          <a:bodyPr/>
+          <a:p/>
+        </p:txBody>
       </p:sp>
       <p:sp xmlns:p="http://schemas.openxmlformats.org/presentationml/2006/main" xmlns:a="http://schemas.openxmlformats.org/drawingml/2006/main" xmlns:r="http://schemas.openxmlformats.org/officeDocument/2006/relationships">
         <p:nvSpPr>
@@ -14427,6 +14593,10 @@
           </a:solidFill>
           <a:ln/>
         </p:spPr>
+        <p:txBody>
+          <a:bodyPr/>
+          <a:p/>
+        </p:txBody>
       </p:sp>
       <p:sp xmlns:p="http://schemas.openxmlformats.org/presentationml/2006/main" xmlns:a="http://schemas.openxmlformats.org/drawingml/2006/main" xmlns:r="http://schemas.openxmlformats.org/officeDocument/2006/relationships">
         <p:nvSpPr>
@@ -14488,6 +14658,10 @@
           </a:solidFill>
           <a:ln/>
         </p:spPr>
+        <p:txBody>
+          <a:bodyPr/>
+          <a:p/>
+        </p:txBody>
       </p:sp>
       <p:sp xmlns:p="http://schemas.openxmlformats.org/presentationml/2006/main" xmlns:a="http://schemas.openxmlformats.org/drawingml/2006/main" xmlns:r="http://schemas.openxmlformats.org/officeDocument/2006/relationships">
         <p:nvSpPr>
@@ -14524,7 +14698,7 @@
                 <a:ea typeface="+mn-ea"/>
                 <a:cs typeface="+mn-cs"/>
               </a:rPr>
-              <a:t>Answers drift in a long session</a:t>
+              <a:t>Answers drift in a long task</a:t>
             </a:r>
             <a:endParaRPr lang="en-US" sz="1800" dirty="0"/>
           </a:p>
@@ -14549,6 +14723,10 @@
           </a:solidFill>
           <a:ln/>
         </p:spPr>
+        <p:txBody>
+          <a:bodyPr/>
+          <a:p/>
+        </p:txBody>
       </p:sp>
       <p:sp xmlns:p="http://schemas.openxmlformats.org/presentationml/2006/main" xmlns:a="http://schemas.openxmlformats.org/drawingml/2006/main" xmlns:r="http://schemas.openxmlformats.org/officeDocument/2006/relationships">
         <p:nvSpPr>
@@ -14585,7 +14763,7 @@
                 <a:ea typeface="+mn-ea"/>
                 <a:cs typeface="+mn-cs"/>
               </a:rPr>
-              <a:t>Merge what works, then start a new session per requirement.</a:t>
+              <a:t>Merge what works, then start a new task per requirement.</a:t>
             </a:r>
             <a:endParaRPr lang="en-US" sz="1800" dirty="0"/>
           </a:p>
@@ -14610,6 +14788,10 @@
           </a:solidFill>
           <a:ln/>
         </p:spPr>
+        <p:txBody>
+          <a:bodyPr/>
+          <a:p/>
+        </p:txBody>
       </p:sp>
       <p:sp xmlns:p="http://schemas.openxmlformats.org/presentationml/2006/main" xmlns:a="http://schemas.openxmlformats.org/drawingml/2006/main" xmlns:r="http://schemas.openxmlformats.org/officeDocument/2006/relationships">
         <p:nvSpPr>
@@ -14773,6 +14955,10 @@
           </a:solidFill>
           <a:ln/>
         </p:spPr>
+        <p:txBody>
+          <a:bodyPr/>
+          <a:p/>
+        </p:txBody>
       </p:sp>
       <p:sp xmlns:p="http://schemas.openxmlformats.org/presentationml/2006/main" xmlns:a="http://schemas.openxmlformats.org/drawingml/2006/main" xmlns:r="http://schemas.openxmlformats.org/officeDocument/2006/relationships">
         <p:nvSpPr>
@@ -14834,6 +15020,10 @@
           </a:solidFill>
           <a:ln/>
         </p:spPr>
+        <p:txBody>
+          <a:bodyPr/>
+          <a:p/>
+        </p:txBody>
       </p:sp>
       <p:sp xmlns:p="http://schemas.openxmlformats.org/presentationml/2006/main" xmlns:a="http://schemas.openxmlformats.org/drawingml/2006/main" xmlns:r="http://schemas.openxmlformats.org/officeDocument/2006/relationships">
         <p:nvSpPr>
@@ -14936,6 +15126,10 @@
           </a:solidFill>
           <a:ln/>
         </p:spPr>
+        <p:txBody>
+          <a:bodyPr/>
+          <a:p/>
+        </p:txBody>
       </p:sp>
       <p:sp xmlns:p="http://schemas.openxmlformats.org/presentationml/2006/main" xmlns:a="http://schemas.openxmlformats.org/drawingml/2006/main" xmlns:r="http://schemas.openxmlformats.org/officeDocument/2006/relationships">
         <p:nvSpPr>
@@ -14972,7 +15166,7 @@
                 <a:ea typeface="+mn-ea"/>
                 <a:cs typeface="+mn-cs"/>
               </a:rPr>
-              <a:t>“Read CLAUDE.md and … Summarize … Don’t change any files.”</a:t>
+              <a:t>“Read AGENTS.md and … Summarize … Don’t change any files.”</a:t>
             </a:r>
             <a:endParaRPr lang="en-US" sz="1800" dirty="0"/>
           </a:p>
@@ -14997,6 +15191,10 @@
           </a:solidFill>
           <a:ln/>
         </p:spPr>
+        <p:txBody>
+          <a:bodyPr/>
+          <a:p/>
+        </p:txBody>
       </p:sp>
       <p:sp xmlns:p="http://schemas.openxmlformats.org/presentationml/2006/main" xmlns:a="http://schemas.openxmlformats.org/drawingml/2006/main" xmlns:r="http://schemas.openxmlformats.org/officeDocument/2006/relationships">
         <p:nvSpPr>
@@ -15058,6 +15256,10 @@
           </a:solidFill>
           <a:ln/>
         </p:spPr>
+        <p:txBody>
+          <a:bodyPr/>
+          <a:p/>
+        </p:txBody>
       </p:sp>
       <p:sp xmlns:p="http://schemas.openxmlformats.org/presentationml/2006/main" xmlns:a="http://schemas.openxmlformats.org/drawingml/2006/main" xmlns:r="http://schemas.openxmlformats.org/officeDocument/2006/relationships">
         <p:nvSpPr>
@@ -15119,6 +15321,10 @@
           </a:solidFill>
           <a:ln/>
         </p:spPr>
+        <p:txBody>
+          <a:bodyPr/>
+          <a:p/>
+        </p:txBody>
       </p:sp>
       <p:sp xmlns:p="http://schemas.openxmlformats.org/presentationml/2006/main" xmlns:a="http://schemas.openxmlformats.org/drawingml/2006/main" xmlns:r="http://schemas.openxmlformats.org/officeDocument/2006/relationships">
         <p:nvSpPr>
@@ -15180,6 +15386,10 @@
           </a:solidFill>
           <a:ln/>
         </p:spPr>
+        <p:txBody>
+          <a:bodyPr/>
+          <a:p/>
+        </p:txBody>
       </p:sp>
       <p:sp xmlns:p="http://schemas.openxmlformats.org/presentationml/2006/main" xmlns:a="http://schemas.openxmlformats.org/drawingml/2006/main" xmlns:r="http://schemas.openxmlformats.org/officeDocument/2006/relationships">
         <p:nvSpPr>
@@ -15241,6 +15451,10 @@
           </a:solidFill>
           <a:ln/>
         </p:spPr>
+        <p:txBody>
+          <a:bodyPr/>
+          <a:p/>
+        </p:txBody>
       </p:sp>
       <p:sp xmlns:p="http://schemas.openxmlformats.org/presentationml/2006/main" xmlns:a="http://schemas.openxmlformats.org/drawingml/2006/main" xmlns:r="http://schemas.openxmlformats.org/officeDocument/2006/relationships">
         <p:nvSpPr>
@@ -15277,7 +15491,7 @@
                 <a:ea typeface="+mn-ea"/>
                 <a:cs typeface="+mn-cs"/>
               </a:rPr>
-              <a:t>Report a failure</a:t>
+              <a:t>Report a failure (PR comment)</a:t>
             </a:r>
             <a:endParaRPr lang="en-US" sz="1800" dirty="0"/>
           </a:p>
@@ -15302,6 +15516,10 @@
           </a:solidFill>
           <a:ln/>
         </p:spPr>
+        <p:txBody>
+          <a:bodyPr/>
+          <a:p/>
+        </p:txBody>
       </p:sp>
       <p:sp xmlns:p="http://schemas.openxmlformats.org/presentationml/2006/main" xmlns:a="http://schemas.openxmlformats.org/drawingml/2006/main" xmlns:r="http://schemas.openxmlformats.org/officeDocument/2006/relationships">
         <p:nvSpPr>
@@ -15338,7 +15556,7 @@
                 <a:ea typeface="+mn-ea"/>
                 <a:cs typeface="+mn-cs"/>
               </a:rPr>
-              <a:t>“Observed …; expected …. Output below. Find the cause and explain it before changing code.”</a:t>
+              <a:t>“@codex Observed …; expected …. Output below. Find the cause and explain it before changing code.”</a:t>
             </a:r>
             <a:endParaRPr lang="en-US" sz="1800" dirty="0"/>
           </a:p>
@@ -15363,6 +15581,10 @@
           </a:solidFill>
           <a:ln/>
         </p:spPr>
+        <p:txBody>
+          <a:bodyPr/>
+          <a:p/>
+        </p:txBody>
       </p:sp>
       <p:sp xmlns:p="http://schemas.openxmlformats.org/presentationml/2006/main" xmlns:a="http://schemas.openxmlformats.org/drawingml/2006/main" xmlns:r="http://schemas.openxmlformats.org/officeDocument/2006/relationships">
         <p:nvSpPr>
@@ -15399,7 +15621,7 @@
                 <a:ea typeface="+mn-ea"/>
                 <a:cs typeface="+mn-cs"/>
               </a:rPr>
-              <a:t>Draft CLAUDE.md</a:t>
+              <a:t>Draft AGENTS.md</a:t>
             </a:r>
             <a:endParaRPr lang="en-US" sz="1800" dirty="0"/>
           </a:p>
@@ -15424,6 +15646,10 @@
           </a:solidFill>
           <a:ln/>
         </p:spPr>
+        <p:txBody>
+          <a:bodyPr/>
+          <a:p/>
+        </p:txBody>
       </p:sp>
       <p:sp xmlns:p="http://schemas.openxmlformats.org/presentationml/2006/main" xmlns:a="http://schemas.openxmlformats.org/drawingml/2006/main" xmlns:r="http://schemas.openxmlformats.org/officeDocument/2006/relationships">
         <p:nvSpPr>
@@ -15460,7 +15686,7 @@
                 <a:ea typeface="+mn-ea"/>
                 <a:cs typeface="+mn-cs"/>
               </a:rPr>
-              <a:t>/init in a session, then correct it</a:t>
+              <a:t>Ask Codex to draft one, then correct it</a:t>
             </a:r>
             <a:endParaRPr lang="en-US" sz="1800" dirty="0"/>
           </a:p>
@@ -15485,6 +15711,10 @@
           </a:solidFill>
           <a:ln/>
         </p:spPr>
+        <p:txBody>
+          <a:bodyPr/>
+          <a:p/>
+        </p:txBody>
       </p:sp>
       <p:sp xmlns:p="http://schemas.openxmlformats.org/presentationml/2006/main" xmlns:a="http://schemas.openxmlformats.org/drawingml/2006/main" xmlns:r="http://schemas.openxmlformats.org/officeDocument/2006/relationships">
         <p:nvSpPr>
@@ -15546,6 +15776,10 @@
           </a:solidFill>
           <a:ln/>
         </p:spPr>
+        <p:txBody>
+          <a:bodyPr/>
+          <a:p/>
+        </p:txBody>
       </p:sp>
       <p:sp xmlns:p="http://schemas.openxmlformats.org/presentationml/2006/main" xmlns:a="http://schemas.openxmlformats.org/drawingml/2006/main" xmlns:r="http://schemas.openxmlformats.org/officeDocument/2006/relationships">
         <p:nvSpPr>
@@ -15582,7 +15816,7 @@
                 <a:ea typeface="+mn-ea"/>
                 <a:cs typeface="+mn-cs"/>
               </a:rPr>
-              <a:t>Create PR in the session</a:t>
+              <a:t>Create the pull request from the task</a:t>
             </a:r>
             <a:endParaRPr lang="en-US" sz="1800" dirty="0"/>
           </a:p>
@@ -15607,6 +15841,10 @@
           </a:solidFill>
           <a:ln/>
         </p:spPr>
+        <p:txBody>
+          <a:bodyPr/>
+          <a:p/>
+        </p:txBody>
       </p:sp>
       <p:sp xmlns:p="http://schemas.openxmlformats.org/presentationml/2006/main" xmlns:a="http://schemas.openxmlformats.org/drawingml/2006/main" xmlns:r="http://schemas.openxmlformats.org/officeDocument/2006/relationships">
         <p:nvSpPr>
@@ -15668,6 +15906,10 @@
           </a:solidFill>
           <a:ln/>
         </p:spPr>
+        <p:txBody>
+          <a:bodyPr/>
+          <a:p/>
+        </p:txBody>
       </p:sp>
       <p:sp xmlns:p="http://schemas.openxmlformats.org/presentationml/2006/main" xmlns:a="http://schemas.openxmlformats.org/drawingml/2006/main" xmlns:r="http://schemas.openxmlformats.org/officeDocument/2006/relationships">
         <p:nvSpPr>
@@ -15704,7 +15946,7 @@
                 <a:ea typeface="+mn-ea"/>
                 <a:cs typeface="+mn-cs"/>
               </a:rPr>
-              <a:t>Fetch origin › Current branch › claude/…</a:t>
+              <a:t>Fetch origin › Current branch › codex/…</a:t>
             </a:r>
             <a:endParaRPr lang="en-US" sz="1800" dirty="0"/>
           </a:p>
@@ -15729,6 +15971,10 @@
           </a:solidFill>
           <a:ln/>
         </p:spPr>
+        <p:txBody>
+          <a:bodyPr/>
+          <a:p/>
+        </p:txBody>
       </p:sp>
       <p:sp xmlns:p="http://schemas.openxmlformats.org/presentationml/2006/main" xmlns:a="http://schemas.openxmlformats.org/drawingml/2006/main" xmlns:r="http://schemas.openxmlformats.org/officeDocument/2006/relationships">
         <p:nvSpPr>
@@ -15790,6 +16036,10 @@
           </a:solidFill>
           <a:ln/>
         </p:spPr>
+        <p:txBody>
+          <a:bodyPr/>
+          <a:p/>
+        </p:txBody>
       </p:sp>
       <p:sp xmlns:p="http://schemas.openxmlformats.org/presentationml/2006/main" xmlns:a="http://schemas.openxmlformats.org/drawingml/2006/main" xmlns:r="http://schemas.openxmlformats.org/officeDocument/2006/relationships">
         <p:nvSpPr>
@@ -15851,6 +16101,10 @@
           </a:solidFill>
           <a:ln/>
         </p:spPr>
+        <p:txBody>
+          <a:bodyPr/>
+          <a:p/>
+        </p:txBody>
       </p:sp>
       <p:sp xmlns:p="http://schemas.openxmlformats.org/presentationml/2006/main" xmlns:a="http://schemas.openxmlformats.org/drawingml/2006/main" xmlns:r="http://schemas.openxmlformats.org/officeDocument/2006/relationships">
         <p:nvSpPr>
@@ -16153,7 +16407,7 @@
                 <a:ea typeface="+mn-ea"/>
                 <a:cs typeface="+mn-cs"/>
               </a:rPr>
-              <a:t>What belongs in CLAUDE.md, and how does it relate to AGENTS.md?</a:t>
+              <a:t>What belongs in AGENTS.md, and why keep it short?</a:t>
             </a:r>
             <a:endParaRPr lang="en-US" sz="2175" dirty="0"/>
           </a:p>
@@ -16424,6 +16678,10 @@
           </a:solidFill>
           <a:ln/>
         </p:spPr>
+        <p:txBody>
+          <a:bodyPr/>
+          <a:p/>
+        </p:txBody>
       </p:sp>
       <p:sp xmlns:p="http://schemas.openxmlformats.org/presentationml/2006/main" xmlns:a="http://schemas.openxmlformats.org/drawingml/2006/main" xmlns:r="http://schemas.openxmlformats.org/officeDocument/2006/relationships">
         <p:nvSpPr>
@@ -16680,6 +16938,10 @@
           </a:solidFill>
           <a:ln/>
         </p:spPr>
+        <p:txBody>
+          <a:bodyPr/>
+          <a:p/>
+        </p:txBody>
       </p:sp>
       <p:sp xmlns:p="http://schemas.openxmlformats.org/presentationml/2006/main" xmlns:a="http://schemas.openxmlformats.org/drawingml/2006/main" xmlns:r="http://schemas.openxmlformats.org/officeDocument/2006/relationships">
         <p:nvSpPr>
@@ -16804,6 +17066,10 @@
           </a:solidFill>
           <a:ln/>
         </p:spPr>
+        <p:txBody>
+          <a:bodyPr/>
+          <a:p/>
+        </p:txBody>
       </p:sp>
       <p:sp xmlns:p="http://schemas.openxmlformats.org/presentationml/2006/main" xmlns:a="http://schemas.openxmlformats.org/drawingml/2006/main" xmlns:r="http://schemas.openxmlformats.org/officeDocument/2006/relationships">
         <p:nvSpPr>
@@ -16824,6 +17090,10 @@
           </a:solidFill>
           <a:ln/>
         </p:spPr>
+        <p:txBody>
+          <a:bodyPr/>
+          <a:p/>
+        </p:txBody>
       </p:sp>
       <p:sp xmlns:p="http://schemas.openxmlformats.org/presentationml/2006/main" xmlns:a="http://schemas.openxmlformats.org/drawingml/2006/main" xmlns:r="http://schemas.openxmlformats.org/officeDocument/2006/relationships">
         <p:nvSpPr>
@@ -16901,7 +17171,7 @@
                 <a:ea typeface="+mn-ea"/>
                 <a:cs typeface="+mn-cs"/>
               </a:rPr>
-              <a:t>Claude Pro or higher for Claude Code on the web. Use the account type your organization directs. Other tools: see Agent Tool Options.</a:t>
+              <a:t>ChatGPT Plus or higher; Business, Edu, and Enterprise plans also include Codex. Use the account type your organization directs.</a:t>
             </a:r>
             <a:endParaRPr lang="en-US" sz="1950" dirty="0"/>
           </a:p>
@@ -16926,6 +17196,10 @@
           </a:solidFill>
           <a:ln/>
         </p:spPr>
+        <p:txBody>
+          <a:bodyPr/>
+          <a:p/>
+        </p:txBody>
       </p:sp>
       <p:sp xmlns:p="http://schemas.openxmlformats.org/presentationml/2006/main" xmlns:a="http://schemas.openxmlformats.org/drawingml/2006/main" xmlns:r="http://schemas.openxmlformats.org/officeDocument/2006/relationships">
         <p:nvSpPr>
@@ -16946,6 +17220,10 @@
           </a:solidFill>
           <a:ln/>
         </p:spPr>
+        <p:txBody>
+          <a:bodyPr/>
+          <a:p/>
+        </p:txBody>
       </p:sp>
       <p:sp xmlns:p="http://schemas.openxmlformats.org/presentationml/2006/main" xmlns:a="http://schemas.openxmlformats.org/drawingml/2006/main" xmlns:r="http://schemas.openxmlformats.org/officeDocument/2006/relationships">
         <p:nvSpPr>
@@ -17048,6 +17326,10 @@
           </a:solidFill>
           <a:ln/>
         </p:spPr>
+        <p:txBody>
+          <a:bodyPr/>
+          <a:p/>
+        </p:txBody>
       </p:sp>
       <p:sp xmlns:p="http://schemas.openxmlformats.org/presentationml/2006/main" xmlns:a="http://schemas.openxmlformats.org/drawingml/2006/main" xmlns:r="http://schemas.openxmlformats.org/officeDocument/2006/relationships">
         <p:nvSpPr>
@@ -17068,6 +17350,10 @@
           </a:solidFill>
           <a:ln/>
         </p:spPr>
+        <p:txBody>
+          <a:bodyPr/>
+          <a:p/>
+        </p:txBody>
       </p:sp>
       <p:sp xmlns:p="http://schemas.openxmlformats.org/presentationml/2006/main" xmlns:a="http://schemas.openxmlformats.org/drawingml/2006/main" xmlns:r="http://schemas.openxmlformats.org/officeDocument/2006/relationships">
         <p:nvSpPr>
@@ -17145,7 +17431,7 @@
                 <a:ea typeface="+mn-ea"/>
                 <a:cs typeface="+mn-cs"/>
               </a:rPr>
-              <a:t>To run the tests yourself. The agent’s cloud sandbox has no MATLAB.</a:t>
+              <a:t>To run the tests yourself. The agent’s cloud environment has no MATLAB.</a:t>
             </a:r>
             <a:endParaRPr lang="en-US" sz="1950" dirty="0"/>
           </a:p>
@@ -17170,6 +17456,10 @@
           </a:solidFill>
           <a:ln/>
         </p:spPr>
+        <p:txBody>
+          <a:bodyPr/>
+          <a:p/>
+        </p:txBody>
       </p:sp>
       <p:sp xmlns:p="http://schemas.openxmlformats.org/presentationml/2006/main" xmlns:a="http://schemas.openxmlformats.org/drawingml/2006/main" xmlns:r="http://schemas.openxmlformats.org/officeDocument/2006/relationships">
         <p:nvSpPr>
@@ -17190,6 +17480,10 @@
           </a:solidFill>
           <a:ln/>
         </p:spPr>
+        <p:txBody>
+          <a:bodyPr/>
+          <a:p/>
+        </p:txBody>
       </p:sp>
       <p:sp xmlns:p="http://schemas.openxmlformats.org/presentationml/2006/main" xmlns:a="http://schemas.openxmlformats.org/drawingml/2006/main" xmlns:r="http://schemas.openxmlformats.org/officeDocument/2006/relationships">
         <p:nvSpPr>
@@ -17292,6 +17586,10 @@
           </a:solidFill>
           <a:ln/>
         </p:spPr>
+        <p:txBody>
+          <a:bodyPr/>
+          <a:p/>
+        </p:txBody>
       </p:sp>
       <p:sp xmlns:p="http://schemas.openxmlformats.org/presentationml/2006/main" xmlns:a="http://schemas.openxmlformats.org/drawingml/2006/main" xmlns:r="http://schemas.openxmlformats.org/officeDocument/2006/relationships">
         <p:nvSpPr>
@@ -17312,6 +17610,10 @@
           </a:solidFill>
           <a:ln/>
         </p:spPr>
+        <p:txBody>
+          <a:bodyPr/>
+          <a:p/>
+        </p:txBody>
       </p:sp>
       <p:sp xmlns:p="http://schemas.openxmlformats.org/presentationml/2006/main" xmlns:a="http://schemas.openxmlformats.org/drawingml/2006/main" xmlns:r="http://schemas.openxmlformats.org/officeDocument/2006/relationships">
         <p:nvSpPr>
@@ -17516,6 +17818,10 @@
           </a:solidFill>
           <a:ln/>
         </p:spPr>
+        <p:txBody>
+          <a:bodyPr/>
+          <a:p/>
+        </p:txBody>
       </p:sp>
       <p:sp xmlns:p="http://schemas.openxmlformats.org/presentationml/2006/main" xmlns:a="http://schemas.openxmlformats.org/drawingml/2006/main" xmlns:r="http://schemas.openxmlformats.org/officeDocument/2006/relationships">
         <p:nvSpPr>
@@ -17618,6 +17924,10 @@
           </a:solidFill>
           <a:ln/>
         </p:spPr>
+        <p:txBody>
+          <a:bodyPr/>
+          <a:p/>
+        </p:txBody>
       </p:sp>
       <p:sp xmlns:p="http://schemas.openxmlformats.org/presentationml/2006/main" xmlns:a="http://schemas.openxmlformats.org/drawingml/2006/main" xmlns:r="http://schemas.openxmlformats.org/officeDocument/2006/relationships">
         <p:nvSpPr>
@@ -17638,6 +17948,10 @@
           </a:solidFill>
           <a:ln/>
         </p:spPr>
+        <p:txBody>
+          <a:bodyPr/>
+          <a:p/>
+        </p:txBody>
       </p:sp>
       <p:sp xmlns:p="http://schemas.openxmlformats.org/presentationml/2006/main" xmlns:a="http://schemas.openxmlformats.org/drawingml/2006/main" xmlns:r="http://schemas.openxmlformats.org/officeDocument/2006/relationships">
         <p:nvSpPr>
@@ -17740,6 +18054,10 @@
           </a:solidFill>
           <a:ln/>
         </p:spPr>
+        <p:txBody>
+          <a:bodyPr/>
+          <a:p/>
+        </p:txBody>
       </p:sp>
       <p:sp xmlns:p="http://schemas.openxmlformats.org/presentationml/2006/main" xmlns:a="http://schemas.openxmlformats.org/drawingml/2006/main" xmlns:r="http://schemas.openxmlformats.org/officeDocument/2006/relationships">
         <p:nvSpPr>
@@ -17760,6 +18078,10 @@
           </a:solidFill>
           <a:ln/>
         </p:spPr>
+        <p:txBody>
+          <a:bodyPr/>
+          <a:p/>
+        </p:txBody>
       </p:sp>
       <p:sp xmlns:p="http://schemas.openxmlformats.org/presentationml/2006/main" xmlns:a="http://schemas.openxmlformats.org/drawingml/2006/main" xmlns:r="http://schemas.openxmlformats.org/officeDocument/2006/relationships">
         <p:nvSpPr>
@@ -17862,6 +18184,10 @@
           </a:solidFill>
           <a:ln/>
         </p:spPr>
+        <p:txBody>
+          <a:bodyPr/>
+          <a:p/>
+        </p:txBody>
       </p:sp>
       <p:sp xmlns:p="http://schemas.openxmlformats.org/presentationml/2006/main" xmlns:a="http://schemas.openxmlformats.org/drawingml/2006/main" xmlns:r="http://schemas.openxmlformats.org/officeDocument/2006/relationships">
         <p:nvSpPr>
@@ -17912,6 +18238,10 @@
           </a:solidFill>
           <a:ln/>
         </p:spPr>
+        <p:txBody>
+          <a:bodyPr/>
+          <a:p/>
+        </p:txBody>
       </p:sp>
       <p:sp xmlns:p="http://schemas.openxmlformats.org/presentationml/2006/main" xmlns:a="http://schemas.openxmlformats.org/drawingml/2006/main" xmlns:r="http://schemas.openxmlformats.org/officeDocument/2006/relationships">
         <p:nvSpPr>
@@ -17973,6 +18303,10 @@
           </a:solidFill>
           <a:ln/>
         </p:spPr>
+        <p:txBody>
+          <a:bodyPr/>
+          <a:p/>
+        </p:txBody>
       </p:sp>
       <p:sp xmlns:p="http://schemas.openxmlformats.org/presentationml/2006/main" xmlns:a="http://schemas.openxmlformats.org/drawingml/2006/main" xmlns:r="http://schemas.openxmlformats.org/officeDocument/2006/relationships">
         <p:nvSpPr>
@@ -18009,7 +18343,7 @@
                 <a:ea typeface="+mn-ea"/>
                 <a:cs typeface="+mn-cs"/>
               </a:rPr>
-              <a:t>Coding agent (Claude Code)</a:t>
+              <a:t>Coding agent (Codex)</a:t>
             </a:r>
             <a:endParaRPr lang="en-US" sz="1800" dirty="0"/>
           </a:p>
@@ -18075,6 +18409,10 @@
           </a:solidFill>
           <a:ln/>
         </p:spPr>
+        <p:txBody>
+          <a:bodyPr/>
+          <a:p/>
+        </p:txBody>
       </p:sp>
       <p:sp xmlns:p="http://schemas.openxmlformats.org/presentationml/2006/main" xmlns:a="http://schemas.openxmlformats.org/drawingml/2006/main" xmlns:r="http://schemas.openxmlformats.org/officeDocument/2006/relationships">
         <p:nvSpPr>
@@ -18136,6 +18474,10 @@
           </a:solidFill>
           <a:ln/>
         </p:spPr>
+        <p:txBody>
+          <a:bodyPr/>
+          <a:p/>
+        </p:txBody>
       </p:sp>
       <p:sp xmlns:p="http://schemas.openxmlformats.org/presentationml/2006/main" xmlns:a="http://schemas.openxmlformats.org/drawingml/2006/main" xmlns:r="http://schemas.openxmlformats.org/officeDocument/2006/relationships">
         <p:nvSpPr>
@@ -18197,6 +18539,10 @@
           </a:solidFill>
           <a:ln/>
         </p:spPr>
+        <p:txBody>
+          <a:bodyPr/>
+          <a:p/>
+        </p:txBody>
       </p:sp>
       <p:sp xmlns:p="http://schemas.openxmlformats.org/presentationml/2006/main" xmlns:a="http://schemas.openxmlformats.org/drawingml/2006/main" xmlns:r="http://schemas.openxmlformats.org/officeDocument/2006/relationships">
         <p:nvSpPr>
@@ -18258,6 +18604,10 @@
           </a:solidFill>
           <a:ln/>
         </p:spPr>
+        <p:txBody>
+          <a:bodyPr/>
+          <a:p/>
+        </p:txBody>
       </p:sp>
       <p:sp xmlns:p="http://schemas.openxmlformats.org/presentationml/2006/main" xmlns:a="http://schemas.openxmlformats.org/drawingml/2006/main" xmlns:r="http://schemas.openxmlformats.org/officeDocument/2006/relationships">
         <p:nvSpPr>
@@ -18319,6 +18669,10 @@
           </a:solidFill>
           <a:ln/>
         </p:spPr>
+        <p:txBody>
+          <a:bodyPr/>
+          <a:p/>
+        </p:txBody>
       </p:sp>
       <p:sp xmlns:p="http://schemas.openxmlformats.org/presentationml/2006/main" xmlns:a="http://schemas.openxmlformats.org/drawingml/2006/main" xmlns:r="http://schemas.openxmlformats.org/officeDocument/2006/relationships">
         <p:nvSpPr>
@@ -18380,6 +18734,10 @@
           </a:solidFill>
           <a:ln/>
         </p:spPr>
+        <p:txBody>
+          <a:bodyPr/>
+          <a:p/>
+        </p:txBody>
       </p:sp>
       <p:sp xmlns:p="http://schemas.openxmlformats.org/presentationml/2006/main" xmlns:a="http://schemas.openxmlformats.org/drawingml/2006/main" xmlns:r="http://schemas.openxmlformats.org/officeDocument/2006/relationships">
         <p:nvSpPr>
@@ -18441,6 +18799,10 @@
           </a:solidFill>
           <a:ln/>
         </p:spPr>
+        <p:txBody>
+          <a:bodyPr/>
+          <a:p/>
+        </p:txBody>
       </p:sp>
       <p:sp xmlns:p="http://schemas.openxmlformats.org/presentationml/2006/main" xmlns:a="http://schemas.openxmlformats.org/drawingml/2006/main" xmlns:r="http://schemas.openxmlformats.org/officeDocument/2006/relationships">
         <p:nvSpPr>
@@ -18502,6 +18864,10 @@
           </a:solidFill>
           <a:ln/>
         </p:spPr>
+        <p:txBody>
+          <a:bodyPr/>
+          <a:p/>
+        </p:txBody>
       </p:sp>
       <p:sp xmlns:p="http://schemas.openxmlformats.org/presentationml/2006/main" xmlns:a="http://schemas.openxmlformats.org/drawingml/2006/main" xmlns:r="http://schemas.openxmlformats.org/officeDocument/2006/relationships">
         <p:nvSpPr>
@@ -18538,7 +18904,7 @@
                 <a:ea typeface="+mn-ea"/>
                 <a:cs typeface="+mn-cs"/>
               </a:rPr>
-              <a:t>Yes, in a cloud sandbox (search, scripts)</a:t>
+              <a:t>Yes, in a cloud environment (search, scripts)</a:t>
             </a:r>
             <a:endParaRPr lang="en-US" sz="1800" dirty="0"/>
           </a:p>
@@ -18563,6 +18929,10 @@
           </a:solidFill>
           <a:ln/>
         </p:spPr>
+        <p:txBody>
+          <a:bodyPr/>
+          <a:p/>
+        </p:txBody>
       </p:sp>
       <p:sp xmlns:p="http://schemas.openxmlformats.org/presentationml/2006/main" xmlns:a="http://schemas.openxmlformats.org/drawingml/2006/main" xmlns:r="http://schemas.openxmlformats.org/officeDocument/2006/relationships">
         <p:nvSpPr>
@@ -18624,6 +18994,10 @@
           </a:solidFill>
           <a:ln/>
         </p:spPr>
+        <p:txBody>
+          <a:bodyPr/>
+          <a:p/>
+        </p:txBody>
       </p:sp>
       <p:sp xmlns:p="http://schemas.openxmlformats.org/presentationml/2006/main" xmlns:a="http://schemas.openxmlformats.org/drawingml/2006/main" xmlns:r="http://schemas.openxmlformats.org/officeDocument/2006/relationships">
         <p:nvSpPr>
@@ -18685,6 +19059,10 @@
           </a:solidFill>
           <a:ln/>
         </p:spPr>
+        <p:txBody>
+          <a:bodyPr/>
+          <a:p/>
+        </p:txBody>
       </p:sp>
       <p:sp xmlns:p="http://schemas.openxmlformats.org/presentationml/2006/main" xmlns:a="http://schemas.openxmlformats.org/drawingml/2006/main" xmlns:r="http://schemas.openxmlformats.org/officeDocument/2006/relationships">
         <p:nvSpPr>
@@ -18721,7 +19099,7 @@
                 <a:ea typeface="+mn-ea"/>
                 <a:cs typeface="+mn-cs"/>
               </a:rPr>
-              <a:t>Written once in CLAUDE.md, read every session</a:t>
+              <a:t>Written once in AGENTS.md, read every task</a:t>
             </a:r>
             <a:endParaRPr lang="en-US" sz="1800" dirty="0"/>
           </a:p>
@@ -18746,6 +19124,10 @@
           </a:solidFill>
           <a:ln/>
         </p:spPr>
+        <p:txBody>
+          <a:bodyPr/>
+          <a:p/>
+        </p:txBody>
       </p:sp>
       <p:sp xmlns:p="http://schemas.openxmlformats.org/presentationml/2006/main" xmlns:a="http://schemas.openxmlformats.org/drawingml/2006/main" xmlns:r="http://schemas.openxmlformats.org/officeDocument/2006/relationships">
         <p:nvSpPr>
@@ -18807,6 +19189,10 @@
           </a:solidFill>
           <a:ln/>
         </p:spPr>
+        <p:txBody>
+          <a:bodyPr/>
+          <a:p/>
+        </p:txBody>
       </p:sp>
       <p:sp xmlns:p="http://schemas.openxmlformats.org/presentationml/2006/main" xmlns:a="http://schemas.openxmlformats.org/drawingml/2006/main" xmlns:r="http://schemas.openxmlformats.org/officeDocument/2006/relationships">
         <p:nvSpPr>
@@ -18868,6 +19254,10 @@
           </a:solidFill>
           <a:ln/>
         </p:spPr>
+        <p:txBody>
+          <a:bodyPr/>
+          <a:p/>
+        </p:txBody>
       </p:sp>
       <p:sp xmlns:p="http://schemas.openxmlformats.org/presentationml/2006/main" xmlns:a="http://schemas.openxmlformats.org/drawingml/2006/main" xmlns:r="http://schemas.openxmlformats.org/officeDocument/2006/relationships">
         <p:nvSpPr>
@@ -18929,6 +19319,10 @@
           </a:solidFill>
           <a:ln/>
         </p:spPr>
+        <p:txBody>
+          <a:bodyPr/>
+          <a:p/>
+        </p:txBody>
       </p:sp>
       <p:sp xmlns:p="http://schemas.openxmlformats.org/presentationml/2006/main" xmlns:a="http://schemas.openxmlformats.org/drawingml/2006/main" xmlns:r="http://schemas.openxmlformats.org/officeDocument/2006/relationships">
         <p:nvSpPr>
@@ -19133,6 +19527,10 @@
           </a:solidFill>
           <a:ln/>
         </p:spPr>
+        <p:txBody>
+          <a:bodyPr/>
+          <a:p/>
+        </p:txBody>
       </p:sp>
       <p:sp xmlns:p="http://schemas.openxmlformats.org/presentationml/2006/main" xmlns:a="http://schemas.openxmlformats.org/drawingml/2006/main" xmlns:r="http://schemas.openxmlformats.org/officeDocument/2006/relationships">
         <p:nvSpPr>
@@ -19235,6 +19633,10 @@
           </a:solidFill>
           <a:ln/>
         </p:spPr>
+        <p:txBody>
+          <a:bodyPr/>
+          <a:p/>
+        </p:txBody>
       </p:sp>
       <p:sp xmlns:p="http://schemas.openxmlformats.org/presentationml/2006/main" xmlns:a="http://schemas.openxmlformats.org/drawingml/2006/main" xmlns:r="http://schemas.openxmlformats.org/officeDocument/2006/relationships">
         <p:nvSpPr>
@@ -19255,6 +19657,10 @@
           </a:solidFill>
           <a:ln/>
         </p:spPr>
+        <p:txBody>
+          <a:bodyPr/>
+          <a:p/>
+        </p:txBody>
       </p:sp>
       <p:sp xmlns:p="http://schemas.openxmlformats.org/presentationml/2006/main" xmlns:a="http://schemas.openxmlformats.org/drawingml/2006/main" xmlns:r="http://schemas.openxmlformats.org/officeDocument/2006/relationships">
         <p:nvSpPr>
@@ -19357,6 +19763,10 @@
           </a:solidFill>
           <a:ln/>
         </p:spPr>
+        <p:txBody>
+          <a:bodyPr/>
+          <a:p/>
+        </p:txBody>
       </p:sp>
       <p:sp xmlns:p="http://schemas.openxmlformats.org/presentationml/2006/main" xmlns:a="http://schemas.openxmlformats.org/drawingml/2006/main" xmlns:r="http://schemas.openxmlformats.org/officeDocument/2006/relationships">
         <p:nvSpPr>
@@ -19377,6 +19787,10 @@
           </a:solidFill>
           <a:ln/>
         </p:spPr>
+        <p:txBody>
+          <a:bodyPr/>
+          <a:p/>
+        </p:txBody>
       </p:sp>
       <p:sp xmlns:p="http://schemas.openxmlformats.org/presentationml/2006/main" xmlns:a="http://schemas.openxmlformats.org/drawingml/2006/main" xmlns:r="http://schemas.openxmlformats.org/officeDocument/2006/relationships">
         <p:nvSpPr>
@@ -19479,6 +19893,10 @@
           </a:solidFill>
           <a:ln/>
         </p:spPr>
+        <p:txBody>
+          <a:bodyPr/>
+          <a:p/>
+        </p:txBody>
       </p:sp>
       <p:sp xmlns:p="http://schemas.openxmlformats.org/presentationml/2006/main" xmlns:a="http://schemas.openxmlformats.org/drawingml/2006/main" xmlns:r="http://schemas.openxmlformats.org/officeDocument/2006/relationships">
         <p:nvSpPr>
@@ -19499,6 +19917,10 @@
           </a:solidFill>
           <a:ln/>
         </p:spPr>
+        <p:txBody>
+          <a:bodyPr/>
+          <a:p/>
+        </p:txBody>
       </p:sp>
       <p:sp xmlns:p="http://schemas.openxmlformats.org/presentationml/2006/main" xmlns:a="http://schemas.openxmlformats.org/drawingml/2006/main" xmlns:r="http://schemas.openxmlformats.org/officeDocument/2006/relationships">
         <p:nvSpPr>
@@ -19601,6 +20023,10 @@
           </a:solidFill>
           <a:ln/>
         </p:spPr>
+        <p:txBody>
+          <a:bodyPr/>
+          <a:p/>
+        </p:txBody>
       </p:sp>
       <p:sp xmlns:p="http://schemas.openxmlformats.org/presentationml/2006/main" xmlns:a="http://schemas.openxmlformats.org/drawingml/2006/main" xmlns:r="http://schemas.openxmlformats.org/officeDocument/2006/relationships">
         <p:nvSpPr>
@@ -19621,6 +20047,10 @@
           </a:solidFill>
           <a:ln/>
         </p:spPr>
+        <p:txBody>
+          <a:bodyPr/>
+          <a:p/>
+        </p:txBody>
       </p:sp>
       <p:sp xmlns:p="http://schemas.openxmlformats.org/presentationml/2006/main" xmlns:a="http://schemas.openxmlformats.org/drawingml/2006/main" xmlns:r="http://schemas.openxmlformats.org/officeDocument/2006/relationships">
         <p:nvSpPr>
@@ -19641,6 +20071,10 @@
           </a:solidFill>
           <a:ln/>
         </p:spPr>
+        <p:txBody>
+          <a:bodyPr/>
+          <a:p/>
+        </p:txBody>
       </p:sp>
       <p:sp xmlns:p="http://schemas.openxmlformats.org/presentationml/2006/main" xmlns:a="http://schemas.openxmlformats.org/drawingml/2006/main" xmlns:r="http://schemas.openxmlformats.org/officeDocument/2006/relationships">
         <p:nvSpPr>
@@ -19661,6 +20095,10 @@
           </a:solidFill>
           <a:ln/>
         </p:spPr>
+        <p:txBody>
+          <a:bodyPr/>
+          <a:p/>
+        </p:txBody>
       </p:sp>
       <p:sp xmlns:p="http://schemas.openxmlformats.org/presentationml/2006/main" xmlns:a="http://schemas.openxmlformats.org/drawingml/2006/main" xmlns:r="http://schemas.openxmlformats.org/officeDocument/2006/relationships">
         <p:nvSpPr>
@@ -19681,6 +20119,10 @@
           </a:solidFill>
           <a:ln/>
         </p:spPr>
+        <p:txBody>
+          <a:bodyPr/>
+          <a:p/>
+        </p:txBody>
       </p:sp>
       <p:sp xmlns:p="http://schemas.openxmlformats.org/presentationml/2006/main" xmlns:a="http://schemas.openxmlformats.org/drawingml/2006/main" xmlns:r="http://schemas.openxmlformats.org/officeDocument/2006/relationships">
         <p:nvSpPr>
@@ -19945,7 +20387,7 @@
                 <a:ea typeface="+mn-ea"/>
                 <a:cs typeface="+mn-cs"/>
               </a:rPr>
-              <a:t>Open a session in Claude Code, Codex, or another coding agent</a:t>
+              <a:t>Open a task in Codex, Claude Code, or another coding agent</a:t>
             </a:r>
             <a:endParaRPr lang="en-US" sz="2025" dirty="0"/>
           </a:p>
@@ -20033,7 +20475,7 @@
                 <a:ea typeface="+mn-ea"/>
                 <a:cs typeface="+mn-cs"/>
               </a:rPr>
-              <a:t>Connect your repo to the session, with a context file (CLAUDE.md)</a:t>
+              <a:t>Connect your repo to the agent, with a context file (AGENTS.md)</a:t>
             </a:r>
             <a:endParaRPr lang="en-US" sz="2025" dirty="0"/>
           </a:p>
@@ -20377,6 +20819,10 @@
           </a:solidFill>
           <a:ln/>
         </p:spPr>
+        <p:txBody>
+          <a:bodyPr/>
+          <a:p/>
+        </p:txBody>
       </p:sp>
       <p:sp xmlns:p="http://schemas.openxmlformats.org/presentationml/2006/main" xmlns:a="http://schemas.openxmlformats.org/drawingml/2006/main" xmlns:r="http://schemas.openxmlformats.org/officeDocument/2006/relationships">
         <p:nvSpPr>
@@ -20438,6 +20884,10 @@
           </a:solidFill>
           <a:ln/>
         </p:spPr>
+        <p:txBody>
+          <a:bodyPr/>
+          <a:p/>
+        </p:txBody>
       </p:sp>
       <p:sp xmlns:p="http://schemas.openxmlformats.org/presentationml/2006/main" xmlns:a="http://schemas.openxmlformats.org/drawingml/2006/main" xmlns:r="http://schemas.openxmlformats.org/officeDocument/2006/relationships">
         <p:nvSpPr>
@@ -20499,6 +20949,10 @@
           </a:solidFill>
           <a:ln/>
         </p:spPr>
+        <p:txBody>
+          <a:bodyPr/>
+          <a:p/>
+        </p:txBody>
       </p:sp>
       <p:sp xmlns:p="http://schemas.openxmlformats.org/presentationml/2006/main" xmlns:a="http://schemas.openxmlformats.org/drawingml/2006/main" xmlns:r="http://schemas.openxmlformats.org/officeDocument/2006/relationships">
         <p:nvSpPr>
@@ -20560,6 +21014,10 @@
           </a:solidFill>
           <a:ln/>
         </p:spPr>
+        <p:txBody>
+          <a:bodyPr/>
+          <a:p/>
+        </p:txBody>
       </p:sp>
       <p:sp xmlns:p="http://schemas.openxmlformats.org/presentationml/2006/main" xmlns:a="http://schemas.openxmlformats.org/drawingml/2006/main" xmlns:r="http://schemas.openxmlformats.org/officeDocument/2006/relationships">
         <p:nvSpPr>
@@ -20637,7 +21095,7 @@
                 <a:ea typeface="+mn-ea"/>
                 <a:cs typeface="+mn-cs"/>
               </a:rPr>
-              <a:t xml:space="preserve">Claude Code on the web </a:t>
+              <a:t xml:space="preserve">ChatGPT Codex </a:t>
             </a:r>
             <a:r>
               <a:rPr lang="en-US" sz="1725" b="1" dirty="0">
@@ -20673,6 +21131,10 @@
           </a:solidFill>
           <a:ln/>
         </p:spPr>
+        <p:txBody>
+          <a:bodyPr/>
+          <a:p/>
+        </p:txBody>
       </p:sp>
       <p:sp xmlns:p="http://schemas.openxmlformats.org/presentationml/2006/main" xmlns:a="http://schemas.openxmlformats.org/drawingml/2006/main" xmlns:r="http://schemas.openxmlformats.org/officeDocument/2006/relationships">
         <p:nvSpPr>
@@ -20709,7 +21171,7 @@
                 <a:ea typeface="+mn-ea"/>
                 <a:cs typeface="+mn-cs"/>
               </a:rPr>
-              <a:t>Cloud sandbox, working from your GitHub repo</a:t>
+              <a:t>Cloud environment from your GitHub repo; also app, CLI, VS Code</a:t>
             </a:r>
             <a:endParaRPr lang="en-US" sz="1725" dirty="0"/>
           </a:p>
@@ -20734,6 +21196,10 @@
           </a:solidFill>
           <a:ln/>
         </p:spPr>
+        <p:txBody>
+          <a:bodyPr/>
+          <a:p/>
+        </p:txBody>
       </p:sp>
       <p:sp xmlns:p="http://schemas.openxmlformats.org/presentationml/2006/main" xmlns:a="http://schemas.openxmlformats.org/drawingml/2006/main" xmlns:r="http://schemas.openxmlformats.org/officeDocument/2006/relationships">
         <p:nvSpPr>
@@ -20770,7 +21236,7 @@
                 <a:ea typeface="+mn-ea"/>
                 <a:cs typeface="+mn-cs"/>
               </a:rPr>
-              <a:t>Claude Pro plan or higher</a:t>
+              <a:t>ChatGPT Plus plan or higher</a:t>
             </a:r>
             <a:endParaRPr lang="en-US" sz="1725" dirty="0"/>
           </a:p>
@@ -20795,6 +21261,10 @@
           </a:solidFill>
           <a:ln/>
         </p:spPr>
+        <p:txBody>
+          <a:bodyPr/>
+          <a:p/>
+        </p:txBody>
       </p:sp>
       <p:sp xmlns:p="http://schemas.openxmlformats.org/presentationml/2006/main" xmlns:a="http://schemas.openxmlformats.org/drawingml/2006/main" xmlns:r="http://schemas.openxmlformats.org/officeDocument/2006/relationships">
         <p:nvSpPr>
@@ -20831,7 +21301,7 @@
                 <a:ea typeface="+mn-ea"/>
                 <a:cs typeface="+mn-cs"/>
               </a:rPr>
-              <a:t>CLAUDE.md</a:t>
+              <a:t>AGENTS.md</a:t>
             </a:r>
             <a:endParaRPr lang="en-US" sz="1725" dirty="0"/>
           </a:p>
@@ -20856,6 +21326,10 @@
           </a:solidFill>
           <a:ln/>
         </p:spPr>
+        <p:txBody>
+          <a:bodyPr/>
+          <a:p/>
+        </p:txBody>
       </p:sp>
       <p:sp xmlns:p="http://schemas.openxmlformats.org/presentationml/2006/main" xmlns:a="http://schemas.openxmlformats.org/drawingml/2006/main" xmlns:r="http://schemas.openxmlformats.org/officeDocument/2006/relationships">
         <p:nvSpPr>
@@ -20892,7 +21366,7 @@
                 <a:ea typeface="+mn-ea"/>
                 <a:cs typeface="+mn-cs"/>
               </a:rPr>
-              <a:t>OpenAI Codex</a:t>
+              <a:t>Claude Code</a:t>
             </a:r>
             <a:endParaRPr lang="en-US" sz="1725" dirty="0"/>
           </a:p>
@@ -20917,6 +21391,10 @@
           </a:solidFill>
           <a:ln/>
         </p:spPr>
+        <p:txBody>
+          <a:bodyPr/>
+          <a:p/>
+        </p:txBody>
       </p:sp>
       <p:sp xmlns:p="http://schemas.openxmlformats.org/presentationml/2006/main" xmlns:a="http://schemas.openxmlformats.org/drawingml/2006/main" xmlns:r="http://schemas.openxmlformats.org/officeDocument/2006/relationships">
         <p:nvSpPr>
@@ -20953,7 +21431,7 @@
                 <a:ea typeface="+mn-ea"/>
                 <a:cs typeface="+mn-cs"/>
               </a:rPr>
-              <a:t>Cloud tasks from your GitHub repo; also an app, CLI, and VS Code extension</a:t>
+              <a:t>Cloud sandbox from your GitHub repo; also CLI and VS Code extension</a:t>
             </a:r>
             <a:endParaRPr lang="en-US" sz="1725" dirty="0"/>
           </a:p>
@@ -20978,6 +21456,10 @@
           </a:solidFill>
           <a:ln/>
         </p:spPr>
+        <p:txBody>
+          <a:bodyPr/>
+          <a:p/>
+        </p:txBody>
       </p:sp>
       <p:sp xmlns:p="http://schemas.openxmlformats.org/presentationml/2006/main" xmlns:a="http://schemas.openxmlformats.org/drawingml/2006/main" xmlns:r="http://schemas.openxmlformats.org/officeDocument/2006/relationships">
         <p:nvSpPr>
@@ -21014,7 +21496,7 @@
                 <a:ea typeface="+mn-ea"/>
                 <a:cs typeface="+mn-cs"/>
               </a:rPr>
-              <a:t>ChatGPT plans; limits vary by plan</a:t>
+              <a:t>Claude Pro plan or higher</a:t>
             </a:r>
             <a:endParaRPr lang="en-US" sz="1725" dirty="0"/>
           </a:p>
@@ -21039,6 +21521,10 @@
           </a:solidFill>
           <a:ln/>
         </p:spPr>
+        <p:txBody>
+          <a:bodyPr/>
+          <a:p/>
+        </p:txBody>
       </p:sp>
       <p:sp xmlns:p="http://schemas.openxmlformats.org/presentationml/2006/main" xmlns:a="http://schemas.openxmlformats.org/drawingml/2006/main" xmlns:r="http://schemas.openxmlformats.org/officeDocument/2006/relationships">
         <p:nvSpPr>
@@ -21075,7 +21561,7 @@
                 <a:ea typeface="+mn-ea"/>
                 <a:cs typeface="+mn-cs"/>
               </a:rPr>
-              <a:t>AGENTS.md</a:t>
+              <a:t>CLAUDE.md (can import AGENTS.md)</a:t>
             </a:r>
             <a:endParaRPr lang="en-US" sz="1725" dirty="0"/>
           </a:p>
@@ -21100,6 +21586,10 @@
           </a:solidFill>
           <a:ln/>
         </p:spPr>
+        <p:txBody>
+          <a:bodyPr/>
+          <a:p/>
+        </p:txBody>
       </p:sp>
       <p:sp xmlns:p="http://schemas.openxmlformats.org/presentationml/2006/main" xmlns:a="http://schemas.openxmlformats.org/drawingml/2006/main" xmlns:r="http://schemas.openxmlformats.org/officeDocument/2006/relationships">
         <p:nvSpPr>
@@ -21161,6 +21651,10 @@
           </a:solidFill>
           <a:ln/>
         </p:spPr>
+        <p:txBody>
+          <a:bodyPr/>
+          <a:p/>
+        </p:txBody>
       </p:sp>
       <p:sp xmlns:p="http://schemas.openxmlformats.org/presentationml/2006/main" xmlns:a="http://schemas.openxmlformats.org/drawingml/2006/main" xmlns:r="http://schemas.openxmlformats.org/officeDocument/2006/relationships">
         <p:nvSpPr>
@@ -21222,6 +21716,10 @@
           </a:solidFill>
           <a:ln/>
         </p:spPr>
+        <p:txBody>
+          <a:bodyPr/>
+          <a:p/>
+        </p:txBody>
       </p:sp>
       <p:sp xmlns:p="http://schemas.openxmlformats.org/presentationml/2006/main" xmlns:a="http://schemas.openxmlformats.org/drawingml/2006/main" xmlns:r="http://schemas.openxmlformats.org/officeDocument/2006/relationships">
         <p:nvSpPr>
@@ -21283,6 +21781,10 @@
           </a:solidFill>
           <a:ln/>
         </p:spPr>
+        <p:txBody>
+          <a:bodyPr/>
+          <a:p/>
+        </p:txBody>
       </p:sp>
       <p:sp xmlns:p="http://schemas.openxmlformats.org/presentationml/2006/main" xmlns:a="http://schemas.openxmlformats.org/drawingml/2006/main" xmlns:r="http://schemas.openxmlformats.org/officeDocument/2006/relationships">
         <p:nvSpPr>
@@ -21361,6 +21863,10 @@
           </a:solidFill>
           <a:ln/>
         </p:spPr>
+        <p:txBody>
+          <a:bodyPr/>
+          <a:p/>
+        </p:txBody>
       </p:sp>
       <p:sp xmlns:p="http://schemas.openxmlformats.org/presentationml/2006/main" xmlns:a="http://schemas.openxmlformats.org/drawingml/2006/main" xmlns:r="http://schemas.openxmlformats.org/officeDocument/2006/relationships">
         <p:nvSpPr>
@@ -22608,7 +23114,7 @@
           <a:p>
             <a:r>
               <a:rPr lang="en-US" dirty="0"/>
-              <a:t>Exercise 1: Add CLAUDE.md</a:t>
+              <a:t>Exercise 1: Improve AGENTS.md</a:t>
             </a:r>
             <a:endParaRPr lang="en-US" dirty="0"/>
           </a:p>
@@ -22635,6 +23141,10 @@
           </a:solidFill>
           <a:ln/>
         </p:spPr>
+        <p:txBody>
+          <a:bodyPr/>
+          <a:p/>
+        </p:txBody>
       </p:sp>
       <p:sp xmlns:p="http://schemas.openxmlformats.org/presentationml/2006/main" xmlns:a="http://schemas.openxmlformats.org/drawingml/2006/main" xmlns:r="http://schemas.openxmlformats.org/officeDocument/2006/relationships">
         <p:nvSpPr>
@@ -22674,7 +23184,7 @@
                 <a:ea typeface="Consolas" pitchFamily="34" charset="-122"/>
                 <a:cs typeface="Consolas" pitchFamily="34" charset="-120"/>
               </a:rPr>
-              <a:t># beam-calc</a:t>
+              <a:t># AGENTS.md</a:t>
             </a:r>
             <a:endParaRPr lang="en-US" sz="1650" dirty="0"/>
           </a:p>
@@ -22688,13 +23198,13 @@
             <a:r>
               <a:rPr lang="en-US" sz="1650" dirty="0">
                 <a:solidFill>
-                  <a:srgbClr val="D4D4D4"/>
+                  <a:srgbClr val="00B0F0"/>
                 </a:solidFill>
                 <a:latin typeface="Consolas" pitchFamily="34" charset="0"/>
                 <a:ea typeface="Consolas" pitchFamily="34" charset="-122"/>
                 <a:cs typeface="Consolas" pitchFamily="34" charset="-120"/>
               </a:rPr>
-              <a:t>@AGENTS.md</a:t>
+              <a:t>## Project</a:t>
             </a:r>
             <a:endParaRPr lang="en-US" sz="1650" dirty="0"/>
           </a:p>
@@ -22714,7 +23224,7 @@
                 <a:ea typeface="Consolas" pitchFamily="34" charset="-122"/>
                 <a:cs typeface="Consolas" pitchFamily="34" charset="-120"/>
               </a:rPr>
-              <a:t xml:space="preserve"> </a:t>
+              <a:t>- MATLAB R2024b, no toolboxes.</a:t>
             </a:r>
             <a:endParaRPr lang="en-US" sz="1650" dirty="0"/>
           </a:p>
@@ -22774,7 +23284,7 @@
                 <a:ea typeface="Consolas" pitchFamily="34" charset="-122"/>
                 <a:cs typeface="Consolas" pitchFamily="34" charset="-120"/>
               </a:rPr>
-              <a:t xml:space="preserve">  new to coding agents. Explain</a:t>
+              <a:t>  new to coding agents. Explain</a:t>
             </a:r>
             <a:endParaRPr lang="en-US" sz="1650" dirty="0"/>
           </a:p>
@@ -22794,7 +23304,7 @@
                 <a:ea typeface="Consolas" pitchFamily="34" charset="-122"/>
                 <a:cs typeface="Consolas" pitchFamily="34" charset="-120"/>
               </a:rPr>
-              <a:t xml:space="preserve">  each change before coding.</a:t>
+              <a:t>  each change before coding.</a:t>
             </a:r>
             <a:endParaRPr lang="en-US" sz="1650" dirty="0"/>
           </a:p>
@@ -22808,13 +23318,13 @@
             <a:r>
               <a:rPr lang="en-US" sz="1650" dirty="0">
                 <a:solidFill>
-                  <a:srgbClr val="D4D4D4"/>
+                  <a:srgbClr val="00B0F0"/>
                 </a:solidFill>
                 <a:latin typeface="Consolas" pitchFamily="34" charset="0"/>
                 <a:ea typeface="Consolas" pitchFamily="34" charset="-122"/>
                 <a:cs typeface="Consolas" pitchFamily="34" charset="-120"/>
               </a:rPr>
-              <a:t>- Prefer simple, readable MATLAB.</a:t>
+              <a:t>## Conventions</a:t>
             </a:r>
             <a:endParaRPr lang="en-US" sz="1650" dirty="0"/>
           </a:p>
@@ -22834,7 +23344,7 @@
                 <a:ea typeface="Consolas" pitchFamily="34" charset="-122"/>
                 <a:cs typeface="Consolas" pitchFamily="34" charset="-120"/>
               </a:rPr>
-              <a:t xml:space="preserve"> </a:t>
+              <a:t>- SI units; comment the units</a:t>
             </a:r>
             <a:endParaRPr lang="en-US" sz="1650" dirty="0"/>
           </a:p>
@@ -22848,13 +23358,13 @@
             <a:r>
               <a:rPr lang="en-US" sz="1650" dirty="0">
                 <a:solidFill>
-                  <a:srgbClr val="00B0F0"/>
+                  <a:srgbClr val="D4D4D4"/>
                 </a:solidFill>
                 <a:latin typeface="Consolas" pitchFamily="34" charset="0"/>
                 <a:ea typeface="Consolas" pitchFamily="34" charset="-122"/>
                 <a:cs typeface="Consolas" pitchFamily="34" charset="-120"/>
               </a:rPr>
-              <a:t>## Environment</a:t>
+              <a:t>  on every constant.</a:t>
             </a:r>
             <a:endParaRPr lang="en-US" sz="1650" dirty="0"/>
           </a:p>
@@ -22874,7 +23384,7 @@
                 <a:ea typeface="Consolas" pitchFamily="34" charset="-122"/>
                 <a:cs typeface="Consolas" pitchFamily="34" charset="-120"/>
               </a:rPr>
-              <a:t>- You can't run MATLAB in your</a:t>
+              <a:t>- One function per file.</a:t>
             </a:r>
             <a:endParaRPr lang="en-US" sz="1650" dirty="0"/>
           </a:p>
@@ -22888,13 +23398,13 @@
             <a:r>
               <a:rPr lang="en-US" sz="1650" dirty="0">
                 <a:solidFill>
-                  <a:srgbClr val="D4D4D4"/>
+                  <a:srgbClr val="00B0F0"/>
                 </a:solidFill>
                 <a:latin typeface="Consolas" pitchFamily="34" charset="0"/>
                 <a:ea typeface="Consolas" pitchFamily="34" charset="-122"/>
                 <a:cs typeface="Consolas" pitchFamily="34" charset="-120"/>
               </a:rPr>
-              <a:t xml:space="preserve">  sandbox. List the checks I</a:t>
+              <a:t>## Environment and checks</a:t>
             </a:r>
             <a:endParaRPr lang="en-US" sz="1650" dirty="0"/>
           </a:p>
@@ -22914,7 +23424,7 @@
                 <a:ea typeface="Consolas" pitchFamily="34" charset="-122"/>
                 <a:cs typeface="Consolas" pitchFamily="34" charset="-120"/>
               </a:rPr>
-              <a:t xml:space="preserve">  must run myself.</a:t>
+              <a:t>- No MATLAB in your cloud</a:t>
             </a:r>
             <a:endParaRPr lang="en-US" sz="1650" dirty="0"/>
           </a:p>
@@ -22934,7 +23444,7 @@
                 <a:ea typeface="Consolas" pitchFamily="34" charset="-122"/>
                 <a:cs typeface="Consolas" pitchFamily="34" charset="-120"/>
               </a:rPr>
-              <a:t xml:space="preserve"> </a:t>
+              <a:t>  environment. List the checks</a:t>
             </a:r>
             <a:endParaRPr lang="en-US" sz="1650" dirty="0"/>
           </a:p>
@@ -22948,13 +23458,13 @@
             <a:r>
               <a:rPr lang="en-US" sz="1650" dirty="0">
                 <a:solidFill>
-                  <a:srgbClr val="00B0F0"/>
+                  <a:srgbClr val="D4D4D4"/>
                 </a:solidFill>
                 <a:latin typeface="Consolas" pitchFamily="34" charset="0"/>
                 <a:ea typeface="Consolas" pitchFamily="34" charset="-122"/>
                 <a:cs typeface="Consolas" pitchFamily="34" charset="-120"/>
               </a:rPr>
-              <a:t>## Rules</a:t>
+              <a:t>  I must run myself.</a:t>
             </a:r>
             <a:endParaRPr lang="en-US" sz="1650" dirty="0"/>
           </a:p>
@@ -22974,7 +23484,7 @@
                 <a:ea typeface="Consolas" pitchFamily="34" charset="-122"/>
                 <a:cs typeface="Consolas" pitchFamily="34" charset="-120"/>
               </a:rPr>
-              <a:t>- One function per file.</a:t>
+              <a:t>- Never change an existing</a:t>
             </a:r>
             <a:endParaRPr lang="en-US" sz="1650" dirty="0"/>
           </a:p>
@@ -22994,27 +23504,7 @@
                 <a:ea typeface="Consolas" pitchFamily="34" charset="-122"/>
                 <a:cs typeface="Consolas" pitchFamily="34" charset="-120"/>
               </a:rPr>
-              <a:t>- Never change an existing</a:t>
-            </a:r>
-            <a:endParaRPr lang="en-US" sz="1650" dirty="0"/>
-          </a:p>
-          <a:p>
-            <a:pPr algn="l" indent="0" marL="0">
-              <a:lnSpc>
-                <a:spcPct val="118000"/>
-              </a:lnSpc>
-              <a:buNone/>
-            </a:pPr>
-            <a:r>
-              <a:rPr lang="en-US" sz="1650" dirty="0">
-                <a:solidFill>
-                  <a:srgbClr val="D4D4D4"/>
-                </a:solidFill>
-                <a:latin typeface="Consolas" pitchFamily="34" charset="0"/>
-                <a:ea typeface="Consolas" pitchFamily="34" charset="-122"/>
-                <a:cs typeface="Consolas" pitchFamily="34" charset="-120"/>
-              </a:rPr>
-              <a:t xml:space="preserve">  result or test without asking.</a:t>
+              <a:t>  result or test without asking.</a:t>
             </a:r>
             <a:endParaRPr lang="en-US" sz="1650" dirty="0"/>
           </a:p>
@@ -23041,6 +23531,10 @@
           </a:solidFill>
           <a:ln/>
         </p:spPr>
+        <p:txBody>
+          <a:bodyPr/>
+          <a:p/>
+        </p:txBody>
       </p:sp>
       <p:sp xmlns:p="http://schemas.openxmlformats.org/presentationml/2006/main" xmlns:a="http://schemas.openxmlformats.org/drawingml/2006/main" xmlns:r="http://schemas.openxmlformats.org/officeDocument/2006/relationships">
         <p:nvSpPr>
@@ -23165,7 +23659,7 @@
                 <a:ea typeface="+mn-ea"/>
                 <a:cs typeface="+mn-cs"/>
               </a:rPr>
-              <a:t xml:space="preserve">In VS Code, create </a:t>
+              <a:t xml:space="preserve">In VS Code, open </a:t>
             </a:r>
             <a:r>
               <a:rPr lang="en-US" sz="1950" b="1" dirty="0">
@@ -23176,7 +23670,7 @@
                 <a:ea typeface="+mn-ea"/>
                 <a:cs typeface="+mn-cs"/>
               </a:rPr>
-              <a:t>CLAUDE.md</a:t>
+              <a:t>AGENTS.md</a:t>
             </a:r>
             <a:r>
               <a:rPr lang="en-US" sz="1950" dirty="0">
@@ -23187,7 +23681,7 @@
                 <a:ea typeface="+mn-ea"/>
                 <a:cs typeface="+mn-cs"/>
               </a:rPr>
-              <a:t xml:space="preserve"> at the repo root. Adapt the example to you.</a:t>
+              <a:t xml:space="preserve"> from Lesson 1. Extend it like the example, adapted to you.</a:t>
             </a:r>
             <a:endParaRPr lang="en-US" sz="1950" dirty="0"/>
           </a:p>
@@ -23275,7 +23769,7 @@
                 <a:ea typeface="+mn-ea"/>
                 <a:cs typeface="+mn-cs"/>
               </a:rPr>
-              <a:t xml:space="preserve">Line 2, </a:t>
+              <a:t xml:space="preserve">Keep the </a:t>
             </a:r>
             <a:r>
               <a:rPr lang="en-US" sz="1950" b="1" dirty="0">
@@ -23286,7 +23780,7 @@
                 <a:ea typeface="+mn-ea"/>
                 <a:cs typeface="+mn-cs"/>
               </a:rPr>
-              <a:t>@AGENTS.md</a:t>
+              <a:t>Environment and checks</a:t>
             </a:r>
             <a:r>
               <a:rPr lang="en-US" sz="1950" dirty="0">
@@ -23297,7 +23791,7 @@
                 <a:ea typeface="+mn-ea"/>
                 <a:cs typeface="+mn-cs"/>
               </a:rPr>
-              <a:t>, imports the rules you wrote in Lesson 1. One set of rules for every agent.</a:t>
+              <a:t> section: it tells Codex what it can’t verify.</a:t>
             </a:r>
             <a:endParaRPr lang="en-US" sz="1950" dirty="0"/>
           </a:p>
@@ -23396,7 +23890,7 @@
                 <a:ea typeface="+mn-ea"/>
                 <a:cs typeface="+mn-cs"/>
               </a:rPr>
-              <a:t>Add CLAUDE.md</a:t>
+              <a:t>Update AGENTS.md</a:t>
             </a:r>
             <a:r>
               <a:rPr lang="en-US" sz="1950" dirty="0">
@@ -23470,7 +23964,7 @@
                 <a:ea typeface="+mn-ea"/>
                 <a:cs typeface="+mn-cs"/>
               </a:rPr>
-              <a:t>Claude Code reads CLAUDE.md at the start of every session. Include what a new colleague would need.</a:t>
+              <a:t>Codex reads AGENTS.md at the start of every task. Include what a new colleague would need.</a:t>
             </a:r>
             <a:endParaRPr lang="en-US" sz="1800" dirty="0"/>
           </a:p>
@@ -23654,7 +24148,7 @@
           <a:p>
             <a:r>
               <a:rPr lang="en-US" dirty="0"/>
-              <a:t>Exercise 2: Open a Session</a:t>
+              <a:t>Exercise 2: Set Up Codex</a:t>
             </a:r>
             <a:endParaRPr lang="en-US" dirty="0"/>
           </a:p>
@@ -23684,6 +24178,10 @@
             <a:prstDash val="solid"/>
           </a:ln>
         </p:spPr>
+        <p:txBody>
+          <a:bodyPr/>
+          <a:p/>
+        </p:txBody>
       </p:sp>
       <p:sp xmlns:p="http://schemas.openxmlformats.org/presentationml/2006/main" xmlns:a="http://schemas.openxmlformats.org/drawingml/2006/main" xmlns:r="http://schemas.openxmlformats.org/officeDocument/2006/relationships">
         <p:nvSpPr>
@@ -23720,7 +24218,7 @@
                 <a:ea typeface="+mn-ea"/>
                 <a:cs typeface="+mn-cs"/>
               </a:rPr>
-              <a:t>Claude Code</a:t>
+              <a:t>Codex cloud</a:t>
             </a:r>
             <a:endParaRPr lang="en-US" sz="2250" dirty="0"/>
           </a:p>
@@ -23761,7 +24259,7 @@
                 <a:ea typeface="+mn-ea"/>
                 <a:cs typeface="+mn-cs"/>
               </a:rPr>
-              <a:t>cloud sandbox</a:t>
+              <a:t>cloud environment</a:t>
             </a:r>
             <a:endParaRPr lang="en-US" sz="1800" dirty="0"/>
           </a:p>
@@ -23786,6 +24284,10 @@
           </a:solidFill>
           <a:ln/>
         </p:spPr>
+        <p:txBody>
+          <a:bodyPr/>
+          <a:p/>
+        </p:txBody>
       </p:sp>
       <p:sp xmlns:p="http://schemas.openxmlformats.org/presentationml/2006/main" xmlns:a="http://schemas.openxmlformats.org/drawingml/2006/main" xmlns:r="http://schemas.openxmlformats.org/officeDocument/2006/relationships">
         <p:nvSpPr>
@@ -23811,6 +24313,10 @@
             <a:prstDash val="solid"/>
           </a:ln>
         </p:spPr>
+        <p:txBody>
+          <a:bodyPr/>
+          <a:p/>
+        </p:txBody>
       </p:sp>
       <p:sp xmlns:p="http://schemas.openxmlformats.org/presentationml/2006/main" xmlns:a="http://schemas.openxmlformats.org/drawingml/2006/main" xmlns:r="http://schemas.openxmlformats.org/officeDocument/2006/relationships">
         <p:nvSpPr>
@@ -23913,6 +24419,10 @@
           </a:solidFill>
           <a:ln/>
         </p:spPr>
+        <p:txBody>
+          <a:bodyPr/>
+          <a:p/>
+        </p:txBody>
       </p:sp>
       <p:sp xmlns:p="http://schemas.openxmlformats.org/presentationml/2006/main" xmlns:a="http://schemas.openxmlformats.org/drawingml/2006/main" xmlns:r="http://schemas.openxmlformats.org/officeDocument/2006/relationships">
         <p:nvSpPr>
@@ -23938,6 +24448,10 @@
             <a:prstDash val="solid"/>
           </a:ln>
         </p:spPr>
+        <p:txBody>
+          <a:bodyPr/>
+          <a:p/>
+        </p:txBody>
       </p:sp>
       <p:sp xmlns:p="http://schemas.openxmlformats.org/presentationml/2006/main" xmlns:a="http://schemas.openxmlformats.org/drawingml/2006/main" xmlns:r="http://schemas.openxmlformats.org/officeDocument/2006/relationships">
         <p:nvSpPr>
@@ -24056,7 +24570,7 @@
                 <a:ea typeface="+mn-ea"/>
                 <a:cs typeface="+mn-cs"/>
               </a:rPr>
-              <a:t>The session can read and change your repo. It cannot reach your laptop, your MATLAB license, or any file outside the repo.</a:t>
+              <a:t>A Codex task can read and change your repo. It cannot reach your laptop, your MATLAB license, or any file outside the repo.</a:t>
             </a:r>
             <a:endParaRPr lang="en-US" sz="1950" dirty="0"/>
           </a:p>
@@ -24083,6 +24597,10 @@
           </a:solidFill>
           <a:ln/>
         </p:spPr>
+        <p:txBody>
+          <a:bodyPr/>
+          <a:p/>
+        </p:txBody>
       </p:sp>
       <p:sp xmlns:p="http://schemas.openxmlformats.org/presentationml/2006/main" xmlns:a="http://schemas.openxmlformats.org/drawingml/2006/main" xmlns:r="http://schemas.openxmlformats.org/officeDocument/2006/relationships">
         <p:nvSpPr>
@@ -24218,7 +24736,7 @@
                 <a:ea typeface="+mn-ea"/>
                 <a:cs typeface="+mn-cs"/>
               </a:rPr>
-              <a:t>claude.ai/code</a:t>
+              <a:t>chatgpt.com/codex</a:t>
             </a:r>
             <a:r>
               <a:rPr lang="en-US" sz="1950" dirty="0">
@@ -24317,7 +24835,7 @@
                 <a:ea typeface="+mn-ea"/>
                 <a:cs typeface="+mn-cs"/>
               </a:rPr>
-              <a:t xml:space="preserve">Connect GitHub when prompted. Install the Claude GitHub App on </a:t>
+              <a:t xml:space="preserve">Connect GitHub when prompted. Give it access to </a:t>
             </a:r>
             <a:r>
               <a:rPr lang="en-US" sz="1950" b="1" dirty="0">
@@ -24427,7 +24945,7 @@
                 <a:ea typeface="+mn-ea"/>
                 <a:cs typeface="+mn-cs"/>
               </a:rPr>
-              <a:t xml:space="preserve">Accept the </a:t>
+              <a:t xml:space="preserve">Create an </a:t>
             </a:r>
             <a:r>
               <a:rPr lang="en-US" sz="1950" b="1" dirty="0">
@@ -24438,7 +24956,7 @@
                 <a:ea typeface="+mn-ea"/>
                 <a:cs typeface="+mn-cs"/>
               </a:rPr>
-              <a:t>Default</a:t>
+              <a:t>environment</a:t>
             </a:r>
             <a:r>
               <a:rPr lang="en-US" sz="1950" dirty="0">
@@ -24449,7 +24967,7 @@
                 <a:ea typeface="+mn-ea"/>
                 <a:cs typeface="+mn-cs"/>
               </a:rPr>
-              <a:t xml:space="preserve"> environment.</a:t>
+              <a:t xml:space="preserve"> for beam-calc. Leave agent internet access off.</a:t>
             </a:r>
             <a:endParaRPr lang="en-US" sz="1950" dirty="0"/>
           </a:p>
@@ -24537,7 +25055,7 @@
                 <a:ea typeface="+mn-ea"/>
                 <a:cs typeface="+mn-cs"/>
               </a:rPr>
-              <a:t xml:space="preserve">New session: select </a:t>
+              <a:t xml:space="preserve">Start a task on </a:t>
             </a:r>
             <a:r>
               <a:rPr lang="en-US" sz="1950" b="1" dirty="0">
@@ -24581,7 +25099,7 @@
                 <a:ea typeface="+mn-ea"/>
                 <a:cs typeface="+mn-cs"/>
               </a:rPr>
-              <a:t xml:space="preserve"> branch. The session clones the repo and loads CLAUDE.md.</a:t>
+              <a:t xml:space="preserve"> branch. Codex reads AGENTS.md automatically.</a:t>
             </a:r>
             <a:endParaRPr lang="en-US" sz="1950" dirty="0"/>
           </a:p>

</xml_diff>

<commit_message>
Formatting pass on Lessons 1-2 and the template; screenshot placeholders
Formatting (both decks and the template):
- sidebar highlight ends at the sidebar edge instead of bleeding past it
- Lesson 1 slide 5: push and fetch/pull arrows are real arrow connectors
  (the old arrowheads were small squares)
- every font size is a whole point (rounded; .5 rounds down)
- text boxes that ran past the slide edge end at the title rule

Screenshot placeholders: 7 in Lesson 1 and 5 in Lesson 2, each a gray
picture to swap with Change Picture, described in its alt text and the
slide notes. The template gains a 'Chip, Steps, and Picture' layout and
a sample slide.

Lesson 1 content: intro line and file-list caption on slide 9, a
'Why branch?' kicker on slide 13, a fuller pull-request kicker on slide
14, and why to set Git ignore on slide 19.

Co-Authored-By: Claude Opus 5.5 <noreply@anthropic.com>
Claude-Session: https://claude.ai/code/session_01EceYBcFXTaBjFSFEfqpJfg
</commit_message>
<xml_diff>
--- a/Lesson Material/LSN 2 - Introduction to Agentic AI for Coding/Agentic_AI_for_Engineering_Lesson_2.pptx
+++ b/Lesson Material/LSN 2 - Introduction to Agentic AI for Coding/Agentic_AI_for_Engineering_Lesson_2.pptx
@@ -583,6 +583,11 @@
               <a:t>The orientation prompt costs one message and tells you whether the agent understands the code. If the Codex interface offers an Ask (question-only) mode, use it here. A good answer names the formula, the units, the test, and its own limits. If the summary is wrong, fix AGENTS.md before going further.</a:t>
             </a:r>
           </a:p>
+          <a:p>
+            <a:r>
+              <a:t>Screenshot to add: Codex task showing the orientation prompt and the agent’s summary (Replace the gray placeholder: right-click › Change Picture › From a File.)</a:t>
+            </a:r>
+          </a:p>
         </p:txBody>
       </p:sp>
     </p:spTree>
@@ -700,6 +705,11 @@
               <a:t>Codex works on its own branch, never directly on main. Codex names the branch when you create the pull request, so yours will differ from codex/udl-deflection. Walk through the diff line by line. Look hardest at the test: an agent that writes both the code and its test can make them agree with each other and still be wrong. Here the expected value 2.40e-3 m comes from our hand calculation, not from the code. The ... in the fprintf lines is shortened for the slide.</a:t>
             </a:r>
           </a:p>
+          <a:p>
+            <a:r>
+              <a:t>Screenshot to add: Codex task diff view with the control that creates the pull request (Replace the gray placeholder: right-click › Change Picture › From a File.)</a:t>
+            </a:r>
+          </a:p>
         </p:txBody>
       </p:sp>
     </p:spTree>
@@ -758,6 +768,11 @@
               <a:t>Same branches and pull requests as Lesson 1, with the agent as the other contributor. Codex never commits to main. The pull request is where the review happens, and where the change is merged after the test passes. To get a fix onto the same pull request, comment on it with @codex and the request; Codex starts a task with the PR as context and can push to its branch. Follow-ups inside the original task may or may not update the PR, depending on the current Codex interface.</a:t>
             </a:r>
           </a:p>
+          <a:p>
+            <a:r>
+              <a:t>Screenshot to add: GitHub pull request for the codex/… branch: Files changed and the commit list (Replace the gray placeholder: right-click › Change Picture › From a File.)</a:t>
+            </a:r>
+          </a:p>
         </p:txBody>
       </p:sp>
     </p:spTree>
@@ -875,6 +890,11 @@
               <a:t>Failure reports should contain observations and logs, not just ‘it doesn’t work’. Commenting @codex on the pull request keeps the fix on the same branch and the discussion on the PR, where reviewers can see it. Asking for an explanation before a fix keeps the engineer in the loop and often exposes a wrong assumption (here, a section dimension entered in mm). One requirement per task keeps context small and commits easy to review.</a:t>
             </a:r>
           </a:p>
+          <a:p>
+            <a:r>
+              <a:t>Screenshot to add: GitHub pull request comment box with an @codex failure report (Replace the gray placeholder: right-click › Change Picture › From a File.)</a:t>
+            </a:r>
+          </a:p>
         </p:txBody>
       </p:sp>
     </p:spTree>
@@ -1751,6 +1771,11 @@
               <a:t>Emphasize the architecture: the agent never touches the laptop. GitHub is the hand-off point between the Codex cloud environment and your machine, which is why Lesson 1 spent so long on push, fetch, and pull. Grant the GitHub connection access to selected repositories only, not your whole account. The Codex interface changes often; check the labels before class, but the steps stay the same: sign in, connect GitHub, set up an environment for the repo, start a task.</a:t>
             </a:r>
           </a:p>
+          <a:p>
+            <a:r>
+              <a:t>Screenshot to add: Codex cloud: environment setup for beam-calc, repository selected and agent internet access off (Replace the gray placeholder: right-click › Change Picture › From a File.)</a:t>
+            </a:r>
+          </a:p>
         </p:txBody>
       </p:sp>
     </p:spTree>
@@ -2475,7 +2500,7 @@
               <a:buSzPct val="110000"/>
               <a:buFont typeface="+mj-lt"/>
               <a:buAutoNum type="arabicPlain"/>
-              <a:defRPr sz="2025"/>
+              <a:defRPr sz="2000"/>
             </a:lvl1pPr>
           </a:lstStyle>
           <a:p>
@@ -2661,7 +2686,7 @@
               <a:buSzPct val="110000"/>
               <a:buFont typeface="+mj-lt"/>
               <a:buAutoNum type="arabicPlain"/>
-              <a:defRPr sz="2025"/>
+              <a:defRPr sz="2000"/>
             </a:lvl1pPr>
           </a:lstStyle>
           <a:p>
@@ -2713,7 +2738,7 @@
                 <a:spcPts val="0"/>
               </a:spcAft>
               <a:buNone/>
-              <a:defRPr sz="1650">
+              <a:defRPr sz="1600">
                 <a:solidFill>
                   <a:srgbClr val="D4D4D4"/>
                 </a:solidFill>
@@ -3146,7 +3171,7 @@
         <p:spPr>
           <a:xfrm>
             <a:off x="133350" y="2381250"/>
-            <a:ext cx="1442184" cy="4191000"/>
+            <a:ext cx="1409700" cy="4191000"/>
           </a:xfrm>
           <a:prstGeom prst="rect">
             <a:avLst/>
@@ -3354,7 +3379,7 @@
         </a:buClr>
         <a:buFont typeface="Arial"/>
         <a:buChar char="•"/>
-        <a:defRPr sz="1950" kern="1200">
+        <a:defRPr sz="1900" kern="1200">
           <a:solidFill>
             <a:schemeClr val="tx1"/>
           </a:solidFill>
@@ -3907,7 +3932,7 @@
               <a:buNone/>
             </a:pPr>
             <a:r>
-              <a:rPr lang="en-US" sz="1950" dirty="0">
+              <a:rPr lang="en-US" sz="1900" dirty="0">
                 <a:solidFill>
                   <a:srgbClr val="000000"/>
                 </a:solidFill>
@@ -3917,7 +3942,7 @@
               </a:rPr>
               <a:t>Send an orientation prompt before asking for any change:</a:t>
             </a:r>
-            <a:endParaRPr lang="en-US" sz="1950" dirty="0"/>
+            <a:endParaRPr lang="en-US" sz="1900" dirty="0"/>
           </a:p>
         </p:txBody>
       </p:sp>
@@ -3974,7 +3999,7 @@
               <a:buNone/>
             </a:pPr>
             <a:r>
-              <a:rPr lang="en-US" sz="1650" b="1" dirty="0">
+              <a:rPr lang="en-US" sz="1600" b="1" dirty="0">
                 <a:solidFill>
                   <a:srgbClr val="1F6FB2"/>
                 </a:solidFill>
@@ -3984,7 +4009,7 @@
               </a:rPr>
               <a:t>YOU</a:t>
             </a:r>
-            <a:endParaRPr lang="en-US" sz="1650" dirty="0"/>
+            <a:endParaRPr lang="en-US" sz="1600" dirty="0"/>
           </a:p>
         </p:txBody>
       </p:sp>
@@ -4085,7 +4110,7 @@
               <a:buNone/>
             </a:pPr>
             <a:r>
-              <a:rPr lang="en-US" sz="1650" b="1" dirty="0">
+              <a:rPr lang="en-US" sz="1600" b="1" dirty="0">
                 <a:solidFill>
                   <a:srgbClr val="00B0F0"/>
                 </a:solidFill>
@@ -4095,7 +4120,7 @@
               </a:rPr>
               <a:t>AGENT</a:t>
             </a:r>
-            <a:endParaRPr lang="en-US" sz="1650" dirty="0"/>
+            <a:endParaRPr lang="en-US" sz="1600" dirty="0"/>
           </a:p>
         </p:txBody>
       </p:sp>
@@ -4170,7 +4195,7 @@
               <a:buNone/>
             </a:pPr>
             <a:r>
-              <a:rPr lang="en-US" sz="1950" b="1" dirty="0">
+              <a:rPr lang="en-US" sz="1900" b="1" dirty="0">
                 <a:solidFill>
                   <a:srgbClr val="000000"/>
                 </a:solidFill>
@@ -4180,7 +4205,7 @@
               </a:rPr>
               <a:t>Check the summary against the code. If the agent misunderstands the code now, its changes will be wrong too.</a:t>
             </a:r>
-            <a:endParaRPr lang="en-US" sz="1950" dirty="0"/>
+            <a:endParaRPr lang="en-US" sz="1900" dirty="0"/>
           </a:p>
         </p:txBody>
       </p:sp>
@@ -4193,7 +4218,7 @@
         <p:spPr>
           <a:xfrm>
             <a:off x="133350" y="3524250"/>
-            <a:ext cx="1442184" cy="381000"/>
+            <a:ext cx="1409700" cy="381000"/>
           </a:xfrm>
           <a:prstGeom prst="rect">
             <a:avLst/>
@@ -4279,6 +4304,30 @@
           </a:p>
         </p:txBody>
       </p:sp>
+      <p:pic>
+        <p:nvPicPr>
+          <p:cNvPr id="16" name="Screenshot placeholder" descr="Screenshot to add: Codex task showing the orientation prompt and the agent’s summary"/>
+          <p:cNvPicPr>
+            <a:picLocks noChangeAspect="1"/>
+          </p:cNvPicPr>
+          <p:nvPr/>
+        </p:nvPicPr>
+        <p:blipFill>
+          <a:blip r:embed="rId3"/>
+          <a:stretch>
+            <a:fillRect/>
+          </a:stretch>
+        </p:blipFill>
+        <p:spPr>
+          <a:xfrm>
+            <a:off x="1810512" y="7452360"/>
+            <a:ext cx="6949440" cy="2057400"/>
+          </a:xfrm>
+          <a:prstGeom prst="rect">
+            <a:avLst/>
+          </a:prstGeom>
+        </p:spPr>
+      </p:pic>
     </p:spTree>
   </p:cSld>
   <p:clrMapOvr>
@@ -4439,7 +4488,7 @@
               <a:buNone/>
             </a:pPr>
             <a:r>
-              <a:rPr lang="en-US" sz="1650" b="1" dirty="0">
+              <a:rPr lang="en-US" sz="1600" b="1" dirty="0">
                 <a:solidFill>
                   <a:srgbClr val="1F6FB2"/>
                 </a:solidFill>
@@ -4449,7 +4498,7 @@
               </a:rPr>
               <a:t>YOU</a:t>
             </a:r>
-            <a:endParaRPr lang="en-US" sz="1650" dirty="0"/>
+            <a:endParaRPr lang="en-US" sz="1600" dirty="0"/>
           </a:p>
         </p:txBody>
       </p:sp>
@@ -4566,7 +4615,7 @@
               <a:buNone/>
             </a:pPr>
             <a:r>
-              <a:rPr lang="en-US" sz="1650" b="1" dirty="0">
+              <a:rPr lang="en-US" sz="1600" b="1" dirty="0">
                 <a:solidFill>
                   <a:srgbClr val="00B0F0"/>
                 </a:solidFill>
@@ -4576,7 +4625,7 @@
               </a:rPr>
               <a:t>AGENT</a:t>
             </a:r>
-            <a:endParaRPr lang="en-US" sz="1650" dirty="0"/>
+            <a:endParaRPr lang="en-US" sz="1600" dirty="0"/>
           </a:p>
         </p:txBody>
       </p:sp>
@@ -4753,7 +4802,7 @@
               <a:buNone/>
             </a:pPr>
             <a:r>
-              <a:rPr lang="en-US" sz="1650" b="1" dirty="0">
+              <a:rPr lang="en-US" sz="1600" b="1" dirty="0">
                 <a:solidFill>
                   <a:srgbClr val="1F6FB2"/>
                 </a:solidFill>
@@ -4763,7 +4812,7 @@
               </a:rPr>
               <a:t>YOU</a:t>
             </a:r>
-            <a:endParaRPr lang="en-US" sz="1650" dirty="0"/>
+            <a:endParaRPr lang="en-US" sz="1600" dirty="0"/>
           </a:p>
         </p:txBody>
       </p:sp>
@@ -4861,7 +4910,7 @@
         <p:spPr>
           <a:xfrm>
             <a:off x="133350" y="3905250"/>
-            <a:ext cx="1442184" cy="381000"/>
+            <a:ext cx="1409700" cy="381000"/>
           </a:xfrm>
           <a:prstGeom prst="rect">
             <a:avLst/>
@@ -5482,7 +5531,7 @@
               <a:buNone/>
             </a:pPr>
             <a:r>
-              <a:rPr lang="en-US" sz="2250" b="1" dirty="0">
+              <a:rPr lang="en-US" sz="2200" b="1" dirty="0">
                 <a:solidFill>
                   <a:srgbClr val="1F6FB2"/>
                 </a:solidFill>
@@ -5492,7 +5541,7 @@
               </a:rPr>
               <a:t>1</a:t>
             </a:r>
-            <a:endParaRPr lang="en-US" sz="2250" dirty="0"/>
+            <a:endParaRPr lang="en-US" sz="2200" dirty="0"/>
           </a:p>
         </p:txBody>
       </p:sp>
@@ -5526,7 +5575,7 @@
               <a:buNone/>
             </a:pPr>
             <a:r>
-              <a:rPr lang="en-US" sz="1875" dirty="0">
+              <a:rPr lang="en-US" sz="1900" dirty="0">
                 <a:solidFill>
                   <a:srgbClr val="000000"/>
                 </a:solidFill>
@@ -5537,7 +5586,7 @@
               <a:t xml:space="preserve">Read every line. Green </a:t>
             </a:r>
             <a:r>
-              <a:rPr lang="en-US" sz="1875" b="1" dirty="0">
+              <a:rPr lang="en-US" sz="1900" b="1" dirty="0">
                 <a:solidFill>
                   <a:srgbClr val="000000"/>
                 </a:solidFill>
@@ -5548,7 +5597,7 @@
               <a:t>+</a:t>
             </a:r>
             <a:r>
-              <a:rPr lang="en-US" sz="1875" dirty="0">
+              <a:rPr lang="en-US" sz="1900" dirty="0">
                 <a:solidFill>
                   <a:srgbClr val="000000"/>
                 </a:solidFill>
@@ -5559,7 +5608,7 @@
               <a:t xml:space="preserve"> lines were added; red </a:t>
             </a:r>
             <a:r>
-              <a:rPr lang="en-US" sz="1875" b="1" dirty="0">
+              <a:rPr lang="en-US" sz="1900" b="1" dirty="0">
                 <a:solidFill>
                   <a:srgbClr val="000000"/>
                 </a:solidFill>
@@ -5570,7 +5619,7 @@
               <a:t>−</a:t>
             </a:r>
             <a:r>
-              <a:rPr lang="en-US" sz="1875" dirty="0">
+              <a:rPr lang="en-US" sz="1900" dirty="0">
                 <a:solidFill>
                   <a:srgbClr val="000000"/>
                 </a:solidFill>
@@ -5580,7 +5629,7 @@
               </a:rPr>
               <a:t xml:space="preserve"> lines were removed.</a:t>
             </a:r>
-            <a:endParaRPr lang="en-US" sz="1875" dirty="0"/>
+            <a:endParaRPr lang="en-US" sz="1900" dirty="0"/>
           </a:p>
         </p:txBody>
       </p:sp>
@@ -5614,7 +5663,7 @@
               <a:buNone/>
             </a:pPr>
             <a:r>
-              <a:rPr lang="en-US" sz="2250" b="1" dirty="0">
+              <a:rPr lang="en-US" sz="2200" b="1" dirty="0">
                 <a:solidFill>
                   <a:srgbClr val="1F6FB2"/>
                 </a:solidFill>
@@ -5624,7 +5673,7 @@
               </a:rPr>
               <a:t>2</a:t>
             </a:r>
-            <a:endParaRPr lang="en-US" sz="2250" dirty="0"/>
+            <a:endParaRPr lang="en-US" sz="2200" dirty="0"/>
           </a:p>
         </p:txBody>
       </p:sp>
@@ -5658,7 +5707,7 @@
               <a:buNone/>
             </a:pPr>
             <a:r>
-              <a:rPr lang="en-US" sz="1875" dirty="0">
+              <a:rPr lang="en-US" sz="1900" dirty="0">
                 <a:solidFill>
                   <a:srgbClr val="000000"/>
                 </a:solidFill>
@@ -5669,7 +5718,7 @@
               <a:t xml:space="preserve">Ask about anything unclear: </a:t>
             </a:r>
             <a:r>
-              <a:rPr lang="en-US" sz="1875" i="1" dirty="0">
+              <a:rPr lang="en-US" sz="1900" i="1" dirty="0">
                 <a:solidFill>
                   <a:srgbClr val="000000"/>
                 </a:solidFill>
@@ -5679,7 +5728,7 @@
               </a:rPr>
               <a:t>Why RelTol 1e-3?</a:t>
             </a:r>
-            <a:endParaRPr lang="en-US" sz="1875" dirty="0"/>
+            <a:endParaRPr lang="en-US" sz="1900" dirty="0"/>
           </a:p>
         </p:txBody>
       </p:sp>
@@ -5713,7 +5762,7 @@
               <a:buNone/>
             </a:pPr>
             <a:r>
-              <a:rPr lang="en-US" sz="2250" b="1" dirty="0">
+              <a:rPr lang="en-US" sz="2200" b="1" dirty="0">
                 <a:solidFill>
                   <a:srgbClr val="1F6FB2"/>
                 </a:solidFill>
@@ -5723,7 +5772,7 @@
               </a:rPr>
               <a:t>3</a:t>
             </a:r>
-            <a:endParaRPr lang="en-US" sz="2250" dirty="0"/>
+            <a:endParaRPr lang="en-US" sz="2200" dirty="0"/>
           </a:p>
         </p:txBody>
       </p:sp>
@@ -5757,7 +5806,7 @@
               <a:buNone/>
             </a:pPr>
             <a:r>
-              <a:rPr lang="en-US" sz="1875" dirty="0">
+              <a:rPr lang="en-US" sz="1900" dirty="0">
                 <a:solidFill>
                   <a:srgbClr val="000000"/>
                 </a:solidFill>
@@ -5768,7 +5817,7 @@
               <a:t xml:space="preserve">Create the </a:t>
             </a:r>
             <a:r>
-              <a:rPr lang="en-US" sz="1875" b="1" dirty="0">
+              <a:rPr lang="en-US" sz="1900" b="1" dirty="0">
                 <a:solidFill>
                   <a:srgbClr val="000000"/>
                 </a:solidFill>
@@ -5779,7 +5828,7 @@
               <a:t>pull request</a:t>
             </a:r>
             <a:r>
-              <a:rPr lang="en-US" sz="1875" dirty="0">
+              <a:rPr lang="en-US" sz="1900" dirty="0">
                 <a:solidFill>
                   <a:srgbClr val="000000"/>
                 </a:solidFill>
@@ -5789,7 +5838,7 @@
               </a:rPr>
               <a:t xml:space="preserve"> from the task.</a:t>
             </a:r>
-            <a:endParaRPr lang="en-US" sz="1875" dirty="0"/>
+            <a:endParaRPr lang="en-US" sz="1900" dirty="0"/>
           </a:p>
         </p:txBody>
       </p:sp>
@@ -5843,7 +5892,7 @@
         <p:spPr>
           <a:xfrm>
             <a:off x="133350" y="3905250"/>
-            <a:ext cx="1442184" cy="381000"/>
+            <a:ext cx="1409700" cy="381000"/>
           </a:xfrm>
           <a:prstGeom prst="rect">
             <a:avLst/>
@@ -5929,6 +5978,30 @@
           </a:p>
         </p:txBody>
       </p:sp>
+      <p:pic>
+        <p:nvPicPr>
+          <p:cNvPr id="17" name="Screenshot placeholder" descr="Screenshot to add: Codex task diff view with the control that creates the pull request"/>
+          <p:cNvPicPr>
+            <a:picLocks noChangeAspect="1"/>
+          </p:cNvPicPr>
+          <p:nvPr/>
+        </p:nvPicPr>
+        <p:blipFill>
+          <a:blip r:embed="rId3"/>
+          <a:stretch>
+            <a:fillRect/>
+          </a:stretch>
+        </p:blipFill>
+        <p:spPr>
+          <a:xfrm>
+            <a:off x="9646920" y="6720840"/>
+            <a:ext cx="3886200" cy="2697480"/>
+          </a:xfrm>
+          <a:prstGeom prst="rect">
+            <a:avLst/>
+          </a:prstGeom>
+        </p:spPr>
+      </p:pic>
     </p:spTree>
   </p:cSld>
   <p:clrMapOvr>
@@ -6129,7 +6202,7 @@
               <a:buNone/>
             </a:pPr>
             <a:r>
-              <a:rPr lang="en-US" sz="1650" b="1" dirty="0">
+              <a:rPr lang="en-US" sz="1600" b="1" dirty="0">
                 <a:solidFill>
                   <a:srgbClr val="000000"/>
                 </a:solidFill>
@@ -6139,7 +6212,7 @@
               </a:rPr>
               <a:t>Lesson 1 work</a:t>
             </a:r>
-            <a:endParaRPr lang="en-US" sz="1650" dirty="0"/>
+            <a:endParaRPr lang="en-US" sz="1600" dirty="0"/>
           </a:p>
         </p:txBody>
       </p:sp>
@@ -6240,7 +6313,7 @@
               <a:buNone/>
             </a:pPr>
             <a:r>
-              <a:rPr lang="en-US" sz="1650" b="1" dirty="0">
+              <a:rPr lang="en-US" sz="1600" b="1" dirty="0">
                 <a:solidFill>
                   <a:srgbClr val="000000"/>
                 </a:solidFill>
@@ -6250,7 +6323,7 @@
               </a:rPr>
               <a:t>Merge PR</a:t>
             </a:r>
-            <a:endParaRPr lang="en-US" sz="1650" dirty="0"/>
+            <a:endParaRPr lang="en-US" sz="1600" dirty="0"/>
           </a:p>
         </p:txBody>
       </p:sp>
@@ -6346,7 +6419,7 @@
               <a:buNone/>
             </a:pPr>
             <a:r>
-              <a:rPr lang="en-US" sz="1650" b="1" dirty="0">
+              <a:rPr lang="en-US" sz="1600" b="1" dirty="0">
                 <a:solidFill>
                   <a:srgbClr val="000000"/>
                 </a:solidFill>
@@ -6356,7 +6429,7 @@
               </a:rPr>
               <a:t>Add UDL deflection</a:t>
             </a:r>
-            <a:endParaRPr lang="en-US" sz="1650" dirty="0"/>
+            <a:endParaRPr lang="en-US" sz="1600" dirty="0"/>
           </a:p>
         </p:txBody>
       </p:sp>
@@ -6452,7 +6525,7 @@
               <a:buNone/>
             </a:pPr>
             <a:r>
-              <a:rPr lang="en-US" sz="1650" b="1" dirty="0">
+              <a:rPr lang="en-US" sz="1600" b="1" dirty="0">
                 <a:solidFill>
                   <a:srgbClr val="000000"/>
                 </a:solidFill>
@@ -6462,7 +6535,7 @@
               </a:rPr>
               <a:t>Fix test units</a:t>
             </a:r>
-            <a:endParaRPr lang="en-US" sz="1650" dirty="0"/>
+            <a:endParaRPr lang="en-US" sz="1600" dirty="0"/>
           </a:p>
         </p:txBody>
       </p:sp>
@@ -6660,7 +6733,7 @@
               <a:buNone/>
             </a:pPr>
             <a:r>
-              <a:rPr lang="en-US" sz="1875" dirty="0">
+              <a:rPr lang="en-US" sz="1900" dirty="0">
                 <a:solidFill>
                   <a:srgbClr val="000000"/>
                 </a:solidFill>
@@ -6670,7 +6743,7 @@
               </a:rPr>
               <a:t>Codex puts each task’s changes on their own codex/… branch when you create the pull request.</a:t>
             </a:r>
-            <a:endParaRPr lang="en-US" sz="1875" dirty="0"/>
+            <a:endParaRPr lang="en-US" sz="1900" dirty="0"/>
           </a:p>
           <a:p>
             <a:pPr algn="l" indent="0" marL="0">
@@ -6680,7 +6753,7 @@
               <a:buNone/>
             </a:pPr>
             <a:r>
-              <a:rPr lang="en-US" sz="1875" dirty="0">
+              <a:rPr lang="en-US" sz="1900" dirty="0">
                 <a:solidFill>
                   <a:srgbClr val="000000"/>
                 </a:solidFill>
@@ -6690,7 +6763,7 @@
               </a:rPr>
               <a:t>For fixes, ask in the task or comment @codex on the PR. main is unchanged until you merge.</a:t>
             </a:r>
-            <a:endParaRPr lang="en-US" sz="1875" dirty="0"/>
+            <a:endParaRPr lang="en-US" sz="1900" dirty="0"/>
           </a:p>
         </p:txBody>
       </p:sp>
@@ -6765,7 +6838,7 @@
               <a:buNone/>
             </a:pPr>
             <a:r>
-              <a:rPr lang="en-US" sz="2250" b="1" dirty="0">
+              <a:rPr lang="en-US" sz="2200" b="1" dirty="0">
                 <a:solidFill>
                   <a:srgbClr val="1F6FB2"/>
                 </a:solidFill>
@@ -6775,7 +6848,7 @@
               </a:rPr>
               <a:t>1</a:t>
             </a:r>
-            <a:endParaRPr lang="en-US" sz="2250" dirty="0"/>
+            <a:endParaRPr lang="en-US" sz="2200" dirty="0"/>
           </a:p>
         </p:txBody>
       </p:sp>
@@ -6809,7 +6882,7 @@
               <a:buNone/>
             </a:pPr>
             <a:r>
-              <a:rPr lang="en-US" sz="1875" dirty="0">
+              <a:rPr lang="en-US" sz="1900" dirty="0">
                 <a:solidFill>
                   <a:srgbClr val="000000"/>
                 </a:solidFill>
@@ -6820,7 +6893,7 @@
               <a:t xml:space="preserve">Create the </a:t>
             </a:r>
             <a:r>
-              <a:rPr lang="en-US" sz="1875" b="1" dirty="0">
+              <a:rPr lang="en-US" sz="1900" b="1" dirty="0">
                 <a:solidFill>
                   <a:srgbClr val="000000"/>
                 </a:solidFill>
@@ -6831,7 +6904,7 @@
               <a:t>pull request</a:t>
             </a:r>
             <a:r>
-              <a:rPr lang="en-US" sz="1875" dirty="0">
+              <a:rPr lang="en-US" sz="1900" dirty="0">
                 <a:solidFill>
                   <a:srgbClr val="000000"/>
                 </a:solidFill>
@@ -6841,7 +6914,7 @@
               </a:rPr>
               <a:t xml:space="preserve"> from the task.</a:t>
             </a:r>
-            <a:endParaRPr lang="en-US" sz="1875" dirty="0"/>
+            <a:endParaRPr lang="en-US" sz="1900" dirty="0"/>
           </a:p>
         </p:txBody>
       </p:sp>
@@ -6875,7 +6948,7 @@
               <a:buNone/>
             </a:pPr>
             <a:r>
-              <a:rPr lang="en-US" sz="2250" b="1" dirty="0">
+              <a:rPr lang="en-US" sz="2200" b="1" dirty="0">
                 <a:solidFill>
                   <a:srgbClr val="1F6FB2"/>
                 </a:solidFill>
@@ -6885,7 +6958,7 @@
               </a:rPr>
               <a:t>2</a:t>
             </a:r>
-            <a:endParaRPr lang="en-US" sz="2250" dirty="0"/>
+            <a:endParaRPr lang="en-US" sz="2200" dirty="0"/>
           </a:p>
         </p:txBody>
       </p:sp>
@@ -6919,7 +6992,7 @@
               <a:buNone/>
             </a:pPr>
             <a:r>
-              <a:rPr lang="en-US" sz="1875" dirty="0">
+              <a:rPr lang="en-US" sz="1900" dirty="0">
                 <a:solidFill>
                   <a:srgbClr val="000000"/>
                 </a:solidFill>
@@ -6930,7 +7003,7 @@
               <a:t xml:space="preserve">On GitHub, read </a:t>
             </a:r>
             <a:r>
-              <a:rPr lang="en-US" sz="1875" b="1" dirty="0">
+              <a:rPr lang="en-US" sz="1900" b="1" dirty="0">
                 <a:solidFill>
                   <a:srgbClr val="000000"/>
                 </a:solidFill>
@@ -6941,7 +7014,7 @@
               <a:t>Files changed</a:t>
             </a:r>
             <a:r>
-              <a:rPr lang="en-US" sz="1875" dirty="0">
+              <a:rPr lang="en-US" sz="1900" dirty="0">
                 <a:solidFill>
                   <a:srgbClr val="000000"/>
                 </a:solidFill>
@@ -6951,7 +7024,7 @@
               </a:rPr>
               <a:t>.</a:t>
             </a:r>
-            <a:endParaRPr lang="en-US" sz="1875" dirty="0"/>
+            <a:endParaRPr lang="en-US" sz="1900" dirty="0"/>
           </a:p>
         </p:txBody>
       </p:sp>
@@ -6985,7 +7058,7 @@
               <a:buNone/>
             </a:pPr>
             <a:r>
-              <a:rPr lang="en-US" sz="2250" b="1" dirty="0">
+              <a:rPr lang="en-US" sz="2200" b="1" dirty="0">
                 <a:solidFill>
                   <a:srgbClr val="1F6FB2"/>
                 </a:solidFill>
@@ -6995,7 +7068,7 @@
               </a:rPr>
               <a:t>3</a:t>
             </a:r>
-            <a:endParaRPr lang="en-US" sz="2250" dirty="0"/>
+            <a:endParaRPr lang="en-US" sz="2200" dirty="0"/>
           </a:p>
         </p:txBody>
       </p:sp>
@@ -7029,7 +7102,7 @@
               <a:buNone/>
             </a:pPr>
             <a:r>
-              <a:rPr lang="en-US" sz="1875" dirty="0">
+              <a:rPr lang="en-US" sz="1900" dirty="0">
                 <a:solidFill>
                   <a:srgbClr val="000000"/>
                 </a:solidFill>
@@ -7039,7 +7112,7 @@
               </a:rPr>
               <a:t>Test the branch yourself (next).</a:t>
             </a:r>
-            <a:endParaRPr lang="en-US" sz="1875" dirty="0"/>
+            <a:endParaRPr lang="en-US" sz="1900" dirty="0"/>
           </a:p>
         </p:txBody>
       </p:sp>
@@ -7073,7 +7146,7 @@
               <a:buNone/>
             </a:pPr>
             <a:r>
-              <a:rPr lang="en-US" sz="2250" b="1" dirty="0">
+              <a:rPr lang="en-US" sz="2200" b="1" dirty="0">
                 <a:solidFill>
                   <a:srgbClr val="1F6FB2"/>
                 </a:solidFill>
@@ -7083,7 +7156,7 @@
               </a:rPr>
               <a:t>4</a:t>
             </a:r>
-            <a:endParaRPr lang="en-US" sz="2250" dirty="0"/>
+            <a:endParaRPr lang="en-US" sz="2200" dirty="0"/>
           </a:p>
         </p:txBody>
       </p:sp>
@@ -7117,7 +7190,7 @@
               <a:buNone/>
             </a:pPr>
             <a:r>
-              <a:rPr lang="en-US" sz="1875" dirty="0">
+              <a:rPr lang="en-US" sz="1900" dirty="0">
                 <a:solidFill>
                   <a:srgbClr val="000000"/>
                 </a:solidFill>
@@ -7127,7 +7200,7 @@
               </a:rPr>
               <a:t>Merge only after it passes.</a:t>
             </a:r>
-            <a:endParaRPr lang="en-US" sz="1875" dirty="0"/>
+            <a:endParaRPr lang="en-US" sz="1900" dirty="0"/>
           </a:p>
         </p:txBody>
       </p:sp>
@@ -7140,7 +7213,7 @@
         <p:spPr>
           <a:xfrm>
             <a:off x="133350" y="3905250"/>
-            <a:ext cx="1442184" cy="381000"/>
+            <a:ext cx="1409700" cy="381000"/>
           </a:xfrm>
           <a:prstGeom prst="rect">
             <a:avLst/>
@@ -7226,6 +7299,30 @@
           </a:p>
         </p:txBody>
       </p:sp>
+      <p:pic>
+        <p:nvPicPr>
+          <p:cNvPr id="35" name="Screenshot placeholder" descr="Screenshot to add: GitHub pull request for the codex/… branch: Files changed and the commit list"/>
+          <p:cNvPicPr>
+            <a:picLocks noChangeAspect="1"/>
+          </p:cNvPicPr>
+          <p:nvPr/>
+        </p:nvPicPr>
+        <p:blipFill>
+          <a:blip r:embed="rId3"/>
+          <a:stretch>
+            <a:fillRect/>
+          </a:stretch>
+        </p:blipFill>
+        <p:spPr>
+          <a:xfrm>
+            <a:off x="1810512" y="6858000"/>
+            <a:ext cx="5669280" cy="2560320"/>
+          </a:xfrm>
+          <a:prstGeom prst="rect">
+            <a:avLst/>
+          </a:prstGeom>
+        </p:spPr>
+      </p:pic>
     </p:spTree>
   </p:cSld>
   <p:clrMapOvr>
@@ -7371,7 +7468,7 @@
               <a:buNone/>
             </a:pPr>
             <a:r>
-              <a:rPr lang="en-US" sz="2250" b="1" dirty="0">
+              <a:rPr lang="en-US" sz="2200" b="1" dirty="0">
                 <a:solidFill>
                   <a:srgbClr val="1F6FB2"/>
                 </a:solidFill>
@@ -7381,7 +7478,7 @@
               </a:rPr>
               <a:t>1</a:t>
             </a:r>
-            <a:endParaRPr lang="en-US" sz="2250" dirty="0"/>
+            <a:endParaRPr lang="en-US" sz="2200" dirty="0"/>
           </a:p>
         </p:txBody>
       </p:sp>
@@ -7415,7 +7512,7 @@
               <a:buNone/>
             </a:pPr>
             <a:r>
-              <a:rPr lang="en-US" sz="1950" dirty="0">
+              <a:rPr lang="en-US" sz="1900" dirty="0">
                 <a:solidFill>
                   <a:srgbClr val="000000"/>
                 </a:solidFill>
@@ -7426,7 +7523,7 @@
               <a:t xml:space="preserve">GitHub Desktop: </a:t>
             </a:r>
             <a:r>
-              <a:rPr lang="en-US" sz="1950" b="1" dirty="0">
+              <a:rPr lang="en-US" sz="1900" b="1" dirty="0">
                 <a:solidFill>
                   <a:srgbClr val="000000"/>
                 </a:solidFill>
@@ -7437,7 +7534,7 @@
               <a:t>Fetch origin</a:t>
             </a:r>
             <a:r>
-              <a:rPr lang="en-US" sz="1950" dirty="0">
+              <a:rPr lang="en-US" sz="1900" dirty="0">
                 <a:solidFill>
                   <a:srgbClr val="000000"/>
                 </a:solidFill>
@@ -7448,7 +7545,7 @@
               <a:t xml:space="preserve">, then switch Current branch to </a:t>
             </a:r>
             <a:r>
-              <a:rPr lang="en-US" sz="1950" b="1" dirty="0">
+              <a:rPr lang="en-US" sz="1900" b="1" dirty="0">
                 <a:solidFill>
                   <a:srgbClr val="000000"/>
                 </a:solidFill>
@@ -7459,7 +7556,7 @@
               <a:t>codex/udl-deflection</a:t>
             </a:r>
             <a:r>
-              <a:rPr lang="en-US" sz="1950" dirty="0">
+              <a:rPr lang="en-US" sz="1900" dirty="0">
                 <a:solidFill>
                   <a:srgbClr val="000000"/>
                 </a:solidFill>
@@ -7469,7 +7566,7 @@
               </a:rPr>
               <a:t>.</a:t>
             </a:r>
-            <a:endParaRPr lang="en-US" sz="1950" dirty="0"/>
+            <a:endParaRPr lang="en-US" sz="1900" dirty="0"/>
           </a:p>
         </p:txBody>
       </p:sp>
@@ -7503,7 +7600,7 @@
               <a:buNone/>
             </a:pPr>
             <a:r>
-              <a:rPr lang="en-US" sz="2250" b="1" dirty="0">
+              <a:rPr lang="en-US" sz="2200" b="1" dirty="0">
                 <a:solidFill>
                   <a:srgbClr val="1F6FB2"/>
                 </a:solidFill>
@@ -7513,7 +7610,7 @@
               </a:rPr>
               <a:t>2</a:t>
             </a:r>
-            <a:endParaRPr lang="en-US" sz="2250" dirty="0"/>
+            <a:endParaRPr lang="en-US" sz="2200" dirty="0"/>
           </a:p>
         </p:txBody>
       </p:sp>
@@ -7547,7 +7644,7 @@
               <a:buNone/>
             </a:pPr>
             <a:r>
-              <a:rPr lang="en-US" sz="1950" dirty="0">
+              <a:rPr lang="en-US" sz="1900" dirty="0">
                 <a:solidFill>
                   <a:srgbClr val="000000"/>
                 </a:solidFill>
@@ -7558,7 +7655,7 @@
               <a:t xml:space="preserve">MATLAB: open the repo folder. Run </a:t>
             </a:r>
             <a:r>
-              <a:rPr lang="en-US" sz="1950" dirty="0">
+              <a:rPr lang="en-US" sz="1900" dirty="0">
                 <a:solidFill>
                   <a:srgbClr val="000000"/>
                 </a:solidFill>
@@ -7569,7 +7666,7 @@
               <a:t>beam</a:t>
             </a:r>
             <a:r>
-              <a:rPr lang="en-US" sz="1950" dirty="0">
+              <a:rPr lang="en-US" sz="1900" dirty="0">
                 <a:solidFill>
                   <a:srgbClr val="000000"/>
                 </a:solidFill>
@@ -7580,7 +7677,7 @@
               <a:t xml:space="preserve">, then </a:t>
             </a:r>
             <a:r>
-              <a:rPr lang="en-US" sz="1950" dirty="0">
+              <a:rPr lang="en-US" sz="1900" dirty="0">
                 <a:solidFill>
                   <a:srgbClr val="000000"/>
                 </a:solidFill>
@@ -7591,7 +7688,7 @@
               <a:t>runtests('tests')</a:t>
             </a:r>
             <a:r>
-              <a:rPr lang="en-US" sz="1950" dirty="0">
+              <a:rPr lang="en-US" sz="1900" dirty="0">
                 <a:solidFill>
                   <a:srgbClr val="000000"/>
                 </a:solidFill>
@@ -7601,7 +7698,7 @@
               </a:rPr>
               <a:t>.</a:t>
             </a:r>
-            <a:endParaRPr lang="en-US" sz="1950" dirty="0"/>
+            <a:endParaRPr lang="en-US" sz="1900" dirty="0"/>
           </a:p>
         </p:txBody>
       </p:sp>
@@ -7635,7 +7732,7 @@
               <a:buNone/>
             </a:pPr>
             <a:r>
-              <a:rPr lang="en-US" sz="2250" b="1" dirty="0">
+              <a:rPr lang="en-US" sz="2200" b="1" dirty="0">
                 <a:solidFill>
                   <a:srgbClr val="1F6FB2"/>
                 </a:solidFill>
@@ -7645,7 +7742,7 @@
               </a:rPr>
               <a:t>3</a:t>
             </a:r>
-            <a:endParaRPr lang="en-US" sz="2250" dirty="0"/>
+            <a:endParaRPr lang="en-US" sz="2200" dirty="0"/>
           </a:p>
         </p:txBody>
       </p:sp>
@@ -7679,7 +7776,7 @@
               <a:buNone/>
             </a:pPr>
             <a:r>
-              <a:rPr lang="en-US" sz="1950" dirty="0">
+              <a:rPr lang="en-US" sz="1900" dirty="0">
                 <a:solidFill>
                   <a:srgbClr val="000000"/>
                 </a:solidFill>
@@ -7689,7 +7786,7 @@
               </a:rPr>
               <a:t>Check the result against your own hand calculation, not the agent’s.</a:t>
             </a:r>
-            <a:endParaRPr lang="en-US" sz="1950" dirty="0"/>
+            <a:endParaRPr lang="en-US" sz="1900" dirty="0"/>
           </a:p>
         </p:txBody>
       </p:sp>
@@ -7720,7 +7817,7 @@
               <a:buNone/>
             </a:pPr>
             <a:r>
-              <a:rPr lang="en-US" sz="1650" b="1" dirty="0">
+              <a:rPr lang="en-US" sz="1600" b="1" dirty="0">
                 <a:solidFill>
                   <a:srgbClr val="404040"/>
                 </a:solidFill>
@@ -7730,7 +7827,7 @@
               </a:rPr>
               <a:t>PASS CRITERIA (FROM THE REQUIREMENT)</a:t>
             </a:r>
-            <a:endParaRPr lang="en-US" sz="1650" dirty="0"/>
+            <a:endParaRPr lang="en-US" sz="1600" dirty="0"/>
           </a:p>
         </p:txBody>
       </p:sp>
@@ -7788,7 +7885,7 @@
               <a:buNone/>
             </a:pPr>
             <a:r>
-              <a:rPr lang="en-US" sz="1950" dirty="0">
+              <a:rPr lang="en-US" sz="1900" dirty="0">
                 <a:solidFill>
                   <a:srgbClr val="000000"/>
                 </a:solidFill>
@@ -7799,7 +7896,7 @@
               <a:t xml:space="preserve">All tests pass, including </a:t>
             </a:r>
             <a:r>
-              <a:rPr lang="en-US" sz="1950" b="1" dirty="0">
+              <a:rPr lang="en-US" sz="1900" b="1" dirty="0">
                 <a:solidFill>
                   <a:srgbClr val="000000"/>
                 </a:solidFill>
@@ -7810,7 +7907,7 @@
               <a:t>testUDLHandCalc</a:t>
             </a:r>
             <a:r>
-              <a:rPr lang="en-US" sz="1950" dirty="0">
+              <a:rPr lang="en-US" sz="1900" dirty="0">
                 <a:solidFill>
                   <a:srgbClr val="000000"/>
                 </a:solidFill>
@@ -7820,7 +7917,7 @@
               </a:rPr>
               <a:t>.</a:t>
             </a:r>
-            <a:endParaRPr lang="en-US" sz="1950" dirty="0"/>
+            <a:endParaRPr lang="en-US" sz="1900" dirty="0"/>
           </a:p>
         </p:txBody>
       </p:sp>
@@ -7902,7 +7999,7 @@
               <a:buNone/>
             </a:pPr>
             <a:r>
-              <a:rPr lang="en-US" sz="1950" dirty="0">
+              <a:rPr lang="en-US" sz="1900" dirty="0">
                 <a:solidFill>
                   <a:srgbClr val="000000"/>
                 </a:solidFill>
@@ -7913,7 +8010,7 @@
               <a:t xml:space="preserve">Hand check: w = 1000 N/m, L = 2.0 m, steel, 50 × 100 mm → </a:t>
             </a:r>
             <a:r>
-              <a:rPr lang="en-US" sz="1950" b="1" dirty="0">
+              <a:rPr lang="en-US" sz="1900" b="1" dirty="0">
                 <a:solidFill>
                   <a:srgbClr val="000000"/>
                 </a:solidFill>
@@ -7924,7 +8021,7 @@
               <a:t>δ = 2.40 mm</a:t>
             </a:r>
             <a:r>
-              <a:rPr lang="en-US" sz="1950" dirty="0">
+              <a:rPr lang="en-US" sz="1900" dirty="0">
                 <a:solidFill>
                   <a:srgbClr val="000000"/>
                 </a:solidFill>
@@ -7934,7 +8031,7 @@
               </a:rPr>
               <a:t>.</a:t>
             </a:r>
-            <a:endParaRPr lang="en-US" sz="1950" dirty="0"/>
+            <a:endParaRPr lang="en-US" sz="1900" dirty="0"/>
           </a:p>
         </p:txBody>
       </p:sp>
@@ -8016,7 +8113,7 @@
               <a:buNone/>
             </a:pPr>
             <a:r>
-              <a:rPr lang="en-US" sz="1950" dirty="0">
+              <a:rPr lang="en-US" sz="1900" dirty="0">
                 <a:solidFill>
                   <a:srgbClr val="000000"/>
                 </a:solidFill>
@@ -8027,7 +8124,7 @@
               <a:t xml:space="preserve">With P = wL, the distributed result is </a:t>
             </a:r>
             <a:r>
-              <a:rPr lang="en-US" sz="1950" b="1" dirty="0">
+              <a:rPr lang="en-US" sz="1900" b="1" dirty="0">
                 <a:solidFill>
                   <a:srgbClr val="000000"/>
                 </a:solidFill>
@@ -8038,7 +8135,7 @@
               <a:t>3/8</a:t>
             </a:r>
             <a:r>
-              <a:rPr lang="en-US" sz="1950" dirty="0">
+              <a:rPr lang="en-US" sz="1900" dirty="0">
                 <a:solidFill>
                   <a:srgbClr val="000000"/>
                 </a:solidFill>
@@ -8048,7 +8145,7 @@
               </a:rPr>
               <a:t xml:space="preserve"> of the point-load result.</a:t>
             </a:r>
-            <a:endParaRPr lang="en-US" sz="1950" dirty="0"/>
+            <a:endParaRPr lang="en-US" sz="1900" dirty="0"/>
           </a:p>
         </p:txBody>
       </p:sp>
@@ -8130,7 +8227,7 @@
               <a:buNone/>
             </a:pPr>
             <a:r>
-              <a:rPr lang="en-US" sz="1950" dirty="0">
+              <a:rPr lang="en-US" sz="1900" dirty="0">
                 <a:solidFill>
                   <a:srgbClr val="000000"/>
                 </a:solidFill>
@@ -8140,7 +8237,7 @@
               </a:rPr>
               <a:t>The point-load line prints the same value as on main.</a:t>
             </a:r>
-            <a:endParaRPr lang="en-US" sz="1950" dirty="0"/>
+            <a:endParaRPr lang="en-US" sz="1900" dirty="0"/>
           </a:p>
         </p:txBody>
       </p:sp>
@@ -8219,7 +8316,7 @@
               <a:buNone/>
             </a:pPr>
             <a:r>
-              <a:rPr lang="en-US" sz="2025" b="1" dirty="0">
+              <a:rPr lang="en-US" sz="2000" b="1" dirty="0">
                 <a:solidFill>
                   <a:srgbClr val="FFFFFF"/>
                 </a:solidFill>
@@ -8229,7 +8326,7 @@
               </a:rPr>
               <a:t>Until you run it, the agent’s commit is a proposal.</a:t>
             </a:r>
-            <a:endParaRPr lang="en-US" sz="2025" dirty="0"/>
+            <a:endParaRPr lang="en-US" sz="2000" dirty="0"/>
           </a:p>
         </p:txBody>
       </p:sp>
@@ -8242,7 +8339,7 @@
         <p:spPr>
           <a:xfrm>
             <a:off x="133350" y="4286250"/>
-            <a:ext cx="1442184" cy="381000"/>
+            <a:ext cx="1409700" cy="381000"/>
           </a:xfrm>
           <a:prstGeom prst="rect">
             <a:avLst/>
@@ -8511,7 +8608,7 @@
               <a:buNone/>
             </a:pPr>
             <a:r>
-              <a:rPr lang="en-US" sz="1875" dirty="0">
+              <a:rPr lang="en-US" sz="1900" dirty="0">
                 <a:solidFill>
                   <a:srgbClr val="000000"/>
                 </a:solidFill>
@@ -8521,7 +8618,7 @@
               </a:rPr>
               <a:t>Comment @codex on the PR with what you saw.</a:t>
             </a:r>
-            <a:endParaRPr lang="en-US" sz="1875" dirty="0"/>
+            <a:endParaRPr lang="en-US" sz="1900" dirty="0"/>
           </a:p>
         </p:txBody>
       </p:sp>
@@ -8578,7 +8675,7 @@
               <a:buNone/>
             </a:pPr>
             <a:r>
-              <a:rPr lang="en-US" sz="1650" b="1" dirty="0">
+              <a:rPr lang="en-US" sz="1600" b="1" dirty="0">
                 <a:solidFill>
                   <a:srgbClr val="1F6FB2"/>
                 </a:solidFill>
@@ -8588,7 +8685,7 @@
               </a:rPr>
               <a:t>YOU</a:t>
             </a:r>
-            <a:endParaRPr lang="en-US" sz="1650" dirty="0"/>
+            <a:endParaRPr lang="en-US" sz="1600" dirty="0"/>
           </a:p>
         </p:txBody>
       </p:sp>
@@ -8622,7 +8719,7 @@
               <a:buNone/>
             </a:pPr>
             <a:r>
-              <a:rPr lang="en-US" sz="1725" dirty="0">
+              <a:rPr lang="en-US" sz="1700" dirty="0">
                 <a:solidFill>
                   <a:srgbClr val="000000"/>
                 </a:solidFill>
@@ -8632,7 +8729,7 @@
               </a:rPr>
               <a:t>@codex testUDLHandCalc fails: expected 2.4000e-03, got 2.4000e-06. Output below. Find the cause and explain it before changing code.</a:t>
             </a:r>
-            <a:endParaRPr lang="en-US" sz="1725" dirty="0"/>
+            <a:endParaRPr lang="en-US" sz="1700" dirty="0"/>
           </a:p>
           <a:p>
             <a:pPr algn="l" indent="0" marL="0">
@@ -8642,7 +8739,7 @@
               <a:buNone/>
             </a:pPr>
             <a:r>
-              <a:rPr lang="en-US" sz="1725" dirty="0">
+              <a:rPr lang="en-US" sz="1700" dirty="0">
                 <a:solidFill>
                   <a:srgbClr val="404040"/>
                 </a:solidFill>
@@ -8652,7 +8749,7 @@
               </a:rPr>
               <a:t>[paste MATLAB output]</a:t>
             </a:r>
-            <a:endParaRPr lang="en-US" sz="1725" dirty="0"/>
+            <a:endParaRPr lang="en-US" sz="1700" dirty="0"/>
           </a:p>
         </p:txBody>
       </p:sp>
@@ -8683,7 +8780,7 @@
               <a:buNone/>
             </a:pPr>
             <a:r>
-              <a:rPr lang="en-US" sz="1875" dirty="0">
+              <a:rPr lang="en-US" sz="1900" dirty="0">
                 <a:solidFill>
                   <a:srgbClr val="404040"/>
                 </a:solidFill>
@@ -8693,7 +8790,7 @@
               </a:rPr>
               <a:t>Codex pushes a fix to the PR’s branch. Fetch, rerun, retest.</a:t>
             </a:r>
-            <a:endParaRPr lang="en-US" sz="1875" dirty="0"/>
+            <a:endParaRPr lang="en-US" sz="1900" dirty="0"/>
           </a:p>
         </p:txBody>
       </p:sp>
@@ -8768,7 +8865,7 @@
               <a:buNone/>
             </a:pPr>
             <a:r>
-              <a:rPr lang="en-US" sz="2250" b="1" dirty="0">
+              <a:rPr lang="en-US" sz="2200" b="1" dirty="0">
                 <a:solidFill>
                   <a:srgbClr val="1F6FB2"/>
                 </a:solidFill>
@@ -8778,7 +8875,7 @@
               </a:rPr>
               <a:t>1</a:t>
             </a:r>
-            <a:endParaRPr lang="en-US" sz="2250" dirty="0"/>
+            <a:endParaRPr lang="en-US" sz="2200" dirty="0"/>
           </a:p>
         </p:txBody>
       </p:sp>
@@ -8812,7 +8909,7 @@
               <a:buNone/>
             </a:pPr>
             <a:r>
-              <a:rPr lang="en-US" sz="1875" dirty="0">
+              <a:rPr lang="en-US" sz="1900" dirty="0">
                 <a:solidFill>
                   <a:srgbClr val="000000"/>
                 </a:solidFill>
@@ -8822,7 +8919,7 @@
               </a:rPr>
               <a:t>Merge the PR on GitHub.</a:t>
             </a:r>
-            <a:endParaRPr lang="en-US" sz="1875" dirty="0"/>
+            <a:endParaRPr lang="en-US" sz="1900" dirty="0"/>
           </a:p>
         </p:txBody>
       </p:sp>
@@ -8856,7 +8953,7 @@
               <a:buNone/>
             </a:pPr>
             <a:r>
-              <a:rPr lang="en-US" sz="2250" b="1" dirty="0">
+              <a:rPr lang="en-US" sz="2200" b="1" dirty="0">
                 <a:solidFill>
                   <a:srgbClr val="1F6FB2"/>
                 </a:solidFill>
@@ -8866,7 +8963,7 @@
               </a:rPr>
               <a:t>2</a:t>
             </a:r>
-            <a:endParaRPr lang="en-US" sz="2250" dirty="0"/>
+            <a:endParaRPr lang="en-US" sz="2200" dirty="0"/>
           </a:p>
         </p:txBody>
       </p:sp>
@@ -8900,7 +8997,7 @@
               <a:buNone/>
             </a:pPr>
             <a:r>
-              <a:rPr lang="en-US" sz="1875" dirty="0">
+              <a:rPr lang="en-US" sz="1900" dirty="0">
                 <a:solidFill>
                   <a:srgbClr val="000000"/>
                 </a:solidFill>
@@ -8911,7 +9008,7 @@
               <a:t xml:space="preserve">GitHub Desktop: switch to main, </a:t>
             </a:r>
             <a:r>
-              <a:rPr lang="en-US" sz="1875" b="1" dirty="0">
+              <a:rPr lang="en-US" sz="1900" b="1" dirty="0">
                 <a:solidFill>
                   <a:srgbClr val="000000"/>
                 </a:solidFill>
@@ -8922,7 +9019,7 @@
               <a:t>Pull origin</a:t>
             </a:r>
             <a:r>
-              <a:rPr lang="en-US" sz="1875" dirty="0">
+              <a:rPr lang="en-US" sz="1900" dirty="0">
                 <a:solidFill>
                   <a:srgbClr val="000000"/>
                 </a:solidFill>
@@ -8932,7 +9029,7 @@
               </a:rPr>
               <a:t>.</a:t>
             </a:r>
-            <a:endParaRPr lang="en-US" sz="1875" dirty="0"/>
+            <a:endParaRPr lang="en-US" sz="1900" dirty="0"/>
           </a:p>
         </p:txBody>
       </p:sp>
@@ -8966,7 +9063,7 @@
               <a:buNone/>
             </a:pPr>
             <a:r>
-              <a:rPr lang="en-US" sz="2250" b="1" dirty="0">
+              <a:rPr lang="en-US" sz="2200" b="1" dirty="0">
                 <a:solidFill>
                   <a:srgbClr val="1F6FB2"/>
                 </a:solidFill>
@@ -8976,7 +9073,7 @@
               </a:rPr>
               <a:t>3</a:t>
             </a:r>
-            <a:endParaRPr lang="en-US" sz="2250" dirty="0"/>
+            <a:endParaRPr lang="en-US" sz="2200" dirty="0"/>
           </a:p>
         </p:txBody>
       </p:sp>
@@ -9010,7 +9107,7 @@
               <a:buNone/>
             </a:pPr>
             <a:r>
-              <a:rPr lang="en-US" sz="1875" dirty="0">
+              <a:rPr lang="en-US" sz="1900" dirty="0">
                 <a:solidFill>
                   <a:srgbClr val="000000"/>
                 </a:solidFill>
@@ -9020,7 +9117,7 @@
               </a:rPr>
               <a:t>Start a new task for the next requirement.</a:t>
             </a:r>
-            <a:endParaRPr lang="en-US" sz="1875" dirty="0"/>
+            <a:endParaRPr lang="en-US" sz="1900" dirty="0"/>
           </a:p>
         </p:txBody>
       </p:sp>
@@ -9054,7 +9151,7 @@
               <a:buNone/>
             </a:pPr>
             <a:r>
-              <a:rPr lang="en-US" sz="2250" b="1" dirty="0">
+              <a:rPr lang="en-US" sz="2200" b="1" dirty="0">
                 <a:solidFill>
                   <a:srgbClr val="1F6FB2"/>
                 </a:solidFill>
@@ -9064,7 +9161,7 @@
               </a:rPr>
               <a:t>4</a:t>
             </a:r>
-            <a:endParaRPr lang="en-US" sz="2250" dirty="0"/>
+            <a:endParaRPr lang="en-US" sz="2200" dirty="0"/>
           </a:p>
         </p:txBody>
       </p:sp>
@@ -9098,7 +9195,7 @@
               <a:buNone/>
             </a:pPr>
             <a:r>
-              <a:rPr lang="en-US" sz="1875" dirty="0">
+              <a:rPr lang="en-US" sz="1900" dirty="0">
                 <a:solidFill>
                   <a:srgbClr val="000000"/>
                 </a:solidFill>
@@ -9108,7 +9205,7 @@
               </a:rPr>
               <a:t>Add a rule to AGENTS.md for any mistake the agent made twice.</a:t>
             </a:r>
-            <a:endParaRPr lang="en-US" sz="1875" dirty="0"/>
+            <a:endParaRPr lang="en-US" sz="1900" dirty="0"/>
           </a:p>
         </p:txBody>
       </p:sp>
@@ -9121,7 +9218,7 @@
         <p:spPr>
           <a:xfrm>
             <a:off x="133350" y="4286250"/>
-            <a:ext cx="1442184" cy="381000"/>
+            <a:ext cx="1409700" cy="381000"/>
           </a:xfrm>
           <a:prstGeom prst="rect">
             <a:avLst/>
@@ -9207,6 +9304,30 @@
           </a:p>
         </p:txBody>
       </p:sp>
+      <p:pic>
+        <p:nvPicPr>
+          <p:cNvPr id="23" name="Screenshot placeholder" descr="Screenshot to add: GitHub pull request comment box with an @codex failure report"/>
+          <p:cNvPicPr>
+            <a:picLocks noChangeAspect="1"/>
+          </p:cNvPicPr>
+          <p:nvPr/>
+        </p:nvPicPr>
+        <p:blipFill>
+          <a:blip r:embed="rId3"/>
+          <a:stretch>
+            <a:fillRect/>
+          </a:stretch>
+        </p:blipFill>
+        <p:spPr>
+          <a:xfrm>
+            <a:off x="1810512" y="6812280"/>
+            <a:ext cx="5852160" cy="2606040"/>
+          </a:xfrm>
+          <a:prstGeom prst="rect">
+            <a:avLst/>
+          </a:prstGeom>
+        </p:spPr>
+      </p:pic>
     </p:spTree>
   </p:cSld>
   <p:clrMapOvr>
@@ -10545,7 +10666,7 @@
         <p:spPr>
           <a:xfrm>
             <a:off x="133350" y="4667250"/>
-            <a:ext cx="1442184" cy="381000"/>
+            <a:ext cx="1409700" cy="381000"/>
           </a:xfrm>
           <a:prstGeom prst="rect">
             <a:avLst/>
@@ -10706,7 +10827,7 @@
               <a:buNone/>
             </a:pPr>
             <a:r>
-              <a:rPr lang="en-US" sz="2025" dirty="0">
+              <a:rPr lang="en-US" sz="2000" dirty="0">
                 <a:solidFill>
                   <a:srgbClr val="000000"/>
                 </a:solidFill>
@@ -10716,7 +10837,7 @@
               </a:rPr>
               <a:t>Model the documentation you require of cadets. Follow current USAFA and department guidance for your course.</a:t>
             </a:r>
-            <a:endParaRPr lang="en-US" sz="2025" dirty="0"/>
+            <a:endParaRPr lang="en-US" sz="2000" dirty="0"/>
           </a:p>
         </p:txBody>
       </p:sp>
@@ -10747,7 +10868,7 @@
               <a:buNone/>
             </a:pPr>
             <a:r>
-              <a:rPr lang="en-US" sz="2025" dirty="0">
+              <a:rPr lang="en-US" sz="2000" dirty="0">
                 <a:solidFill>
                   <a:srgbClr val="000000"/>
                 </a:solidFill>
@@ -10758,7 +10879,7 @@
               <a:t xml:space="preserve">Keep an </a:t>
             </a:r>
             <a:r>
-              <a:rPr lang="en-US" sz="2025" b="1" dirty="0">
+              <a:rPr lang="en-US" sz="2000" b="1" dirty="0">
                 <a:solidFill>
                   <a:srgbClr val="000000"/>
                 </a:solidFill>
@@ -10769,7 +10890,7 @@
               <a:t>AI_LOG.md</a:t>
             </a:r>
             <a:r>
-              <a:rPr lang="en-US" sz="2025" dirty="0">
+              <a:rPr lang="en-US" sz="2000" dirty="0">
                 <a:solidFill>
                   <a:srgbClr val="000000"/>
                 </a:solidFill>
@@ -10779,7 +10900,7 @@
               </a:rPr>
               <a:t xml:space="preserve"> in the repo, with one entry per task:</a:t>
             </a:r>
-            <a:endParaRPr lang="en-US" sz="2025" dirty="0"/>
+            <a:endParaRPr lang="en-US" sz="2000" dirty="0"/>
           </a:p>
         </p:txBody>
       </p:sp>
@@ -10839,7 +10960,7 @@
               <a:buNone/>
             </a:pPr>
             <a:r>
-              <a:rPr lang="en-US" sz="1725" dirty="0">
+              <a:rPr lang="en-US" sz="1700" dirty="0">
                 <a:solidFill>
                   <a:srgbClr val="00B0F0"/>
                 </a:solidFill>
@@ -10849,7 +10970,7 @@
               </a:rPr>
               <a:t>## 2026-10-14 · UDL tip deflection</a:t>
             </a:r>
-            <a:endParaRPr lang="en-US" sz="1725" dirty="0"/>
+            <a:endParaRPr lang="en-US" sz="1700" dirty="0"/>
           </a:p>
           <a:p>
             <a:pPr algn="l" indent="0" marL="0">
@@ -10859,7 +10980,7 @@
               <a:buNone/>
             </a:pPr>
             <a:r>
-              <a:rPr lang="en-US" sz="1725" dirty="0">
+              <a:rPr lang="en-US" sz="1700" dirty="0">
                 <a:solidFill>
                   <a:srgbClr val="D4D4D4"/>
                 </a:solidFill>
@@ -10869,7 +10990,7 @@
               </a:rPr>
               <a:t>Task:         chatgpt.com/codex link</a:t>
             </a:r>
-            <a:endParaRPr lang="en-US" sz="1725" dirty="0"/>
+            <a:endParaRPr lang="en-US" sz="1700" dirty="0"/>
           </a:p>
           <a:p>
             <a:pPr algn="l" indent="0" marL="0">
@@ -10879,7 +11000,7 @@
               <a:buNone/>
             </a:pPr>
             <a:r>
-              <a:rPr lang="en-US" sz="1725" dirty="0">
+              <a:rPr lang="en-US" sz="1700" dirty="0">
                 <a:solidFill>
                   <a:srgbClr val="D4D4D4"/>
                 </a:solidFill>
@@ -10889,7 +11010,7 @@
               </a:rPr>
               <a:t>Prompts:      orientation, plan, implement, fix test units</a:t>
             </a:r>
-            <a:endParaRPr lang="en-US" sz="1725" dirty="0"/>
+            <a:endParaRPr lang="en-US" sz="1700" dirty="0"/>
           </a:p>
           <a:p>
             <a:pPr algn="l" indent="0" marL="0">
@@ -10899,7 +11020,7 @@
               <a:buNone/>
             </a:pPr>
             <a:r>
-              <a:rPr lang="en-US" sz="1725" dirty="0">
+              <a:rPr lang="en-US" sz="1700" dirty="0">
                 <a:solidFill>
                   <a:srgbClr val="D4D4D4"/>
                 </a:solidFill>
@@ -10909,7 +11030,7 @@
               </a:rPr>
               <a:t>Agent made:   commits a1b2c3d, e4f5a6b (PR #2)</a:t>
             </a:r>
-            <a:endParaRPr lang="en-US" sz="1725" dirty="0"/>
+            <a:endParaRPr lang="en-US" sz="1700" dirty="0"/>
           </a:p>
           <a:p>
             <a:pPr algn="l" indent="0" marL="0">
@@ -10919,7 +11040,7 @@
               <a:buNone/>
             </a:pPr>
             <a:r>
-              <a:rPr lang="en-US" sz="1725" dirty="0">
+              <a:rPr lang="en-US" sz="1700" dirty="0">
                 <a:solidFill>
                   <a:srgbClr val="D4D4D4"/>
                 </a:solidFill>
@@ -10929,7 +11050,7 @@
               </a:rPr>
               <a:t>I decided:    load acts over the full length</a:t>
             </a:r>
-            <a:endParaRPr lang="en-US" sz="1725" dirty="0"/>
+            <a:endParaRPr lang="en-US" sz="1700" dirty="0"/>
           </a:p>
           <a:p>
             <a:pPr algn="l" indent="0" marL="0">
@@ -10939,7 +11060,7 @@
               <a:buNone/>
             </a:pPr>
             <a:r>
-              <a:rPr lang="en-US" sz="1725" dirty="0">
+              <a:rPr lang="en-US" sz="1700" dirty="0">
                 <a:solidFill>
                   <a:srgbClr val="D4D4D4"/>
                 </a:solidFill>
@@ -10949,7 +11070,7 @@
               </a:rPr>
               <a:t>Verified:     runtests passes; hand calc 2.40 mm; 3/8 ratio</a:t>
             </a:r>
-            <a:endParaRPr lang="en-US" sz="1725" dirty="0"/>
+            <a:endParaRPr lang="en-US" sz="1700" dirty="0"/>
           </a:p>
           <a:p>
             <a:pPr algn="l" indent="0" marL="0">
@@ -10959,7 +11080,7 @@
               <a:buNone/>
             </a:pPr>
             <a:r>
-              <a:rPr lang="en-US" sz="1725" dirty="0">
+              <a:rPr lang="en-US" sz="1700" dirty="0">
                 <a:solidFill>
                   <a:srgbClr val="D4D4D4"/>
                 </a:solidFill>
@@ -10969,7 +11090,7 @@
               </a:rPr>
               <a:t>Issue found:  test section entered in mm on first try</a:t>
             </a:r>
-            <a:endParaRPr lang="en-US" sz="1725" dirty="0"/>
+            <a:endParaRPr lang="en-US" sz="1700" dirty="0"/>
           </a:p>
         </p:txBody>
       </p:sp>
@@ -11000,7 +11121,7 @@
               <a:buNone/>
             </a:pPr>
             <a:r>
-              <a:rPr lang="en-US" sz="1950" dirty="0">
+              <a:rPr lang="en-US" sz="1900" dirty="0">
                 <a:solidFill>
                   <a:srgbClr val="404040"/>
                 </a:solidFill>
@@ -11010,7 +11131,7 @@
               </a:rPr>
               <a:t>The commit history and PR discussion are also part of the record.</a:t>
             </a:r>
-            <a:endParaRPr lang="en-US" sz="1950" dirty="0"/>
+            <a:endParaRPr lang="en-US" sz="1900" dirty="0"/>
           </a:p>
         </p:txBody>
       </p:sp>
@@ -11023,7 +11144,7 @@
         <p:spPr>
           <a:xfrm>
             <a:off x="133350" y="5048250"/>
-            <a:ext cx="1442184" cy="381000"/>
+            <a:ext cx="1409700" cy="381000"/>
           </a:xfrm>
           <a:prstGeom prst="rect">
             <a:avLst/>
@@ -11254,7 +11375,7 @@
               <a:buNone/>
             </a:pPr>
             <a:r>
-              <a:rPr lang="en-US" sz="2250" b="1" dirty="0">
+              <a:rPr lang="en-US" sz="2200" b="1" dirty="0">
                 <a:solidFill>
                   <a:srgbClr val="1F6FB2"/>
                 </a:solidFill>
@@ -11264,7 +11385,7 @@
               </a:rPr>
               <a:t>1</a:t>
             </a:r>
-            <a:endParaRPr lang="en-US" sz="2250" dirty="0"/>
+            <a:endParaRPr lang="en-US" sz="2200" dirty="0"/>
           </a:p>
         </p:txBody>
       </p:sp>
@@ -11298,7 +11419,7 @@
               <a:buNone/>
             </a:pPr>
             <a:r>
-              <a:rPr lang="en-US" sz="1950" dirty="0">
+              <a:rPr lang="en-US" sz="1900" dirty="0">
                 <a:solidFill>
                   <a:srgbClr val="000000"/>
                 </a:solidFill>
@@ -11308,7 +11429,7 @@
               </a:rPr>
               <a:t>Open your Agent-Ready repo from Lesson 1.</a:t>
             </a:r>
-            <a:endParaRPr lang="en-US" sz="1950" dirty="0"/>
+            <a:endParaRPr lang="en-US" sz="1900" dirty="0"/>
           </a:p>
         </p:txBody>
       </p:sp>
@@ -11342,7 +11463,7 @@
               <a:buNone/>
             </a:pPr>
             <a:r>
-              <a:rPr lang="en-US" sz="2250" b="1" dirty="0">
+              <a:rPr lang="en-US" sz="2200" b="1" dirty="0">
                 <a:solidFill>
                   <a:srgbClr val="1F6FB2"/>
                 </a:solidFill>
@@ -11352,7 +11473,7 @@
               </a:rPr>
               <a:t>2</a:t>
             </a:r>
-            <a:endParaRPr lang="en-US" sz="2250" dirty="0"/>
+            <a:endParaRPr lang="en-US" sz="2200" dirty="0"/>
           </a:p>
         </p:txBody>
       </p:sp>
@@ -11386,7 +11507,7 @@
               <a:buNone/>
             </a:pPr>
             <a:r>
-              <a:rPr lang="en-US" sz="1950" dirty="0">
+              <a:rPr lang="en-US" sz="1900" dirty="0">
                 <a:solidFill>
                   <a:srgbClr val="000000"/>
                 </a:solidFill>
@@ -11397,7 +11518,7 @@
               <a:t xml:space="preserve">Write one small requirement </a:t>
             </a:r>
             <a:r>
-              <a:rPr lang="en-US" sz="1950" b="1" dirty="0">
+              <a:rPr lang="en-US" sz="1900" b="1" dirty="0">
                 <a:solidFill>
                   <a:srgbClr val="000000"/>
                 </a:solidFill>
@@ -11408,7 +11529,7 @@
               <a:t>and how you’ll verify it</a:t>
             </a:r>
             <a:r>
-              <a:rPr lang="en-US" sz="1950" dirty="0">
+              <a:rPr lang="en-US" sz="1900" dirty="0">
                 <a:solidFill>
                   <a:srgbClr val="000000"/>
                 </a:solidFill>
@@ -11418,7 +11539,7 @@
               </a:rPr>
               <a:t>, before starting a task.</a:t>
             </a:r>
-            <a:endParaRPr lang="en-US" sz="1950" dirty="0"/>
+            <a:endParaRPr lang="en-US" sz="1900" dirty="0"/>
           </a:p>
         </p:txBody>
       </p:sp>
@@ -11452,7 +11573,7 @@
               <a:buNone/>
             </a:pPr>
             <a:r>
-              <a:rPr lang="en-US" sz="2250" b="1" dirty="0">
+              <a:rPr lang="en-US" sz="2200" b="1" dirty="0">
                 <a:solidFill>
                   <a:srgbClr val="1F6FB2"/>
                 </a:solidFill>
@@ -11462,7 +11583,7 @@
               </a:rPr>
               <a:t>3</a:t>
             </a:r>
-            <a:endParaRPr lang="en-US" sz="2250" dirty="0"/>
+            <a:endParaRPr lang="en-US" sz="2200" dirty="0"/>
           </a:p>
         </p:txBody>
       </p:sp>
@@ -11496,7 +11617,7 @@
               <a:buNone/>
             </a:pPr>
             <a:r>
-              <a:rPr lang="en-US" sz="1950" dirty="0">
+              <a:rPr lang="en-US" sz="1900" dirty="0">
                 <a:solidFill>
                   <a:srgbClr val="000000"/>
                 </a:solidFill>
@@ -11507,7 +11628,7 @@
               <a:t xml:space="preserve">Improve </a:t>
             </a:r>
             <a:r>
-              <a:rPr lang="en-US" sz="1950" b="1" dirty="0">
+              <a:rPr lang="en-US" sz="1900" b="1" dirty="0">
                 <a:solidFill>
                   <a:srgbClr val="000000"/>
                 </a:solidFill>
@@ -11518,7 +11639,7 @@
               <a:t>AGENTS.md</a:t>
             </a:r>
             <a:r>
-              <a:rPr lang="en-US" sz="1950" dirty="0">
+              <a:rPr lang="en-US" sz="1900" dirty="0">
                 <a:solidFill>
                   <a:srgbClr val="000000"/>
                 </a:solidFill>
@@ -11528,7 +11649,7 @@
               </a:rPr>
               <a:t xml:space="preserve">, or have Codex draft one.</a:t>
             </a:r>
-            <a:endParaRPr lang="en-US" sz="1950" dirty="0"/>
+            <a:endParaRPr lang="en-US" sz="1900" dirty="0"/>
           </a:p>
         </p:txBody>
       </p:sp>
@@ -11562,7 +11683,7 @@
               <a:buNone/>
             </a:pPr>
             <a:r>
-              <a:rPr lang="en-US" sz="2250" b="1" dirty="0">
+              <a:rPr lang="en-US" sz="2200" b="1" dirty="0">
                 <a:solidFill>
                   <a:srgbClr val="1F6FB2"/>
                 </a:solidFill>
@@ -11572,7 +11693,7 @@
               </a:rPr>
               <a:t>4</a:t>
             </a:r>
-            <a:endParaRPr lang="en-US" sz="2250" dirty="0"/>
+            <a:endParaRPr lang="en-US" sz="2200" dirty="0"/>
           </a:p>
         </p:txBody>
       </p:sp>
@@ -11606,7 +11727,7 @@
               <a:buNone/>
             </a:pPr>
             <a:r>
-              <a:rPr lang="en-US" sz="1950" dirty="0">
+              <a:rPr lang="en-US" sz="1900" dirty="0">
                 <a:solidFill>
                   <a:srgbClr val="000000"/>
                 </a:solidFill>
@@ -11616,7 +11737,7 @@
               </a:rPr>
               <a:t>Orient → plan → implement.</a:t>
             </a:r>
-            <a:endParaRPr lang="en-US" sz="1950" dirty="0"/>
+            <a:endParaRPr lang="en-US" sz="1900" dirty="0"/>
           </a:p>
         </p:txBody>
       </p:sp>
@@ -11650,7 +11771,7 @@
               <a:buNone/>
             </a:pPr>
             <a:r>
-              <a:rPr lang="en-US" sz="2250" b="1" dirty="0">
+              <a:rPr lang="en-US" sz="2200" b="1" dirty="0">
                 <a:solidFill>
                   <a:srgbClr val="1F6FB2"/>
                 </a:solidFill>
@@ -11660,7 +11781,7 @@
               </a:rPr>
               <a:t>5</a:t>
             </a:r>
-            <a:endParaRPr lang="en-US" sz="2250" dirty="0"/>
+            <a:endParaRPr lang="en-US" sz="2200" dirty="0"/>
           </a:p>
         </p:txBody>
       </p:sp>
@@ -11694,7 +11815,7 @@
               <a:buNone/>
             </a:pPr>
             <a:r>
-              <a:rPr lang="en-US" sz="1950" dirty="0">
+              <a:rPr lang="en-US" sz="1900" dirty="0">
                 <a:solidFill>
                   <a:srgbClr val="000000"/>
                 </a:solidFill>
@@ -11704,7 +11825,7 @@
               </a:rPr>
               <a:t>Review the PR and test it yourself. Merge only if it passes.</a:t>
             </a:r>
-            <a:endParaRPr lang="en-US" sz="1950" dirty="0"/>
+            <a:endParaRPr lang="en-US" sz="1900" dirty="0"/>
           </a:p>
         </p:txBody>
       </p:sp>
@@ -11738,7 +11859,7 @@
               <a:buNone/>
             </a:pPr>
             <a:r>
-              <a:rPr lang="en-US" sz="2250" b="1" dirty="0">
+              <a:rPr lang="en-US" sz="2200" b="1" dirty="0">
                 <a:solidFill>
                   <a:srgbClr val="1F6FB2"/>
                 </a:solidFill>
@@ -11748,7 +11869,7 @@
               </a:rPr>
               <a:t>6</a:t>
             </a:r>
-            <a:endParaRPr lang="en-US" sz="2250" dirty="0"/>
+            <a:endParaRPr lang="en-US" sz="2200" dirty="0"/>
           </a:p>
         </p:txBody>
       </p:sp>
@@ -11782,7 +11903,7 @@
               <a:buNone/>
             </a:pPr>
             <a:r>
-              <a:rPr lang="en-US" sz="1950" dirty="0">
+              <a:rPr lang="en-US" sz="1900" dirty="0">
                 <a:solidFill>
                   <a:srgbClr val="000000"/>
                 </a:solidFill>
@@ -11792,7 +11913,7 @@
               </a:rPr>
               <a:t>Add an entry to AI_LOG.md.</a:t>
             </a:r>
-            <a:endParaRPr lang="en-US" sz="1950" dirty="0"/>
+            <a:endParaRPr lang="en-US" sz="1900" dirty="0"/>
           </a:p>
         </p:txBody>
       </p:sp>
@@ -11847,7 +11968,7 @@
               <a:buNone/>
             </a:pPr>
             <a:r>
-              <a:rPr lang="en-US" sz="1950" b="1" dirty="0">
+              <a:rPr lang="en-US" sz="1900" b="1" dirty="0">
                 <a:solidFill>
                   <a:srgbClr val="152A47"/>
                 </a:solidFill>
@@ -11857,7 +11978,7 @@
               </a:rPr>
               <a:t>Good first requests</a:t>
             </a:r>
-            <a:endParaRPr lang="en-US" sz="1950" dirty="0"/>
+            <a:endParaRPr lang="en-US" sz="1900" dirty="0"/>
           </a:p>
         </p:txBody>
       </p:sp>
@@ -11891,7 +12012,7 @@
               <a:buNone/>
             </a:pPr>
             <a:r>
-              <a:rPr lang="en-US" sz="1725" dirty="0">
+              <a:rPr lang="en-US" sz="1700" dirty="0">
                 <a:solidFill>
                   <a:srgbClr val="000000"/>
                 </a:solidFill>
@@ -11901,7 +12022,7 @@
               </a:rPr>
               <a:t>Add a test for an existing function</a:t>
             </a:r>
-            <a:endParaRPr lang="en-US" sz="1725" dirty="0"/>
+            <a:endParaRPr lang="en-US" sz="1700" dirty="0"/>
           </a:p>
           <a:p>
             <a:pPr algn="l" indent="0" marL="0">
@@ -11911,7 +12032,7 @@
               <a:buNone/>
             </a:pPr>
             <a:r>
-              <a:rPr lang="en-US" sz="1725" dirty="0">
+              <a:rPr lang="en-US" sz="1700" dirty="0">
                 <a:solidFill>
                   <a:srgbClr val="000000"/>
                 </a:solidFill>
@@ -11921,7 +12042,7 @@
               </a:rPr>
               <a:t>Add input checks with clear errors</a:t>
             </a:r>
-            <a:endParaRPr lang="en-US" sz="1725" dirty="0"/>
+            <a:endParaRPr lang="en-US" sz="1700" dirty="0"/>
           </a:p>
           <a:p>
             <a:pPr algn="l" indent="0" marL="0">
@@ -11931,7 +12052,7 @@
               <a:buNone/>
             </a:pPr>
             <a:r>
-              <a:rPr lang="en-US" sz="1725" dirty="0">
+              <a:rPr lang="en-US" sz="1700" dirty="0">
                 <a:solidFill>
                   <a:srgbClr val="000000"/>
                 </a:solidFill>
@@ -11941,7 +12062,7 @@
               </a:rPr>
               <a:t>Explain how to run it in the README</a:t>
             </a:r>
-            <a:endParaRPr lang="en-US" sz="1725" dirty="0"/>
+            <a:endParaRPr lang="en-US" sz="1700" dirty="0"/>
           </a:p>
           <a:p>
             <a:pPr algn="l" indent="0" marL="0">
@@ -11951,7 +12072,7 @@
               <a:buNone/>
             </a:pPr>
             <a:r>
-              <a:rPr lang="en-US" sz="1725" dirty="0">
+              <a:rPr lang="en-US" sz="1700" dirty="0">
                 <a:solidFill>
                   <a:srgbClr val="000000"/>
                 </a:solidFill>
@@ -11961,7 +12082,7 @@
               </a:rPr>
               <a:t>Replace hard-coded values with parameters</a:t>
             </a:r>
-            <a:endParaRPr lang="en-US" sz="1725" dirty="0"/>
+            <a:endParaRPr lang="en-US" sz="1700" dirty="0"/>
           </a:p>
         </p:txBody>
       </p:sp>
@@ -12016,7 +12137,7 @@
               <a:buNone/>
             </a:pPr>
             <a:r>
-              <a:rPr lang="en-US" sz="1950" b="1" dirty="0">
+              <a:rPr lang="en-US" sz="1900" b="1" dirty="0">
                 <a:solidFill>
                   <a:srgbClr val="152A47"/>
                 </a:solidFill>
@@ -12026,7 +12147,7 @@
               </a:rPr>
               <a:t>Avoid for now</a:t>
             </a:r>
-            <a:endParaRPr lang="en-US" sz="1950" dirty="0"/>
+            <a:endParaRPr lang="en-US" sz="1900" dirty="0"/>
           </a:p>
         </p:txBody>
       </p:sp>
@@ -12060,7 +12181,7 @@
               <a:buNone/>
             </a:pPr>
             <a:r>
-              <a:rPr lang="en-US" sz="1725" dirty="0">
+              <a:rPr lang="en-US" sz="1700" dirty="0">
                 <a:solidFill>
                   <a:srgbClr val="000000"/>
                 </a:solidFill>
@@ -12070,7 +12191,7 @@
               </a:rPr>
               <a:t>“Rewrite the whole project”</a:t>
             </a:r>
-            <a:endParaRPr lang="en-US" sz="1725" dirty="0"/>
+            <a:endParaRPr lang="en-US" sz="1700" dirty="0"/>
           </a:p>
           <a:p>
             <a:pPr algn="l" indent="0" marL="0">
@@ -12080,7 +12201,7 @@
               <a:buNone/>
             </a:pPr>
             <a:r>
-              <a:rPr lang="en-US" sz="1725" dirty="0">
+              <a:rPr lang="en-US" sz="1700" dirty="0">
                 <a:solidFill>
                   <a:srgbClr val="000000"/>
                 </a:solidFill>
@@ -12090,7 +12211,7 @@
               </a:rPr>
               <a:t>Anything you can’t check yourself</a:t>
             </a:r>
-            <a:endParaRPr lang="en-US" sz="1725" dirty="0"/>
+            <a:endParaRPr lang="en-US" sz="1700" dirty="0"/>
           </a:p>
         </p:txBody>
       </p:sp>
@@ -12103,7 +12224,7 @@
         <p:spPr>
           <a:xfrm>
             <a:off x="133350" y="5429250"/>
-            <a:ext cx="1442184" cy="381000"/>
+            <a:ext cx="1409700" cy="381000"/>
           </a:xfrm>
           <a:prstGeom prst="rect">
             <a:avLst/>
@@ -12264,7 +12385,7 @@
               <a:buNone/>
             </a:pPr>
             <a:r>
-              <a:rPr lang="en-US" sz="2025" dirty="0">
+              <a:rPr lang="en-US" sz="2000" dirty="0">
                 <a:solidFill>
                   <a:srgbClr val="000000"/>
                 </a:solidFill>
@@ -12274,7 +12395,7 @@
               </a:rPr>
               <a:t>A Codex task belongs to one ChatGPT account; teammates can’t join it. The GitHub repo is the team’s shared workspace.</a:t>
             </a:r>
-            <a:endParaRPr lang="en-US" sz="2025" dirty="0"/>
+            <a:endParaRPr lang="en-US" sz="2000" dirty="0"/>
           </a:p>
         </p:txBody>
       </p:sp>
@@ -12329,7 +12450,7 @@
               <a:buNone/>
             </a:pPr>
             <a:r>
-              <a:rPr lang="en-US" sz="1650" b="1" dirty="0">
+              <a:rPr lang="en-US" sz="1600" b="1" dirty="0">
                 <a:solidFill>
                   <a:srgbClr val="404040"/>
                 </a:solidFill>
@@ -12339,7 +12460,7 @@
               </a:rPr>
               <a:t>OPTION A</a:t>
             </a:r>
-            <a:endParaRPr lang="en-US" sz="1650" dirty="0"/>
+            <a:endParaRPr lang="en-US" sz="1600" dirty="0"/>
           </a:p>
         </p:txBody>
       </p:sp>
@@ -12370,7 +12491,7 @@
               <a:buNone/>
             </a:pPr>
             <a:r>
-              <a:rPr lang="en-US" sz="2250" b="1" dirty="0">
+              <a:rPr lang="en-US" sz="2200" b="1" dirty="0">
                 <a:solidFill>
                   <a:srgbClr val="152A47"/>
                 </a:solidFill>
@@ -12380,7 +12501,7 @@
               </a:rPr>
               <a:t>One driver</a:t>
             </a:r>
-            <a:endParaRPr lang="en-US" sz="2250" dirty="0"/>
+            <a:endParaRPr lang="en-US" sz="2200" dirty="0"/>
           </a:p>
         </p:txBody>
       </p:sp>
@@ -12519,7 +12640,7 @@
               <a:buNone/>
             </a:pPr>
             <a:r>
-              <a:rPr lang="en-US" sz="1650" b="1" dirty="0">
+              <a:rPr lang="en-US" sz="1600" b="1" dirty="0">
                 <a:solidFill>
                   <a:srgbClr val="404040"/>
                 </a:solidFill>
@@ -12529,7 +12650,7 @@
               </a:rPr>
               <a:t>OPTION B</a:t>
             </a:r>
-            <a:endParaRPr lang="en-US" sz="1650" dirty="0"/>
+            <a:endParaRPr lang="en-US" sz="1600" dirty="0"/>
           </a:p>
         </p:txBody>
       </p:sp>
@@ -12560,7 +12681,7 @@
               <a:buNone/>
             </a:pPr>
             <a:r>
-              <a:rPr lang="en-US" sz="2250" b="1" dirty="0">
+              <a:rPr lang="en-US" sz="2200" b="1" dirty="0">
                 <a:solidFill>
                   <a:srgbClr val="152A47"/>
                 </a:solidFill>
@@ -12570,7 +12691,7 @@
               </a:rPr>
               <a:t>Parallel drivers</a:t>
             </a:r>
-            <a:endParaRPr lang="en-US" sz="2250" dirty="0"/>
+            <a:endParaRPr lang="en-US" sz="2200" dirty="0"/>
           </a:p>
         </p:txBody>
       </p:sp>
@@ -12712,7 +12833,7 @@
               <a:buNone/>
             </a:pPr>
             <a:r>
-              <a:rPr lang="en-US" sz="1875" b="1" dirty="0">
+              <a:rPr lang="en-US" sz="1900" b="1" dirty="0">
                 <a:solidFill>
                   <a:srgbClr val="FFFFFF"/>
                 </a:solidFill>
@@ -12723,7 +12844,7 @@
               <a:t>Grade the process:</a:t>
             </a:r>
             <a:r>
-              <a:rPr lang="en-US" sz="1875" dirty="0">
+              <a:rPr lang="en-US" sz="1900" dirty="0">
                 <a:solidFill>
                   <a:srgbClr val="FFFFFF"/>
                 </a:solidFill>
@@ -12733,7 +12854,7 @@
               </a:rPr>
               <a:t xml:space="preserve"> requirement, plan, PR review, test evidence, AI_LOG.md.</a:t>
             </a:r>
-            <a:endParaRPr lang="en-US" sz="1875" dirty="0"/>
+            <a:endParaRPr lang="en-US" sz="1900" dirty="0"/>
           </a:p>
           <a:p>
             <a:pPr algn="l" indent="0" marL="0">
@@ -12743,7 +12864,7 @@
               <a:buNone/>
             </a:pPr>
             <a:r>
-              <a:rPr lang="en-US" sz="1875" dirty="0">
+              <a:rPr lang="en-US" sz="1900" dirty="0">
                 <a:solidFill>
                   <a:srgbClr val="FFFFFF"/>
                 </a:solidFill>
@@ -12753,7 +12874,7 @@
               </a:rPr>
               <a:t>Add every teammate as a repo collaborator. Never share agent account logins.</a:t>
             </a:r>
-            <a:endParaRPr lang="en-US" sz="1875" dirty="0"/>
+            <a:endParaRPr lang="en-US" sz="1900" dirty="0"/>
           </a:p>
         </p:txBody>
       </p:sp>
@@ -12766,7 +12887,7 @@
         <p:spPr>
           <a:xfrm>
             <a:off x="133350" y="5810250"/>
-            <a:ext cx="1442184" cy="381000"/>
+            <a:ext cx="1409700" cy="381000"/>
           </a:xfrm>
           <a:prstGeom prst="rect">
             <a:avLst/>
@@ -12909,7 +13030,7 @@
         <p:spPr>
           <a:xfrm>
             <a:off x="1810512" y="1618488"/>
-            <a:ext cx="12847320" cy="393192"/>
+            <a:ext cx="11768328" cy="393192"/>
           </a:xfrm>
           <a:prstGeom prst="rect">
             <a:avLst/>
@@ -12971,7 +13092,7 @@
               <a:buNone/>
             </a:pPr>
             <a:r>
-              <a:rPr lang="en-US" sz="2250" b="1" dirty="0">
+              <a:rPr lang="en-US" sz="2200" b="1" dirty="0">
                 <a:solidFill>
                   <a:srgbClr val="1F6FB2"/>
                 </a:solidFill>
@@ -12981,7 +13102,7 @@
               </a:rPr>
               <a:t>1</a:t>
             </a:r>
-            <a:endParaRPr lang="en-US" sz="2250" dirty="0"/>
+            <a:endParaRPr lang="en-US" sz="2200" dirty="0"/>
           </a:p>
         </p:txBody>
       </p:sp>
@@ -13059,7 +13180,7 @@
               <a:buNone/>
             </a:pPr>
             <a:r>
-              <a:rPr lang="en-US" sz="2250" b="1" dirty="0">
+              <a:rPr lang="en-US" sz="2200" b="1" dirty="0">
                 <a:solidFill>
                   <a:srgbClr val="1F6FB2"/>
                 </a:solidFill>
@@ -13069,7 +13190,7 @@
               </a:rPr>
               <a:t>2</a:t>
             </a:r>
-            <a:endParaRPr lang="en-US" sz="2250" dirty="0"/>
+            <a:endParaRPr lang="en-US" sz="2200" dirty="0"/>
           </a:p>
         </p:txBody>
       </p:sp>
@@ -13147,7 +13268,7 @@
               <a:buNone/>
             </a:pPr>
             <a:r>
-              <a:rPr lang="en-US" sz="2250" b="1" dirty="0">
+              <a:rPr lang="en-US" sz="2200" b="1" dirty="0">
                 <a:solidFill>
                   <a:srgbClr val="1F6FB2"/>
                 </a:solidFill>
@@ -13157,7 +13278,7 @@
               </a:rPr>
               <a:t>3</a:t>
             </a:r>
-            <a:endParaRPr lang="en-US" sz="2250" dirty="0"/>
+            <a:endParaRPr lang="en-US" sz="2200" dirty="0"/>
           </a:p>
         </p:txBody>
       </p:sp>
@@ -13235,7 +13356,7 @@
               <a:buNone/>
             </a:pPr>
             <a:r>
-              <a:rPr lang="en-US" sz="2250" b="1" dirty="0">
+              <a:rPr lang="en-US" sz="2200" b="1" dirty="0">
                 <a:solidFill>
                   <a:srgbClr val="1F6FB2"/>
                 </a:solidFill>
@@ -13245,7 +13366,7 @@
               </a:rPr>
               <a:t>4</a:t>
             </a:r>
-            <a:endParaRPr lang="en-US" sz="2250" dirty="0"/>
+            <a:endParaRPr lang="en-US" sz="2200" dirty="0"/>
           </a:p>
         </p:txBody>
       </p:sp>
@@ -13323,7 +13444,7 @@
               <a:buNone/>
             </a:pPr>
             <a:r>
-              <a:rPr lang="en-US" sz="2250" b="1" dirty="0">
+              <a:rPr lang="en-US" sz="2200" b="1" dirty="0">
                 <a:solidFill>
                   <a:srgbClr val="1F6FB2"/>
                 </a:solidFill>
@@ -13333,7 +13454,7 @@
               </a:rPr>
               <a:t>5</a:t>
             </a:r>
-            <a:endParaRPr lang="en-US" sz="2250" dirty="0"/>
+            <a:endParaRPr lang="en-US" sz="2200" dirty="0"/>
           </a:p>
         </p:txBody>
       </p:sp>
@@ -13390,7 +13511,7 @@
         <p:spPr>
           <a:xfrm>
             <a:off x="1810512" y="5148072"/>
-            <a:ext cx="12847320" cy="393192"/>
+            <a:ext cx="11768328" cy="393192"/>
           </a:xfrm>
           <a:prstGeom prst="rect">
             <a:avLst/>
@@ -13749,7 +13870,7 @@
         <p:spPr>
           <a:xfrm>
             <a:off x="133350" y="2381250"/>
-            <a:ext cx="1442184" cy="381000"/>
+            <a:ext cx="1409700" cy="381000"/>
           </a:xfrm>
           <a:prstGeom prst="rect">
             <a:avLst/>
@@ -14802,7 +14923,7 @@
         <p:spPr>
           <a:xfrm>
             <a:off x="133350" y="6191250"/>
-            <a:ext cx="1442184" cy="381000"/>
+            <a:ext cx="1409700" cy="381000"/>
           </a:xfrm>
           <a:prstGeom prst="rect">
             <a:avLst/>
@@ -16115,7 +16236,7 @@
         <p:spPr>
           <a:xfrm>
             <a:off x="133350" y="6191250"/>
-            <a:ext cx="1442184" cy="381000"/>
+            <a:ext cx="1409700" cy="381000"/>
           </a:xfrm>
           <a:prstGeom prst="rect">
             <a:avLst/>
@@ -16317,7 +16438,7 @@
               <a:buNone/>
             </a:pPr>
             <a:r>
-              <a:rPr lang="en-US" sz="2175" dirty="0">
+              <a:rPr lang="en-US" sz="2200" dirty="0">
                 <a:solidFill>
                   <a:srgbClr val="000000"/>
                 </a:solidFill>
@@ -16327,7 +16448,7 @@
               </a:rPr>
               <a:t>What can a coding agent do that a chat LLM can’t, and how does that change your role?</a:t>
             </a:r>
-            <a:endParaRPr lang="en-US" sz="2175" dirty="0"/>
+            <a:endParaRPr lang="en-US" sz="2200" dirty="0"/>
           </a:p>
         </p:txBody>
       </p:sp>
@@ -16399,7 +16520,7 @@
               <a:buNone/>
             </a:pPr>
             <a:r>
-              <a:rPr lang="en-US" sz="2175" dirty="0">
+              <a:rPr lang="en-US" sz="2200" dirty="0">
                 <a:solidFill>
                   <a:srgbClr val="000000"/>
                 </a:solidFill>
@@ -16409,7 +16530,7 @@
               </a:rPr>
               <a:t>What belongs in AGENTS.md, and why keep it short?</a:t>
             </a:r>
-            <a:endParaRPr lang="en-US" sz="2175" dirty="0"/>
+            <a:endParaRPr lang="en-US" sz="2200" dirty="0"/>
           </a:p>
         </p:txBody>
       </p:sp>
@@ -16481,7 +16602,7 @@
               <a:buNone/>
             </a:pPr>
             <a:r>
-              <a:rPr lang="en-US" sz="2175" dirty="0">
+              <a:rPr lang="en-US" sz="2200" dirty="0">
                 <a:solidFill>
                   <a:srgbClr val="000000"/>
                 </a:solidFill>
@@ -16491,7 +16612,7 @@
               </a:rPr>
               <a:t>Why ask for a plan before any code is written?</a:t>
             </a:r>
-            <a:endParaRPr lang="en-US" sz="2175" dirty="0"/>
+            <a:endParaRPr lang="en-US" sz="2200" dirty="0"/>
           </a:p>
         </p:txBody>
       </p:sp>
@@ -16563,7 +16684,7 @@
               <a:buNone/>
             </a:pPr>
             <a:r>
-              <a:rPr lang="en-US" sz="2175" dirty="0">
+              <a:rPr lang="en-US" sz="2200" dirty="0">
                 <a:solidFill>
                   <a:srgbClr val="000000"/>
                 </a:solidFill>
@@ -16573,7 +16694,7 @@
               </a:rPr>
               <a:t>The agent reports “All tests pass.” What do you do?</a:t>
             </a:r>
-            <a:endParaRPr lang="en-US" sz="2175" dirty="0"/>
+            <a:endParaRPr lang="en-US" sz="2200" dirty="0"/>
           </a:p>
         </p:txBody>
       </p:sp>
@@ -16645,7 +16766,7 @@
               <a:buNone/>
             </a:pPr>
             <a:r>
-              <a:rPr lang="en-US" sz="2175" dirty="0">
+              <a:rPr lang="en-US" sz="2200" dirty="0">
                 <a:solidFill>
                   <a:srgbClr val="000000"/>
                 </a:solidFill>
@@ -16655,7 +16776,7 @@
               </a:rPr>
               <a:t>A PR changes a test’s expected value so the test passes. Merge it?</a:t>
             </a:r>
-            <a:endParaRPr lang="en-US" sz="2175" dirty="0"/>
+            <a:endParaRPr lang="en-US" sz="2200" dirty="0"/>
           </a:p>
         </p:txBody>
       </p:sp>
@@ -16710,7 +16831,7 @@
               <a:buNone/>
             </a:pPr>
             <a:r>
-              <a:rPr lang="en-US" sz="2025" b="1" dirty="0">
+              <a:rPr lang="en-US" sz="2000" b="1" dirty="0">
                 <a:solidFill>
                   <a:srgbClr val="FFFFFF"/>
                 </a:solidFill>
@@ -16721,7 +16842,7 @@
               <a:t>Next: Lesson 3</a:t>
             </a:r>
             <a:r>
-              <a:rPr lang="en-US" sz="2025" dirty="0">
+              <a:rPr lang="en-US" sz="2000" dirty="0">
                 <a:solidFill>
                   <a:srgbClr val="FFFFFF"/>
                 </a:solidFill>
@@ -16731,7 +16852,7 @@
               </a:rPr>
               <a:t xml:space="preserve"> · Agentic AI for course app development using GitHub Pages.</a:t>
             </a:r>
-            <a:endParaRPr lang="en-US" sz="2025" dirty="0"/>
+            <a:endParaRPr lang="en-US" sz="2000" dirty="0"/>
           </a:p>
         </p:txBody>
       </p:sp>
@@ -16744,7 +16865,7 @@
         <p:spPr>
           <a:xfrm>
             <a:off x="133350" y="6191250"/>
-            <a:ext cx="1442184" cy="381000"/>
+            <a:ext cx="1409700" cy="381000"/>
           </a:xfrm>
           <a:prstGeom prst="rect">
             <a:avLst/>
@@ -16887,7 +17008,7 @@
         <p:spPr>
           <a:xfrm>
             <a:off x="1810512" y="1618488"/>
-            <a:ext cx="12847320" cy="393192"/>
+            <a:ext cx="11768328" cy="393192"/>
           </a:xfrm>
           <a:prstGeom prst="rect">
             <a:avLst/>
@@ -16970,7 +17091,7 @@
               <a:buNone/>
             </a:pPr>
             <a:r>
-              <a:rPr lang="en-US" sz="1950" b="1" dirty="0">
+              <a:rPr lang="en-US" sz="1900" b="1" dirty="0">
                 <a:solidFill>
                   <a:srgbClr val="000000"/>
                 </a:solidFill>
@@ -16980,7 +17101,7 @@
               </a:rPr>
               <a:t>Lesson 1 repo</a:t>
             </a:r>
-            <a:endParaRPr lang="en-US" sz="1950" dirty="0"/>
+            <a:endParaRPr lang="en-US" sz="1900" dirty="0"/>
           </a:p>
         </p:txBody>
       </p:sp>
@@ -17011,7 +17132,7 @@
               <a:buNone/>
             </a:pPr>
             <a:r>
-              <a:rPr lang="en-US" sz="1950" dirty="0">
+              <a:rPr lang="en-US" sz="1900" dirty="0">
                 <a:solidFill>
                   <a:srgbClr val="000000"/>
                 </a:solidFill>
@@ -17022,7 +17143,7 @@
               <a:t xml:space="preserve">Your private copy of </a:t>
             </a:r>
             <a:r>
-              <a:rPr lang="en-US" sz="1950" b="1" dirty="0">
+              <a:rPr lang="en-US" sz="1900" b="1" dirty="0">
                 <a:solidFill>
                   <a:srgbClr val="000000"/>
                 </a:solidFill>
@@ -17033,7 +17154,7 @@
               <a:t>beam-calc</a:t>
             </a:r>
             <a:r>
-              <a:rPr lang="en-US" sz="1950" dirty="0">
+              <a:rPr lang="en-US" sz="1900" dirty="0">
                 <a:solidFill>
                   <a:srgbClr val="000000"/>
                 </a:solidFill>
@@ -17043,7 +17164,7 @@
               </a:rPr>
               <a:t xml:space="preserve"> on GitHub, cloned with GitHub Desktop.</a:t>
             </a:r>
-            <a:endParaRPr lang="en-US" sz="1950" dirty="0"/>
+            <a:endParaRPr lang="en-US" sz="1900" dirty="0"/>
           </a:p>
         </p:txBody>
       </p:sp>
@@ -17122,7 +17243,7 @@
               <a:buNone/>
             </a:pPr>
             <a:r>
-              <a:rPr lang="en-US" sz="1950" b="1" dirty="0">
+              <a:rPr lang="en-US" sz="1900" b="1" dirty="0">
                 <a:solidFill>
                   <a:srgbClr val="000000"/>
                 </a:solidFill>
@@ -17132,7 +17253,7 @@
               </a:rPr>
               <a:t>Agent account</a:t>
             </a:r>
-            <a:endParaRPr lang="en-US" sz="1950" dirty="0"/>
+            <a:endParaRPr lang="en-US" sz="1900" dirty="0"/>
           </a:p>
         </p:txBody>
       </p:sp>
@@ -17163,7 +17284,7 @@
               <a:buNone/>
             </a:pPr>
             <a:r>
-              <a:rPr lang="en-US" sz="1950" dirty="0">
+              <a:rPr lang="en-US" sz="1900" dirty="0">
                 <a:solidFill>
                   <a:srgbClr val="000000"/>
                 </a:solidFill>
@@ -17173,7 +17294,7 @@
               </a:rPr>
               <a:t>ChatGPT Plus or higher; Business, Edu, and Enterprise plans also include Codex. Use the account type your organization directs.</a:t>
             </a:r>
-            <a:endParaRPr lang="en-US" sz="1950" dirty="0"/>
+            <a:endParaRPr lang="en-US" sz="1900" dirty="0"/>
           </a:p>
         </p:txBody>
       </p:sp>
@@ -17252,7 +17373,7 @@
               <a:buNone/>
             </a:pPr>
             <a:r>
-              <a:rPr lang="en-US" sz="1950" b="1" dirty="0">
+              <a:rPr lang="en-US" sz="1900" b="1" dirty="0">
                 <a:solidFill>
                   <a:srgbClr val="000000"/>
                 </a:solidFill>
@@ -17262,7 +17383,7 @@
               </a:rPr>
               <a:t>GitHub Desktop + VS Code</a:t>
             </a:r>
-            <a:endParaRPr lang="en-US" sz="1950" dirty="0"/>
+            <a:endParaRPr lang="en-US" sz="1900" dirty="0"/>
           </a:p>
         </p:txBody>
       </p:sp>
@@ -17293,7 +17414,7 @@
               <a:buNone/>
             </a:pPr>
             <a:r>
-              <a:rPr lang="en-US" sz="1950" dirty="0">
+              <a:rPr lang="en-US" sz="1900" dirty="0">
                 <a:solidFill>
                   <a:srgbClr val="000000"/>
                 </a:solidFill>
@@ -17303,7 +17424,7 @@
               </a:rPr>
               <a:t>Installed and signed in (Lesson 1).</a:t>
             </a:r>
-            <a:endParaRPr lang="en-US" sz="1950" dirty="0"/>
+            <a:endParaRPr lang="en-US" sz="1900" dirty="0"/>
           </a:p>
         </p:txBody>
       </p:sp>
@@ -17382,7 +17503,7 @@
               <a:buNone/>
             </a:pPr>
             <a:r>
-              <a:rPr lang="en-US" sz="1950" b="1" dirty="0">
+              <a:rPr lang="en-US" sz="1900" b="1" dirty="0">
                 <a:solidFill>
                   <a:srgbClr val="000000"/>
                 </a:solidFill>
@@ -17392,7 +17513,7 @@
               </a:rPr>
               <a:t>MATLAB (optional)</a:t>
             </a:r>
-            <a:endParaRPr lang="en-US" sz="1950" dirty="0"/>
+            <a:endParaRPr lang="en-US" sz="1900" dirty="0"/>
           </a:p>
         </p:txBody>
       </p:sp>
@@ -17423,7 +17544,7 @@
               <a:buNone/>
             </a:pPr>
             <a:r>
-              <a:rPr lang="en-US" sz="1950" dirty="0">
+              <a:rPr lang="en-US" sz="1900" dirty="0">
                 <a:solidFill>
                   <a:srgbClr val="000000"/>
                 </a:solidFill>
@@ -17433,7 +17554,7 @@
               </a:rPr>
               <a:t>To run the tests yourself. The agent’s cloud environment has no MATLAB.</a:t>
             </a:r>
-            <a:endParaRPr lang="en-US" sz="1950" dirty="0"/>
+            <a:endParaRPr lang="en-US" sz="1900" dirty="0"/>
           </a:p>
         </p:txBody>
       </p:sp>
@@ -17512,7 +17633,7 @@
               <a:buNone/>
             </a:pPr>
             <a:r>
-              <a:rPr lang="en-US" sz="1950" b="1" dirty="0">
+              <a:rPr lang="en-US" sz="1900" b="1" dirty="0">
                 <a:solidFill>
                   <a:srgbClr val="000000"/>
                 </a:solidFill>
@@ -17522,7 +17643,7 @@
               </a:rPr>
               <a:t>Your own project</a:t>
             </a:r>
-            <a:endParaRPr lang="en-US" sz="1950" dirty="0"/>
+            <a:endParaRPr lang="en-US" sz="1900" dirty="0"/>
           </a:p>
         </p:txBody>
       </p:sp>
@@ -17553,7 +17674,7 @@
               <a:buNone/>
             </a:pPr>
             <a:r>
-              <a:rPr lang="en-US" sz="1950" dirty="0">
+              <a:rPr lang="en-US" sz="1900" dirty="0">
                 <a:solidFill>
                   <a:srgbClr val="000000"/>
                 </a:solidFill>
@@ -17563,7 +17684,7 @@
               </a:rPr>
               <a:t>The repo from Lesson 1’s Agent-Ready Checklist, for Exercise 7.</a:t>
             </a:r>
-            <a:endParaRPr lang="en-US" sz="1950" dirty="0"/>
+            <a:endParaRPr lang="en-US" sz="1900" dirty="0"/>
           </a:p>
         </p:txBody>
       </p:sp>
@@ -17624,25 +17745,25 @@
         <p:spPr>
           <a:xfrm>
             <a:off x="1810512" y="7355205"/>
-            <a:ext cx="11887200" cy="731520"/>
-          </a:xfrm>
-          <a:prstGeom prst="rect">
-            <a:avLst/>
-          </a:prstGeom>
-          <a:noFill/>
-          <a:ln/>
-        </p:spPr>
-        <p:txBody>
-          <a:bodyPr wrap="square" lIns="25400" tIns="25400" rIns="25400" bIns="25400" rtlCol="0" anchor="t">
-            <a:noAutofit/>
-          </a:bodyPr>
-          <a:lstStyle/>
-          <a:p>
-            <a:pPr algn="l" indent="0" marL="0">
-              <a:buNone/>
-            </a:pPr>
-            <a:r>
-              <a:rPr lang="en-US" sz="1950" dirty="0">
+            <a:ext cx="11768328" cy="731520"/>
+          </a:xfrm>
+          <a:prstGeom prst="rect">
+            <a:avLst/>
+          </a:prstGeom>
+          <a:noFill/>
+          <a:ln/>
+        </p:spPr>
+        <p:txBody>
+          <a:bodyPr wrap="square" lIns="25400" tIns="25400" rIns="25400" bIns="25400" rtlCol="0" anchor="t">
+            <a:noAutofit/>
+          </a:bodyPr>
+          <a:lstStyle/>
+          <a:p>
+            <a:pPr algn="l" indent="0" marL="0">
+              <a:buNone/>
+            </a:pPr>
+            <a:r>
+              <a:rPr lang="en-US" sz="1900" dirty="0">
                 <a:solidFill>
                   <a:srgbClr val="404040"/>
                 </a:solidFill>
@@ -17652,7 +17773,7 @@
               </a:rPr>
               <a:t>Follow current USAFA guidance on GenAI tools and data handling before you connect a repo to an agent.</a:t>
             </a:r>
-            <a:endParaRPr lang="en-US" sz="1950" dirty="0"/>
+            <a:endParaRPr lang="en-US" sz="1900" dirty="0"/>
           </a:p>
         </p:txBody>
       </p:sp>
@@ -17665,7 +17786,7 @@
         <p:spPr>
           <a:xfrm>
             <a:off x="133350" y="2381250"/>
-            <a:ext cx="1442184" cy="381000"/>
+            <a:ext cx="1409700" cy="381000"/>
           </a:xfrm>
           <a:prstGeom prst="rect">
             <a:avLst/>
@@ -17891,7 +18012,7 @@
               <a:buNone/>
             </a:pPr>
             <a:r>
-              <a:rPr lang="en-US" sz="1725" dirty="0">
+              <a:rPr lang="en-US" sz="1700" dirty="0">
                 <a:solidFill>
                   <a:srgbClr val="000000"/>
                 </a:solidFill>
@@ -17901,7 +18022,7 @@
               </a:rPr>
               <a:t>Answers in text. You copy, paste, and debug.</a:t>
             </a:r>
-            <a:endParaRPr lang="en-US" sz="1725" dirty="0"/>
+            <a:endParaRPr lang="en-US" sz="1700" dirty="0"/>
           </a:p>
         </p:txBody>
       </p:sp>
@@ -18021,7 +18142,7 @@
               <a:buNone/>
             </a:pPr>
             <a:r>
-              <a:rPr lang="en-US" sz="1725" dirty="0">
+              <a:rPr lang="en-US" sz="1700" dirty="0">
                 <a:solidFill>
                   <a:srgbClr val="000000"/>
                 </a:solidFill>
@@ -18031,7 +18152,7 @@
               </a:rPr>
               <a:t>Writes and runs code in the chat. You still integrate it.</a:t>
             </a:r>
-            <a:endParaRPr lang="en-US" sz="1725" dirty="0"/>
+            <a:endParaRPr lang="en-US" sz="1700" dirty="0"/>
           </a:p>
         </p:txBody>
       </p:sp>
@@ -18151,7 +18272,7 @@
               <a:buNone/>
             </a:pPr>
             <a:r>
-              <a:rPr lang="en-US" sz="1725" dirty="0">
+              <a:rPr lang="en-US" sz="1700" dirty="0">
                 <a:solidFill>
                   <a:srgbClr val="FFFFFF"/>
                 </a:solidFill>
@@ -18161,7 +18282,7 @@
               </a:rPr>
               <a:t>Reads your repo, edits files, runs commands, commits. You review.</a:t>
             </a:r>
-            <a:endParaRPr lang="en-US" sz="1725" dirty="0"/>
+            <a:endParaRPr lang="en-US" sz="1700" dirty="0"/>
           </a:p>
         </p:txBody>
       </p:sp>
@@ -19351,7 +19472,7 @@
               <a:buNone/>
             </a:pPr>
             <a:r>
-              <a:rPr lang="en-US" sz="2025" b="1" dirty="0">
+              <a:rPr lang="en-US" sz="2000" b="1" dirty="0">
                 <a:solidFill>
                   <a:srgbClr val="000000"/>
                 </a:solidFill>
@@ -19361,7 +19482,7 @@
               </a:rPr>
               <a:t>An agent does more work per prompt. Each prompt needs a clearer specification, and each result needs a closer review.</a:t>
             </a:r>
-            <a:endParaRPr lang="en-US" sz="2025" dirty="0"/>
+            <a:endParaRPr lang="en-US" sz="2000" dirty="0"/>
           </a:p>
         </p:txBody>
       </p:sp>
@@ -19374,7 +19495,7 @@
         <p:spPr>
           <a:xfrm>
             <a:off x="133350" y="2762250"/>
-            <a:ext cx="1442184" cy="381000"/>
+            <a:ext cx="1409700" cy="381000"/>
           </a:xfrm>
           <a:prstGeom prst="rect">
             <a:avLst/>
@@ -19559,7 +19680,7 @@
               <a:buNone/>
             </a:pPr>
             <a:r>
-              <a:rPr lang="en-US" sz="2025" b="1" dirty="0">
+              <a:rPr lang="en-US" sz="2000" b="1" dirty="0">
                 <a:solidFill>
                   <a:srgbClr val="00B0F0"/>
                 </a:solidFill>
@@ -19569,7 +19690,7 @@
               </a:rPr>
               <a:t>SPECIFY</a:t>
             </a:r>
-            <a:endParaRPr lang="en-US" sz="2025" dirty="0"/>
+            <a:endParaRPr lang="en-US" sz="2000" dirty="0"/>
           </a:p>
         </p:txBody>
       </p:sp>
@@ -19600,7 +19721,7 @@
               <a:buNone/>
             </a:pPr>
             <a:r>
-              <a:rPr lang="en-US" sz="1650" dirty="0">
+              <a:rPr lang="en-US" sz="1600" dirty="0">
                 <a:solidFill>
                   <a:srgbClr val="FFFFFF"/>
                 </a:solidFill>
@@ -19610,7 +19731,7 @@
               </a:rPr>
               <a:t>Verifiable requirements</a:t>
             </a:r>
-            <a:endParaRPr lang="en-US" sz="1650" dirty="0"/>
+            <a:endParaRPr lang="en-US" sz="1600" dirty="0"/>
           </a:p>
         </p:txBody>
       </p:sp>
@@ -19689,7 +19810,7 @@
               <a:buNone/>
             </a:pPr>
             <a:r>
-              <a:rPr lang="en-US" sz="2025" b="1" dirty="0">
+              <a:rPr lang="en-US" sz="2000" b="1" dirty="0">
                 <a:solidFill>
                   <a:srgbClr val="FFFFFF"/>
                 </a:solidFill>
@@ -19699,7 +19820,7 @@
               </a:rPr>
               <a:t>GENERATE</a:t>
             </a:r>
-            <a:endParaRPr lang="en-US" sz="2025" dirty="0"/>
+            <a:endParaRPr lang="en-US" sz="2000" dirty="0"/>
           </a:p>
         </p:txBody>
       </p:sp>
@@ -19730,7 +19851,7 @@
               <a:buNone/>
             </a:pPr>
             <a:r>
-              <a:rPr lang="en-US" sz="1650" dirty="0">
+              <a:rPr lang="en-US" sz="1600" dirty="0">
                 <a:solidFill>
                   <a:srgbClr val="FFFFFF"/>
                 </a:solidFill>
@@ -19740,7 +19861,7 @@
               </a:rPr>
               <a:t>Agent proposes a design</a:t>
             </a:r>
-            <a:endParaRPr lang="en-US" sz="1650" dirty="0"/>
+            <a:endParaRPr lang="en-US" sz="1600" dirty="0"/>
           </a:p>
         </p:txBody>
       </p:sp>
@@ -19819,7 +19940,7 @@
               <a:buNone/>
             </a:pPr>
             <a:r>
-              <a:rPr lang="en-US" sz="2025" b="1" dirty="0">
+              <a:rPr lang="en-US" sz="2000" b="1" dirty="0">
                 <a:solidFill>
                   <a:srgbClr val="FFFFFF"/>
                 </a:solidFill>
@@ -19829,7 +19950,7 @@
               </a:rPr>
               <a:t>IMPLEMENT</a:t>
             </a:r>
-            <a:endParaRPr lang="en-US" sz="2025" dirty="0"/>
+            <a:endParaRPr lang="en-US" sz="2000" dirty="0"/>
           </a:p>
         </p:txBody>
       </p:sp>
@@ -19860,7 +19981,7 @@
               <a:buNone/>
             </a:pPr>
             <a:r>
-              <a:rPr lang="en-US" sz="1650" dirty="0">
+              <a:rPr lang="en-US" sz="1600" dirty="0">
                 <a:solidFill>
                   <a:srgbClr val="FFFFFF"/>
                 </a:solidFill>
@@ -19870,7 +19991,7 @@
               </a:rPr>
               <a:t>Trusted tools make it real</a:t>
             </a:r>
-            <a:endParaRPr lang="en-US" sz="1650" dirty="0"/>
+            <a:endParaRPr lang="en-US" sz="1600" dirty="0"/>
           </a:p>
         </p:txBody>
       </p:sp>
@@ -19949,7 +20070,7 @@
               <a:buNone/>
             </a:pPr>
             <a:r>
-              <a:rPr lang="en-US" sz="2025" b="1" dirty="0">
+              <a:rPr lang="en-US" sz="2000" b="1" dirty="0">
                 <a:solidFill>
                   <a:srgbClr val="00B0F0"/>
                 </a:solidFill>
@@ -19959,7 +20080,7 @@
               </a:rPr>
               <a:t>ADJUDICATE</a:t>
             </a:r>
-            <a:endParaRPr lang="en-US" sz="2025" dirty="0"/>
+            <a:endParaRPr lang="en-US" sz="2000" dirty="0"/>
           </a:p>
         </p:txBody>
       </p:sp>
@@ -19990,7 +20111,7 @@
               <a:buNone/>
             </a:pPr>
             <a:r>
-              <a:rPr lang="en-US" sz="1650" dirty="0">
+              <a:rPr lang="en-US" sz="1600" dirty="0">
                 <a:solidFill>
                   <a:srgbClr val="FFFFFF"/>
                 </a:solidFill>
@@ -20000,7 +20121,7 @@
               </a:rPr>
               <a:t>Engineer owns the call</a:t>
             </a:r>
-            <a:endParaRPr lang="en-US" sz="1650" dirty="0"/>
+            <a:endParaRPr lang="en-US" sz="1600" dirty="0"/>
           </a:p>
         </p:txBody>
       </p:sp>
@@ -20151,7 +20272,7 @@
               <a:buNone/>
             </a:pPr>
             <a:r>
-              <a:rPr lang="en-US" sz="1650" b="1" dirty="0">
+              <a:rPr lang="en-US" sz="1600" b="1" dirty="0">
                 <a:solidFill>
                   <a:srgbClr val="595959"/>
                 </a:solidFill>
@@ -20161,7 +20282,7 @@
               </a:rPr>
               <a:t>ITERATE</a:t>
             </a:r>
-            <a:endParaRPr lang="en-US" sz="1650" dirty="0"/>
+            <a:endParaRPr lang="en-US" sz="1600" dirty="0"/>
           </a:p>
         </p:txBody>
       </p:sp>
@@ -20174,7 +20295,7 @@
         <p:spPr>
           <a:xfrm>
             <a:off x="1810512" y="3611880"/>
-            <a:ext cx="12847320" cy="393192"/>
+            <a:ext cx="11768328" cy="393192"/>
           </a:xfrm>
           <a:prstGeom prst="rect">
             <a:avLst/>
@@ -20236,7 +20357,7 @@
               <a:buNone/>
             </a:pPr>
             <a:r>
-              <a:rPr lang="en-US" sz="2250" b="1" dirty="0">
+              <a:rPr lang="en-US" sz="2200" b="1" dirty="0">
                 <a:solidFill>
                   <a:srgbClr val="1F6FB2"/>
                 </a:solidFill>
@@ -20246,7 +20367,7 @@
               </a:rPr>
               <a:t>1</a:t>
             </a:r>
-            <a:endParaRPr lang="en-US" sz="2250" dirty="0"/>
+            <a:endParaRPr lang="en-US" sz="2200" dirty="0"/>
           </a:p>
         </p:txBody>
       </p:sp>
@@ -20280,7 +20401,7 @@
               <a:buNone/>
             </a:pPr>
             <a:r>
-              <a:rPr lang="en-US" sz="2025" dirty="0">
+              <a:rPr lang="en-US" sz="2000" dirty="0">
                 <a:solidFill>
                   <a:srgbClr val="000000"/>
                 </a:solidFill>
@@ -20291,7 +20412,7 @@
               <a:t xml:space="preserve">Put your project in a GitHub repo  </a:t>
             </a:r>
             <a:r>
-              <a:rPr lang="en-US" sz="2025" dirty="0">
+              <a:rPr lang="en-US" sz="2000" dirty="0">
                 <a:solidFill>
                   <a:srgbClr val="595959"/>
                 </a:solidFill>
@@ -20301,7 +20422,7 @@
               </a:rPr>
               <a:t>(done in Lesson 1)</a:t>
             </a:r>
-            <a:endParaRPr lang="en-US" sz="2025" dirty="0"/>
+            <a:endParaRPr lang="en-US" sz="2000" dirty="0"/>
           </a:p>
         </p:txBody>
       </p:sp>
@@ -20335,7 +20456,7 @@
               <a:buNone/>
             </a:pPr>
             <a:r>
-              <a:rPr lang="en-US" sz="2250" b="1" dirty="0">
+              <a:rPr lang="en-US" sz="2200" b="1" dirty="0">
                 <a:solidFill>
                   <a:srgbClr val="1F6FB2"/>
                 </a:solidFill>
@@ -20345,7 +20466,7 @@
               </a:rPr>
               <a:t>2</a:t>
             </a:r>
-            <a:endParaRPr lang="en-US" sz="2250" dirty="0"/>
+            <a:endParaRPr lang="en-US" sz="2200" dirty="0"/>
           </a:p>
         </p:txBody>
       </p:sp>
@@ -20379,7 +20500,7 @@
               <a:buNone/>
             </a:pPr>
             <a:r>
-              <a:rPr lang="en-US" sz="2025" dirty="0">
+              <a:rPr lang="en-US" sz="2000" dirty="0">
                 <a:solidFill>
                   <a:srgbClr val="000000"/>
                 </a:solidFill>
@@ -20389,7 +20510,7 @@
               </a:rPr>
               <a:t>Open a task in Codex, Claude Code, or another coding agent</a:t>
             </a:r>
-            <a:endParaRPr lang="en-US" sz="2025" dirty="0"/>
+            <a:endParaRPr lang="en-US" sz="2000" dirty="0"/>
           </a:p>
         </p:txBody>
       </p:sp>
@@ -20423,7 +20544,7 @@
               <a:buNone/>
             </a:pPr>
             <a:r>
-              <a:rPr lang="en-US" sz="2250" b="1" dirty="0">
+              <a:rPr lang="en-US" sz="2200" b="1" dirty="0">
                 <a:solidFill>
                   <a:srgbClr val="1F6FB2"/>
                 </a:solidFill>
@@ -20433,7 +20554,7 @@
               </a:rPr>
               <a:t>3</a:t>
             </a:r>
-            <a:endParaRPr lang="en-US" sz="2250" dirty="0"/>
+            <a:endParaRPr lang="en-US" sz="2200" dirty="0"/>
           </a:p>
         </p:txBody>
       </p:sp>
@@ -20467,7 +20588,7 @@
               <a:buNone/>
             </a:pPr>
             <a:r>
-              <a:rPr lang="en-US" sz="2025" dirty="0">
+              <a:rPr lang="en-US" sz="2000" dirty="0">
                 <a:solidFill>
                   <a:srgbClr val="000000"/>
                 </a:solidFill>
@@ -20477,7 +20598,7 @@
               </a:rPr>
               <a:t>Connect your repo to the agent, with a context file (AGENTS.md)</a:t>
             </a:r>
-            <a:endParaRPr lang="en-US" sz="2025" dirty="0"/>
+            <a:endParaRPr lang="en-US" sz="2000" dirty="0"/>
           </a:p>
         </p:txBody>
       </p:sp>
@@ -20511,7 +20632,7 @@
               <a:buNone/>
             </a:pPr>
             <a:r>
-              <a:rPr lang="en-US" sz="2250" b="1" dirty="0">
+              <a:rPr lang="en-US" sz="2200" b="1" dirty="0">
                 <a:solidFill>
                   <a:srgbClr val="1F6FB2"/>
                 </a:solidFill>
@@ -20521,7 +20642,7 @@
               </a:rPr>
               <a:t>4</a:t>
             </a:r>
-            <a:endParaRPr lang="en-US" sz="2250" dirty="0"/>
+            <a:endParaRPr lang="en-US" sz="2200" dirty="0"/>
           </a:p>
         </p:txBody>
       </p:sp>
@@ -20555,7 +20676,7 @@
               <a:buNone/>
             </a:pPr>
             <a:r>
-              <a:rPr lang="en-US" sz="2025" dirty="0">
+              <a:rPr lang="en-US" sz="2000" dirty="0">
                 <a:solidFill>
                   <a:srgbClr val="000000"/>
                 </a:solidFill>
@@ -20565,7 +20686,7 @@
               </a:rPr>
               <a:t>Work with the agent to generate commits on a branch</a:t>
             </a:r>
-            <a:endParaRPr lang="en-US" sz="2025" dirty="0"/>
+            <a:endParaRPr lang="en-US" sz="2000" dirty="0"/>
           </a:p>
         </p:txBody>
       </p:sp>
@@ -20599,7 +20720,7 @@
               <a:buNone/>
             </a:pPr>
             <a:r>
-              <a:rPr lang="en-US" sz="2250" b="1" dirty="0">
+              <a:rPr lang="en-US" sz="2200" b="1" dirty="0">
                 <a:solidFill>
                   <a:srgbClr val="1F6FB2"/>
                 </a:solidFill>
@@ -20609,7 +20730,7 @@
               </a:rPr>
               <a:t>5</a:t>
             </a:r>
-            <a:endParaRPr lang="en-US" sz="2250" dirty="0"/>
+            <a:endParaRPr lang="en-US" sz="2200" dirty="0"/>
           </a:p>
         </p:txBody>
       </p:sp>
@@ -20643,7 +20764,7 @@
               <a:buNone/>
             </a:pPr>
             <a:r>
-              <a:rPr lang="en-US" sz="2025" dirty="0">
+              <a:rPr lang="en-US" sz="2000" dirty="0">
                 <a:solidFill>
                   <a:srgbClr val="000000"/>
                 </a:solidFill>
@@ -20653,7 +20774,7 @@
               </a:rPr>
               <a:t>Adjudicate the agent’s work yourself, and iterate</a:t>
             </a:r>
-            <a:endParaRPr lang="en-US" sz="2025" dirty="0"/>
+            <a:endParaRPr lang="en-US" sz="2000" dirty="0"/>
           </a:p>
         </p:txBody>
       </p:sp>
@@ -20666,7 +20787,7 @@
         <p:spPr>
           <a:xfrm>
             <a:off x="133350" y="2762250"/>
-            <a:ext cx="1442184" cy="381000"/>
+            <a:ext cx="1409700" cy="381000"/>
           </a:xfrm>
           <a:prstGeom prst="rect">
             <a:avLst/>
@@ -20851,7 +20972,7 @@
               <a:buNone/>
             </a:pPr>
             <a:r>
-              <a:rPr lang="en-US" sz="1725" b="1" dirty="0">
+              <a:rPr lang="en-US" sz="1700" b="1" dirty="0">
                 <a:solidFill>
                   <a:srgbClr val="FFFFFF"/>
                 </a:solidFill>
@@ -20861,7 +20982,7 @@
               </a:rPr>
               <a:t>Tool</a:t>
             </a:r>
-            <a:endParaRPr lang="en-US" sz="1725" dirty="0"/>
+            <a:endParaRPr lang="en-US" sz="1700" dirty="0"/>
           </a:p>
         </p:txBody>
       </p:sp>
@@ -20916,7 +21037,7 @@
               <a:buNone/>
             </a:pPr>
             <a:r>
-              <a:rPr lang="en-US" sz="1725" b="1" dirty="0">
+              <a:rPr lang="en-US" sz="1700" b="1" dirty="0">
                 <a:solidFill>
                   <a:srgbClr val="FFFFFF"/>
                 </a:solidFill>
@@ -20926,7 +21047,7 @@
               </a:rPr>
               <a:t>Where it runs</a:t>
             </a:r>
-            <a:endParaRPr lang="en-US" sz="1725" dirty="0"/>
+            <a:endParaRPr lang="en-US" sz="1700" dirty="0"/>
           </a:p>
         </p:txBody>
       </p:sp>
@@ -20981,7 +21102,7 @@
               <a:buNone/>
             </a:pPr>
             <a:r>
-              <a:rPr lang="en-US" sz="1725" b="1" dirty="0">
+              <a:rPr lang="en-US" sz="1700" b="1" dirty="0">
                 <a:solidFill>
                   <a:srgbClr val="FFFFFF"/>
                 </a:solidFill>
@@ -20991,7 +21112,7 @@
               </a:rPr>
               <a:t>Access</a:t>
             </a:r>
-            <a:endParaRPr lang="en-US" sz="1725" dirty="0"/>
+            <a:endParaRPr lang="en-US" sz="1700" dirty="0"/>
           </a:p>
         </p:txBody>
       </p:sp>
@@ -21046,7 +21167,7 @@
               <a:buNone/>
             </a:pPr>
             <a:r>
-              <a:rPr lang="en-US" sz="1725" b="1" dirty="0">
+              <a:rPr lang="en-US" sz="1700" b="1" dirty="0">
                 <a:solidFill>
                   <a:srgbClr val="FFFFFF"/>
                 </a:solidFill>
@@ -21056,7 +21177,7 @@
               </a:rPr>
               <a:t>Context file</a:t>
             </a:r>
-            <a:endParaRPr lang="en-US" sz="1725" dirty="0"/>
+            <a:endParaRPr lang="en-US" sz="1700" dirty="0"/>
           </a:p>
         </p:txBody>
       </p:sp>
@@ -21087,7 +21208,7 @@
               <a:buNone/>
             </a:pPr>
             <a:r>
-              <a:rPr lang="en-US" sz="1725" b="1" dirty="0">
+              <a:rPr lang="en-US" sz="1700" b="1" dirty="0">
                 <a:solidFill>
                   <a:srgbClr val="000000"/>
                 </a:solidFill>
@@ -21098,7 +21219,7 @@
               <a:t xml:space="preserve">ChatGPT Codex </a:t>
             </a:r>
             <a:r>
-              <a:rPr lang="en-US" sz="1725" b="1" dirty="0">
+              <a:rPr lang="en-US" sz="1700" b="1" dirty="0">
                 <a:solidFill>
                   <a:srgbClr val="404040"/>
                 </a:solidFill>
@@ -21108,7 +21229,7 @@
               </a:rPr>
               <a:t>(this lesson)</a:t>
             </a:r>
-            <a:endParaRPr lang="en-US" sz="1725" dirty="0"/>
+            <a:endParaRPr lang="en-US" sz="1700" dirty="0"/>
           </a:p>
         </p:txBody>
       </p:sp>
@@ -21163,7 +21284,7 @@
               <a:buNone/>
             </a:pPr>
             <a:r>
-              <a:rPr lang="en-US" sz="1725" dirty="0">
+              <a:rPr lang="en-US" sz="1700" dirty="0">
                 <a:solidFill>
                   <a:srgbClr val="000000"/>
                 </a:solidFill>
@@ -21173,7 +21294,7 @@
               </a:rPr>
               <a:t>Cloud environment from your GitHub repo; also app, CLI, VS Code</a:t>
             </a:r>
-            <a:endParaRPr lang="en-US" sz="1725" dirty="0"/>
+            <a:endParaRPr lang="en-US" sz="1700" dirty="0"/>
           </a:p>
         </p:txBody>
       </p:sp>
@@ -21228,7 +21349,7 @@
               <a:buNone/>
             </a:pPr>
             <a:r>
-              <a:rPr lang="en-US" sz="1725" dirty="0">
+              <a:rPr lang="en-US" sz="1700" dirty="0">
                 <a:solidFill>
                   <a:srgbClr val="000000"/>
                 </a:solidFill>
@@ -21238,7 +21359,7 @@
               </a:rPr>
               <a:t>ChatGPT Plus plan or higher</a:t>
             </a:r>
-            <a:endParaRPr lang="en-US" sz="1725" dirty="0"/>
+            <a:endParaRPr lang="en-US" sz="1700" dirty="0"/>
           </a:p>
         </p:txBody>
       </p:sp>
@@ -21293,7 +21414,7 @@
               <a:buNone/>
             </a:pPr>
             <a:r>
-              <a:rPr lang="en-US" sz="1725" dirty="0">
+              <a:rPr lang="en-US" sz="1700" dirty="0">
                 <a:solidFill>
                   <a:srgbClr val="000000"/>
                 </a:solidFill>
@@ -21303,7 +21424,7 @@
               </a:rPr>
               <a:t>AGENTS.md</a:t>
             </a:r>
-            <a:endParaRPr lang="en-US" sz="1725" dirty="0"/>
+            <a:endParaRPr lang="en-US" sz="1700" dirty="0"/>
           </a:p>
         </p:txBody>
       </p:sp>
@@ -21358,7 +21479,7 @@
               <a:buNone/>
             </a:pPr>
             <a:r>
-              <a:rPr lang="en-US" sz="1725" b="1" dirty="0">
+              <a:rPr lang="en-US" sz="1700" b="1" dirty="0">
                 <a:solidFill>
                   <a:srgbClr val="000000"/>
                 </a:solidFill>
@@ -21368,7 +21489,7 @@
               </a:rPr>
               <a:t>Claude Code</a:t>
             </a:r>
-            <a:endParaRPr lang="en-US" sz="1725" dirty="0"/>
+            <a:endParaRPr lang="en-US" sz="1700" dirty="0"/>
           </a:p>
         </p:txBody>
       </p:sp>
@@ -21423,7 +21544,7 @@
               <a:buNone/>
             </a:pPr>
             <a:r>
-              <a:rPr lang="en-US" sz="1725" dirty="0">
+              <a:rPr lang="en-US" sz="1700" dirty="0">
                 <a:solidFill>
                   <a:srgbClr val="000000"/>
                 </a:solidFill>
@@ -21433,7 +21554,7 @@
               </a:rPr>
               <a:t>Cloud sandbox from your GitHub repo; also CLI and VS Code extension</a:t>
             </a:r>
-            <a:endParaRPr lang="en-US" sz="1725" dirty="0"/>
+            <a:endParaRPr lang="en-US" sz="1700" dirty="0"/>
           </a:p>
         </p:txBody>
       </p:sp>
@@ -21488,7 +21609,7 @@
               <a:buNone/>
             </a:pPr>
             <a:r>
-              <a:rPr lang="en-US" sz="1725" dirty="0">
+              <a:rPr lang="en-US" sz="1700" dirty="0">
                 <a:solidFill>
                   <a:srgbClr val="000000"/>
                 </a:solidFill>
@@ -21498,7 +21619,7 @@
               </a:rPr>
               <a:t>Claude Pro plan or higher</a:t>
             </a:r>
-            <a:endParaRPr lang="en-US" sz="1725" dirty="0"/>
+            <a:endParaRPr lang="en-US" sz="1700" dirty="0"/>
           </a:p>
         </p:txBody>
       </p:sp>
@@ -21553,7 +21674,7 @@
               <a:buNone/>
             </a:pPr>
             <a:r>
-              <a:rPr lang="en-US" sz="1725" dirty="0">
+              <a:rPr lang="en-US" sz="1700" dirty="0">
                 <a:solidFill>
                   <a:srgbClr val="000000"/>
                 </a:solidFill>
@@ -21563,7 +21684,7 @@
               </a:rPr>
               <a:t>CLAUDE.md (can import AGENTS.md)</a:t>
             </a:r>
-            <a:endParaRPr lang="en-US" sz="1725" dirty="0"/>
+            <a:endParaRPr lang="en-US" sz="1700" dirty="0"/>
           </a:p>
         </p:txBody>
       </p:sp>
@@ -21618,7 +21739,7 @@
               <a:buNone/>
             </a:pPr>
             <a:r>
-              <a:rPr lang="en-US" sz="1725" b="1" dirty="0">
+              <a:rPr lang="en-US" sz="1700" b="1" dirty="0">
                 <a:solidFill>
                   <a:srgbClr val="000000"/>
                 </a:solidFill>
@@ -21628,7 +21749,7 @@
               </a:rPr>
               <a:t>GitHub Copilot agent mode</a:t>
             </a:r>
-            <a:endParaRPr lang="en-US" sz="1725" dirty="0"/>
+            <a:endParaRPr lang="en-US" sz="1700" dirty="0"/>
           </a:p>
         </p:txBody>
       </p:sp>
@@ -21683,7 +21804,7 @@
               <a:buNone/>
             </a:pPr>
             <a:r>
-              <a:rPr lang="en-US" sz="1725" dirty="0">
+              <a:rPr lang="en-US" sz="1700" dirty="0">
                 <a:solidFill>
                   <a:srgbClr val="000000"/>
                 </a:solidFill>
@@ -21693,7 +21814,7 @@
               </a:rPr>
               <a:t>VS Code on your laptop; coding agent on GitHub</a:t>
             </a:r>
-            <a:endParaRPr lang="en-US" sz="1725" dirty="0"/>
+            <a:endParaRPr lang="en-US" sz="1700" dirty="0"/>
           </a:p>
         </p:txBody>
       </p:sp>
@@ -21748,7 +21869,7 @@
               <a:buNone/>
             </a:pPr>
             <a:r>
-              <a:rPr lang="en-US" sz="1725" dirty="0">
+              <a:rPr lang="en-US" sz="1700" dirty="0">
                 <a:solidFill>
                   <a:srgbClr val="000000"/>
                 </a:solidFill>
@@ -21758,7 +21879,7 @@
               </a:rPr>
               <a:t>Copilot Free (limited) or paid plans</a:t>
             </a:r>
-            <a:endParaRPr lang="en-US" sz="1725" dirty="0"/>
+            <a:endParaRPr lang="en-US" sz="1700" dirty="0"/>
           </a:p>
         </p:txBody>
       </p:sp>
@@ -21813,7 +21934,7 @@
               <a:buNone/>
             </a:pPr>
             <a:r>
-              <a:rPr lang="en-US" sz="1725" dirty="0">
+              <a:rPr lang="en-US" sz="1700" dirty="0">
                 <a:solidFill>
                   <a:srgbClr val="000000"/>
                 </a:solidFill>
@@ -21823,14 +21944,14 @@
               </a:rPr>
               <a:t>.github/copilot-</a:t>
             </a:r>
-            <a:endParaRPr lang="en-US" sz="1725" dirty="0"/>
-          </a:p>
-          <a:p>
-            <a:pPr algn="l" indent="0" marL="0">
-              <a:buNone/>
-            </a:pPr>
-            <a:r>
-              <a:rPr lang="en-US" sz="1725" dirty="0">
+            <a:endParaRPr lang="en-US" sz="1700" dirty="0"/>
+          </a:p>
+          <a:p>
+            <a:pPr algn="l" indent="0" marL="0">
+              <a:buNone/>
+            </a:pPr>
+            <a:r>
+              <a:rPr lang="en-US" sz="1700" dirty="0">
                 <a:solidFill>
                   <a:srgbClr val="000000"/>
                 </a:solidFill>
@@ -21840,7 +21961,7 @@
               </a:rPr>
               <a:t>instructions.md</a:t>
             </a:r>
-            <a:endParaRPr lang="en-US" sz="1725" dirty="0"/>
+            <a:endParaRPr lang="en-US" sz="1700" dirty="0"/>
           </a:p>
         </p:txBody>
       </p:sp>
@@ -21898,7 +22019,7 @@
               <a:buNone/>
             </a:pPr>
             <a:r>
-              <a:rPr lang="en-US" sz="2250" b="1" dirty="0">
+              <a:rPr lang="en-US" sz="2200" b="1" dirty="0">
                 <a:solidFill>
                   <a:srgbClr val="1F6FB2"/>
                 </a:solidFill>
@@ -21908,7 +22029,7 @@
               </a:rPr>
               <a:t>1</a:t>
             </a:r>
-            <a:endParaRPr lang="en-US" sz="2250" dirty="0"/>
+            <a:endParaRPr lang="en-US" sz="2200" dirty="0"/>
           </a:p>
         </p:txBody>
       </p:sp>
@@ -21942,7 +22063,7 @@
               <a:buNone/>
             </a:pPr>
             <a:r>
-              <a:rPr lang="en-US" sz="1950" dirty="0">
+              <a:rPr lang="en-US" sz="1900" dirty="0">
                 <a:solidFill>
                   <a:srgbClr val="000000"/>
                 </a:solidFill>
@@ -21952,7 +22073,7 @@
               </a:rPr>
               <a:t>The five workflow steps are the same for every tool.</a:t>
             </a:r>
-            <a:endParaRPr lang="en-US" sz="1950" dirty="0"/>
+            <a:endParaRPr lang="en-US" sz="1900" dirty="0"/>
           </a:p>
         </p:txBody>
       </p:sp>
@@ -21986,7 +22107,7 @@
               <a:buNone/>
             </a:pPr>
             <a:r>
-              <a:rPr lang="en-US" sz="2250" b="1" dirty="0">
+              <a:rPr lang="en-US" sz="2200" b="1" dirty="0">
                 <a:solidFill>
                   <a:srgbClr val="1F6FB2"/>
                 </a:solidFill>
@@ -21996,7 +22117,7 @@
               </a:rPr>
               <a:t>2</a:t>
             </a:r>
-            <a:endParaRPr lang="en-US" sz="2250" dirty="0"/>
+            <a:endParaRPr lang="en-US" sz="2200" dirty="0"/>
           </a:p>
         </p:txBody>
       </p:sp>
@@ -22030,7 +22151,7 @@
               <a:buNone/>
             </a:pPr>
             <a:r>
-              <a:rPr lang="en-US" sz="1950" dirty="0">
+              <a:rPr lang="en-US" sz="1900" dirty="0">
                 <a:solidFill>
                   <a:srgbClr val="000000"/>
                 </a:solidFill>
@@ -22040,7 +22161,7 @@
               </a:rPr>
               <a:t>With a local agent, Exercises 2–3 become “open the repo folder in VS Code.” The agent edits your working copy; you review and commit in GitHub Desktop.</a:t>
             </a:r>
-            <a:endParaRPr lang="en-US" sz="1950" dirty="0"/>
+            <a:endParaRPr lang="en-US" sz="1900" dirty="0"/>
           </a:p>
         </p:txBody>
       </p:sp>
@@ -22094,7 +22215,7 @@
         <p:spPr>
           <a:xfrm>
             <a:off x="133350" y="2762250"/>
-            <a:ext cx="1442184" cy="381000"/>
+            <a:ext cx="1409700" cy="381000"/>
           </a:xfrm>
           <a:prstGeom prst="rect">
             <a:avLst/>
@@ -22318,7 +22439,7 @@
               <a:buNone/>
             </a:pPr>
             <a:r>
-              <a:rPr lang="en-US" sz="1650" b="1" dirty="0">
+              <a:rPr lang="en-US" sz="1600" b="1" dirty="0">
                 <a:solidFill>
                   <a:srgbClr val="404040"/>
                 </a:solidFill>
@@ -22328,7 +22449,7 @@
               </a:rPr>
               <a:t>STARTING POINT</a:t>
             </a:r>
-            <a:endParaRPr lang="en-US" sz="1650" dirty="0"/>
+            <a:endParaRPr lang="en-US" sz="1600" dirty="0"/>
           </a:p>
         </p:txBody>
       </p:sp>
@@ -22359,7 +22480,7 @@
               <a:buNone/>
             </a:pPr>
             <a:r>
-              <a:rPr lang="en-US" sz="1950" dirty="0">
+              <a:rPr lang="en-US" sz="1900" dirty="0">
                 <a:solidFill>
                   <a:srgbClr val="000000"/>
                 </a:solidFill>
@@ -22370,7 +22491,7 @@
               <a:t xml:space="preserve">Your </a:t>
             </a:r>
             <a:r>
-              <a:rPr lang="en-US" sz="1950" b="1" dirty="0">
+              <a:rPr lang="en-US" sz="1900" b="1" dirty="0">
                 <a:solidFill>
                   <a:srgbClr val="000000"/>
                 </a:solidFill>
@@ -22381,7 +22502,7 @@
               <a:t>beam-calc</a:t>
             </a:r>
             <a:r>
-              <a:rPr lang="en-US" sz="1950" dirty="0">
+              <a:rPr lang="en-US" sz="1900" dirty="0">
                 <a:solidFill>
                   <a:srgbClr val="000000"/>
                 </a:solidFill>
@@ -22392,7 +22513,7 @@
               <a:t xml:space="preserve"> repo from Lesson 1. </a:t>
             </a:r>
             <a:r>
-              <a:rPr lang="en-US" sz="1950" dirty="0">
+              <a:rPr lang="en-US" sz="1900" dirty="0">
                 <a:solidFill>
                   <a:srgbClr val="000000"/>
                 </a:solidFill>
@@ -22403,7 +22524,7 @@
               <a:t>beam.m</a:t>
             </a:r>
             <a:r>
-              <a:rPr lang="en-US" sz="1950" dirty="0">
+              <a:rPr lang="en-US" sz="1900" dirty="0">
                 <a:solidFill>
                   <a:srgbClr val="000000"/>
                 </a:solidFill>
@@ -22414,7 +22535,7 @@
               <a:t xml:space="preserve"> computes cantilever tip deflection for a point load; </a:t>
             </a:r>
             <a:r>
-              <a:rPr lang="en-US" sz="1950" dirty="0">
+              <a:rPr lang="en-US" sz="1900" dirty="0">
                 <a:solidFill>
                   <a:srgbClr val="000000"/>
                 </a:solidFill>
@@ -22425,7 +22546,7 @@
               <a:t>tests/testBeam.m</a:t>
             </a:r>
             <a:r>
-              <a:rPr lang="en-US" sz="1950" dirty="0">
+              <a:rPr lang="en-US" sz="1900" dirty="0">
                 <a:solidFill>
                   <a:srgbClr val="000000"/>
                 </a:solidFill>
@@ -22435,7 +22556,7 @@
               </a:rPr>
               <a:t xml:space="preserve"> checks it.</a:t>
             </a:r>
-            <a:endParaRPr lang="en-US" sz="1950" dirty="0"/>
+            <a:endParaRPr lang="en-US" sz="1900" dirty="0"/>
           </a:p>
         </p:txBody>
       </p:sp>
@@ -22466,7 +22587,7 @@
               <a:buNone/>
             </a:pPr>
             <a:r>
-              <a:rPr lang="en-US" sz="1650" b="1" dirty="0">
+              <a:rPr lang="en-US" sz="1600" b="1" dirty="0">
                 <a:solidFill>
                   <a:srgbClr val="404040"/>
                 </a:solidFill>
@@ -22476,7 +22597,7 @@
               </a:rPr>
               <a:t>REQUIREMENT</a:t>
             </a:r>
-            <a:endParaRPr lang="en-US" sz="1650" dirty="0"/>
+            <a:endParaRPr lang="en-US" sz="1600" dirty="0"/>
           </a:p>
         </p:txBody>
       </p:sp>
@@ -22507,7 +22628,7 @@
               <a:buNone/>
             </a:pPr>
             <a:r>
-              <a:rPr lang="en-US" sz="1950" b="1" dirty="0">
+              <a:rPr lang="en-US" sz="1900" b="1" dirty="0">
                 <a:solidFill>
                   <a:srgbClr val="000000"/>
                 </a:solidFill>
@@ -22517,7 +22638,7 @@
               </a:rPr>
               <a:t>beam-calc shall compute the tip deflection for a uniformly distributed load w (N/m) with a function tipDeflectionUDL(w, L, E, I), and beam.m shall print it below the point-load result.</a:t>
             </a:r>
-            <a:endParaRPr lang="en-US" sz="1950" dirty="0"/>
+            <a:endParaRPr lang="en-US" sz="1900" dirty="0"/>
           </a:p>
         </p:txBody>
       </p:sp>
@@ -22548,7 +22669,7 @@
               <a:buNone/>
             </a:pPr>
             <a:r>
-              <a:rPr lang="en-US" sz="1650" b="1" dirty="0">
+              <a:rPr lang="en-US" sz="1600" b="1" dirty="0">
                 <a:solidFill>
                   <a:srgbClr val="404040"/>
                 </a:solidFill>
@@ -22558,7 +22679,7 @@
               </a:rPr>
               <a:t>VERIFICATION</a:t>
             </a:r>
-            <a:endParaRPr lang="en-US" sz="1650" dirty="0"/>
+            <a:endParaRPr lang="en-US" sz="1600" dirty="0"/>
           </a:p>
         </p:txBody>
       </p:sp>
@@ -22589,7 +22710,7 @@
               <a:buNone/>
             </a:pPr>
             <a:r>
-              <a:rPr lang="en-US" sz="1950" dirty="0">
+              <a:rPr lang="en-US" sz="1900" dirty="0">
                 <a:solidFill>
                   <a:srgbClr val="000000"/>
                 </a:solidFill>
@@ -22600,7 +22721,7 @@
               <a:t xml:space="preserve">Test: a new case in </a:t>
             </a:r>
             <a:r>
-              <a:rPr lang="en-US" sz="1950" dirty="0">
+              <a:rPr lang="en-US" sz="1900" dirty="0">
                 <a:solidFill>
                   <a:srgbClr val="000000"/>
                 </a:solidFill>
@@ -22611,7 +22732,7 @@
               <a:t>tests/testBeam.m</a:t>
             </a:r>
             <a:r>
-              <a:rPr lang="en-US" sz="1950" dirty="0">
+              <a:rPr lang="en-US" sz="1900" dirty="0">
                 <a:solidFill>
                   <a:srgbClr val="000000"/>
                 </a:solidFill>
@@ -22622,7 +22743,7 @@
               <a:t xml:space="preserve"> matches the hand calculation within 0.1%, and </a:t>
             </a:r>
             <a:r>
-              <a:rPr lang="en-US" sz="1950" dirty="0">
+              <a:rPr lang="en-US" sz="1900" dirty="0">
                 <a:solidFill>
                   <a:srgbClr val="000000"/>
                 </a:solidFill>
@@ -22633,7 +22754,7 @@
               <a:t>runtests('tests')</a:t>
             </a:r>
             <a:r>
-              <a:rPr lang="en-US" sz="1950" dirty="0">
+              <a:rPr lang="en-US" sz="1900" dirty="0">
                 <a:solidFill>
                   <a:srgbClr val="000000"/>
                 </a:solidFill>
@@ -22643,7 +22764,7 @@
               </a:rPr>
               <a:t xml:space="preserve"> passes in MATLAB. The point-load result is unchanged.</a:t>
             </a:r>
-            <a:endParaRPr lang="en-US" sz="1950" dirty="0"/>
+            <a:endParaRPr lang="en-US" sz="1900" dirty="0"/>
           </a:p>
         </p:txBody>
       </p:sp>
@@ -22694,7 +22815,7 @@
               <a:buNone/>
             </a:pPr>
             <a:r>
-              <a:rPr lang="en-US" sz="1950" b="1" dirty="0">
+              <a:rPr lang="en-US" sz="1900" b="1" dirty="0">
                 <a:solidFill>
                   <a:srgbClr val="152A47"/>
                 </a:solidFill>
@@ -22704,7 +22825,7 @@
               </a:rPr>
               <a:t>Theory</a:t>
             </a:r>
-            <a:endParaRPr lang="en-US" sz="1950" dirty="0"/>
+            <a:endParaRPr lang="en-US" sz="1900" dirty="0"/>
           </a:p>
         </p:txBody>
       </p:sp>
@@ -22735,7 +22856,7 @@
               <a:buNone/>
             </a:pPr>
             <a:r>
-              <a:rPr lang="en-US" sz="1950" dirty="0">
+              <a:rPr lang="en-US" sz="1900" dirty="0">
                 <a:solidFill>
                   <a:srgbClr val="000000"/>
                 </a:solidFill>
@@ -22745,7 +22866,7 @@
               </a:rPr>
               <a:t>Point load:   δ = P L³ / (3 E I)</a:t>
             </a:r>
-            <a:endParaRPr lang="en-US" sz="1950" dirty="0"/>
+            <a:endParaRPr lang="en-US" sz="1900" dirty="0"/>
           </a:p>
         </p:txBody>
       </p:sp>
@@ -22776,7 +22897,7 @@
               <a:buNone/>
             </a:pPr>
             <a:r>
-              <a:rPr lang="en-US" sz="1950" b="1" dirty="0">
+              <a:rPr lang="en-US" sz="1900" b="1" dirty="0">
                 <a:solidFill>
                   <a:srgbClr val="000000"/>
                 </a:solidFill>
@@ -22786,7 +22907,7 @@
               </a:rPr>
               <a:t>Distributed:  δ = w L⁴ / (8 E I)</a:t>
             </a:r>
-            <a:endParaRPr lang="en-US" sz="1950" dirty="0"/>
+            <a:endParaRPr lang="en-US" sz="1900" dirty="0"/>
           </a:p>
         </p:txBody>
       </p:sp>
@@ -22817,7 +22938,7 @@
               <a:buNone/>
             </a:pPr>
             <a:r>
-              <a:rPr lang="en-US" sz="1725" dirty="0">
+              <a:rPr lang="en-US" sz="1700" dirty="0">
                 <a:solidFill>
                   <a:srgbClr val="404040"/>
                 </a:solidFill>
@@ -22827,7 +22948,7 @@
               </a:rPr>
               <a:t>Same beam, P = wL: the distributed result is 3/8 of the point-load result.</a:t>
             </a:r>
-            <a:endParaRPr lang="en-US" sz="1725" dirty="0"/>
+            <a:endParaRPr lang="en-US" sz="1700" dirty="0"/>
           </a:p>
         </p:txBody>
       </p:sp>
@@ -22883,7 +23004,7 @@
               <a:buNone/>
             </a:pPr>
             <a:r>
-              <a:rPr lang="en-US" sz="1725" dirty="0">
+              <a:rPr lang="en-US" sz="1700" dirty="0">
                 <a:solidFill>
                   <a:srgbClr val="6A9955"/>
                 </a:solidFill>
@@ -22893,7 +23014,7 @@
               </a:rPr>
               <a:t>% Hand check</a:t>
             </a:r>
-            <a:endParaRPr lang="en-US" sz="1725" dirty="0"/>
+            <a:endParaRPr lang="en-US" sz="1700" dirty="0"/>
           </a:p>
           <a:p>
             <a:pPr algn="l" indent="0" marL="0">
@@ -22903,7 +23024,7 @@
               <a:buNone/>
             </a:pPr>
             <a:r>
-              <a:rPr lang="en-US" sz="1725" dirty="0">
+              <a:rPr lang="en-US" sz="1700" dirty="0">
                 <a:solidFill>
                   <a:srgbClr val="D4D4D4"/>
                 </a:solidFill>
@@ -22913,7 +23034,7 @@
               </a:rPr>
               <a:t>w = 1000;  L = 2.0;</a:t>
             </a:r>
-            <a:endParaRPr lang="en-US" sz="1725" dirty="0"/>
+            <a:endParaRPr lang="en-US" sz="1700" dirty="0"/>
           </a:p>
           <a:p>
             <a:pPr algn="l" indent="0" marL="0">
@@ -22923,7 +23044,7 @@
               <a:buNone/>
             </a:pPr>
             <a:r>
-              <a:rPr lang="en-US" sz="1725" dirty="0">
+              <a:rPr lang="en-US" sz="1700" dirty="0">
                 <a:solidFill>
                   <a:srgbClr val="D4D4D4"/>
                 </a:solidFill>
@@ -22933,7 +23054,7 @@
               </a:rPr>
               <a:t>E = 200e9;</a:t>
             </a:r>
-            <a:endParaRPr lang="en-US" sz="1725" dirty="0"/>
+            <a:endParaRPr lang="en-US" sz="1700" dirty="0"/>
           </a:p>
           <a:p>
             <a:pPr algn="l" indent="0" marL="0">
@@ -22943,7 +23064,7 @@
               <a:buNone/>
             </a:pPr>
             <a:r>
-              <a:rPr lang="en-US" sz="1725" dirty="0">
+              <a:rPr lang="en-US" sz="1700" dirty="0">
                 <a:solidFill>
                   <a:srgbClr val="D4D4D4"/>
                 </a:solidFill>
@@ -22953,7 +23074,7 @@
               </a:rPr>
               <a:t>I = 0.05*0.10^3/12;</a:t>
             </a:r>
-            <a:endParaRPr lang="en-US" sz="1725" dirty="0"/>
+            <a:endParaRPr lang="en-US" sz="1700" dirty="0"/>
           </a:p>
           <a:p>
             <a:pPr algn="l" indent="0" marL="0">
@@ -22963,7 +23084,7 @@
               <a:buNone/>
             </a:pPr>
             <a:r>
-              <a:rPr lang="en-US" sz="1725" dirty="0">
+              <a:rPr lang="en-US" sz="1700" dirty="0">
                 <a:solidFill>
                   <a:srgbClr val="89D185"/>
                 </a:solidFill>
@@ -22973,7 +23094,7 @@
               </a:rPr>
               <a:t>% δ = 2.40 mm</a:t>
             </a:r>
-            <a:endParaRPr lang="en-US" sz="1725" dirty="0"/>
+            <a:endParaRPr lang="en-US" sz="1700" dirty="0"/>
           </a:p>
         </p:txBody>
       </p:sp>
@@ -22986,7 +23107,7 @@
         <p:spPr>
           <a:xfrm>
             <a:off x="133350" y="3143250"/>
-            <a:ext cx="1442184" cy="381000"/>
+            <a:ext cx="1409700" cy="381000"/>
           </a:xfrm>
           <a:prstGeom prst="rect">
             <a:avLst/>
@@ -23176,7 +23297,7 @@
               <a:buNone/>
             </a:pPr>
             <a:r>
-              <a:rPr lang="en-US" sz="1650" dirty="0">
+              <a:rPr lang="en-US" sz="1600" dirty="0">
                 <a:solidFill>
                   <a:srgbClr val="00B0F0"/>
                 </a:solidFill>
@@ -23186,7 +23307,7 @@
               </a:rPr>
               <a:t># AGENTS.md</a:t>
             </a:r>
-            <a:endParaRPr lang="en-US" sz="1650" dirty="0"/>
+            <a:endParaRPr lang="en-US" sz="1600" dirty="0"/>
           </a:p>
           <a:p>
             <a:pPr algn="l" indent="0" marL="0">
@@ -23196,7 +23317,7 @@
               <a:buNone/>
             </a:pPr>
             <a:r>
-              <a:rPr lang="en-US" sz="1650" dirty="0">
+              <a:rPr lang="en-US" sz="1600" dirty="0">
                 <a:solidFill>
                   <a:srgbClr val="00B0F0"/>
                 </a:solidFill>
@@ -23206,7 +23327,7 @@
               </a:rPr>
               <a:t>## Project</a:t>
             </a:r>
-            <a:endParaRPr lang="en-US" sz="1650" dirty="0"/>
+            <a:endParaRPr lang="en-US" sz="1600" dirty="0"/>
           </a:p>
           <a:p>
             <a:pPr algn="l" indent="0" marL="0">
@@ -23216,7 +23337,7 @@
               <a:buNone/>
             </a:pPr>
             <a:r>
-              <a:rPr lang="en-US" sz="1650" dirty="0">
+              <a:rPr lang="en-US" sz="1600" dirty="0">
                 <a:solidFill>
                   <a:srgbClr val="D4D4D4"/>
                 </a:solidFill>
@@ -23226,7 +23347,7 @@
               </a:rPr>
               <a:t>- MATLAB R2024b, no toolboxes.</a:t>
             </a:r>
-            <a:endParaRPr lang="en-US" sz="1650" dirty="0"/>
+            <a:endParaRPr lang="en-US" sz="1600" dirty="0"/>
           </a:p>
           <a:p>
             <a:pPr algn="l" indent="0" marL="0">
@@ -23236,7 +23357,7 @@
               <a:buNone/>
             </a:pPr>
             <a:r>
-              <a:rPr lang="en-US" sz="1650" dirty="0">
+              <a:rPr lang="en-US" sz="1600" dirty="0">
                 <a:solidFill>
                   <a:srgbClr val="00B0F0"/>
                 </a:solidFill>
@@ -23246,7 +23367,7 @@
               </a:rPr>
               <a:t>## About me</a:t>
             </a:r>
-            <a:endParaRPr lang="en-US" sz="1650" dirty="0"/>
+            <a:endParaRPr lang="en-US" sz="1600" dirty="0"/>
           </a:p>
           <a:p>
             <a:pPr algn="l" indent="0" marL="0">
@@ -23256,7 +23377,7 @@
               <a:buNone/>
             </a:pPr>
             <a:r>
-              <a:rPr lang="en-US" sz="1650" dirty="0">
+              <a:rPr lang="en-US" sz="1600" dirty="0">
                 <a:solidFill>
                   <a:srgbClr val="D4D4D4"/>
                 </a:solidFill>
@@ -23266,7 +23387,7 @@
               </a:rPr>
               <a:t>- Instructor. Fluent in MATLAB,</a:t>
             </a:r>
-            <a:endParaRPr lang="en-US" sz="1650" dirty="0"/>
+            <a:endParaRPr lang="en-US" sz="1600" dirty="0"/>
           </a:p>
           <a:p>
             <a:pPr algn="l" indent="0" marL="0">
@@ -23276,7 +23397,7 @@
               <a:buNone/>
             </a:pPr>
             <a:r>
-              <a:rPr lang="en-US" sz="1650" dirty="0">
+              <a:rPr lang="en-US" sz="1600" dirty="0">
                 <a:solidFill>
                   <a:srgbClr val="D4D4D4"/>
                 </a:solidFill>
@@ -23286,7 +23407,7 @@
               </a:rPr>
               <a:t>  new to coding agents. Explain</a:t>
             </a:r>
-            <a:endParaRPr lang="en-US" sz="1650" dirty="0"/>
+            <a:endParaRPr lang="en-US" sz="1600" dirty="0"/>
           </a:p>
           <a:p>
             <a:pPr algn="l" indent="0" marL="0">
@@ -23296,7 +23417,7 @@
               <a:buNone/>
             </a:pPr>
             <a:r>
-              <a:rPr lang="en-US" sz="1650" dirty="0">
+              <a:rPr lang="en-US" sz="1600" dirty="0">
                 <a:solidFill>
                   <a:srgbClr val="D4D4D4"/>
                 </a:solidFill>
@@ -23306,7 +23427,7 @@
               </a:rPr>
               <a:t>  each change before coding.</a:t>
             </a:r>
-            <a:endParaRPr lang="en-US" sz="1650" dirty="0"/>
+            <a:endParaRPr lang="en-US" sz="1600" dirty="0"/>
           </a:p>
           <a:p>
             <a:pPr algn="l" indent="0" marL="0">
@@ -23316,7 +23437,7 @@
               <a:buNone/>
             </a:pPr>
             <a:r>
-              <a:rPr lang="en-US" sz="1650" dirty="0">
+              <a:rPr lang="en-US" sz="1600" dirty="0">
                 <a:solidFill>
                   <a:srgbClr val="00B0F0"/>
                 </a:solidFill>
@@ -23326,7 +23447,7 @@
               </a:rPr>
               <a:t>## Conventions</a:t>
             </a:r>
-            <a:endParaRPr lang="en-US" sz="1650" dirty="0"/>
+            <a:endParaRPr lang="en-US" sz="1600" dirty="0"/>
           </a:p>
           <a:p>
             <a:pPr algn="l" indent="0" marL="0">
@@ -23336,7 +23457,7 @@
               <a:buNone/>
             </a:pPr>
             <a:r>
-              <a:rPr lang="en-US" sz="1650" dirty="0">
+              <a:rPr lang="en-US" sz="1600" dirty="0">
                 <a:solidFill>
                   <a:srgbClr val="D4D4D4"/>
                 </a:solidFill>
@@ -23346,7 +23467,7 @@
               </a:rPr>
               <a:t>- SI units; comment the units</a:t>
             </a:r>
-            <a:endParaRPr lang="en-US" sz="1650" dirty="0"/>
+            <a:endParaRPr lang="en-US" sz="1600" dirty="0"/>
           </a:p>
           <a:p>
             <a:pPr algn="l" indent="0" marL="0">
@@ -23356,7 +23477,7 @@
               <a:buNone/>
             </a:pPr>
             <a:r>
-              <a:rPr lang="en-US" sz="1650" dirty="0">
+              <a:rPr lang="en-US" sz="1600" dirty="0">
                 <a:solidFill>
                   <a:srgbClr val="D4D4D4"/>
                 </a:solidFill>
@@ -23366,7 +23487,7 @@
               </a:rPr>
               <a:t>  on every constant.</a:t>
             </a:r>
-            <a:endParaRPr lang="en-US" sz="1650" dirty="0"/>
+            <a:endParaRPr lang="en-US" sz="1600" dirty="0"/>
           </a:p>
           <a:p>
             <a:pPr algn="l" indent="0" marL="0">
@@ -23376,7 +23497,7 @@
               <a:buNone/>
             </a:pPr>
             <a:r>
-              <a:rPr lang="en-US" sz="1650" dirty="0">
+              <a:rPr lang="en-US" sz="1600" dirty="0">
                 <a:solidFill>
                   <a:srgbClr val="D4D4D4"/>
                 </a:solidFill>
@@ -23386,7 +23507,7 @@
               </a:rPr>
               <a:t>- One function per file.</a:t>
             </a:r>
-            <a:endParaRPr lang="en-US" sz="1650" dirty="0"/>
+            <a:endParaRPr lang="en-US" sz="1600" dirty="0"/>
           </a:p>
           <a:p>
             <a:pPr algn="l" indent="0" marL="0">
@@ -23396,7 +23517,7 @@
               <a:buNone/>
             </a:pPr>
             <a:r>
-              <a:rPr lang="en-US" sz="1650" dirty="0">
+              <a:rPr lang="en-US" sz="1600" dirty="0">
                 <a:solidFill>
                   <a:srgbClr val="00B0F0"/>
                 </a:solidFill>
@@ -23406,7 +23527,7 @@
               </a:rPr>
               <a:t>## Environment and checks</a:t>
             </a:r>
-            <a:endParaRPr lang="en-US" sz="1650" dirty="0"/>
+            <a:endParaRPr lang="en-US" sz="1600" dirty="0"/>
           </a:p>
           <a:p>
             <a:pPr algn="l" indent="0" marL="0">
@@ -23416,7 +23537,7 @@
               <a:buNone/>
             </a:pPr>
             <a:r>
-              <a:rPr lang="en-US" sz="1650" dirty="0">
+              <a:rPr lang="en-US" sz="1600" dirty="0">
                 <a:solidFill>
                   <a:srgbClr val="D4D4D4"/>
                 </a:solidFill>
@@ -23426,7 +23547,7 @@
               </a:rPr>
               <a:t>- No MATLAB in your cloud</a:t>
             </a:r>
-            <a:endParaRPr lang="en-US" sz="1650" dirty="0"/>
+            <a:endParaRPr lang="en-US" sz="1600" dirty="0"/>
           </a:p>
           <a:p>
             <a:pPr algn="l" indent="0" marL="0">
@@ -23436,7 +23557,7 @@
               <a:buNone/>
             </a:pPr>
             <a:r>
-              <a:rPr lang="en-US" sz="1650" dirty="0">
+              <a:rPr lang="en-US" sz="1600" dirty="0">
                 <a:solidFill>
                   <a:srgbClr val="D4D4D4"/>
                 </a:solidFill>
@@ -23446,7 +23567,7 @@
               </a:rPr>
               <a:t>  environment. List the checks</a:t>
             </a:r>
-            <a:endParaRPr lang="en-US" sz="1650" dirty="0"/>
+            <a:endParaRPr lang="en-US" sz="1600" dirty="0"/>
           </a:p>
           <a:p>
             <a:pPr algn="l" indent="0" marL="0">
@@ -23456,7 +23577,7 @@
               <a:buNone/>
             </a:pPr>
             <a:r>
-              <a:rPr lang="en-US" sz="1650" dirty="0">
+              <a:rPr lang="en-US" sz="1600" dirty="0">
                 <a:solidFill>
                   <a:srgbClr val="D4D4D4"/>
                 </a:solidFill>
@@ -23466,7 +23587,7 @@
               </a:rPr>
               <a:t>  I must run myself.</a:t>
             </a:r>
-            <a:endParaRPr lang="en-US" sz="1650" dirty="0"/>
+            <a:endParaRPr lang="en-US" sz="1600" dirty="0"/>
           </a:p>
           <a:p>
             <a:pPr algn="l" indent="0" marL="0">
@@ -23476,7 +23597,7 @@
               <a:buNone/>
             </a:pPr>
             <a:r>
-              <a:rPr lang="en-US" sz="1650" dirty="0">
+              <a:rPr lang="en-US" sz="1600" dirty="0">
                 <a:solidFill>
                   <a:srgbClr val="D4D4D4"/>
                 </a:solidFill>
@@ -23486,7 +23607,7 @@
               </a:rPr>
               <a:t>- Never change an existing</a:t>
             </a:r>
-            <a:endParaRPr lang="en-US" sz="1650" dirty="0"/>
+            <a:endParaRPr lang="en-US" sz="1600" dirty="0"/>
           </a:p>
           <a:p>
             <a:pPr algn="l" indent="0" marL="0">
@@ -23496,7 +23617,7 @@
               <a:buNone/>
             </a:pPr>
             <a:r>
-              <a:rPr lang="en-US" sz="1650" dirty="0">
+              <a:rPr lang="en-US" sz="1600" dirty="0">
                 <a:solidFill>
                   <a:srgbClr val="D4D4D4"/>
                 </a:solidFill>
@@ -23506,7 +23627,7 @@
               </a:rPr>
               <a:t>  result or test without asking.</a:t>
             </a:r>
-            <a:endParaRPr lang="en-US" sz="1650" dirty="0"/>
+            <a:endParaRPr lang="en-US" sz="1600" dirty="0"/>
           </a:p>
         </p:txBody>
       </p:sp>
@@ -23607,7 +23728,7 @@
               <a:buNone/>
             </a:pPr>
             <a:r>
-              <a:rPr lang="en-US" sz="2250" b="1" dirty="0">
+              <a:rPr lang="en-US" sz="2200" b="1" dirty="0">
                 <a:solidFill>
                   <a:srgbClr val="1F6FB2"/>
                 </a:solidFill>
@@ -23617,7 +23738,7 @@
               </a:rPr>
               <a:t>1</a:t>
             </a:r>
-            <a:endParaRPr lang="en-US" sz="2250" dirty="0"/>
+            <a:endParaRPr lang="en-US" sz="2200" dirty="0"/>
           </a:p>
         </p:txBody>
       </p:sp>
@@ -23651,7 +23772,7 @@
               <a:buNone/>
             </a:pPr>
             <a:r>
-              <a:rPr lang="en-US" sz="1950" dirty="0">
+              <a:rPr lang="en-US" sz="1900" dirty="0">
                 <a:solidFill>
                   <a:srgbClr val="000000"/>
                 </a:solidFill>
@@ -23662,7 +23783,7 @@
               <a:t xml:space="preserve">In VS Code, open </a:t>
             </a:r>
             <a:r>
-              <a:rPr lang="en-US" sz="1950" b="1" dirty="0">
+              <a:rPr lang="en-US" sz="1900" b="1" dirty="0">
                 <a:solidFill>
                   <a:srgbClr val="000000"/>
                 </a:solidFill>
@@ -23673,7 +23794,7 @@
               <a:t>AGENTS.md</a:t>
             </a:r>
             <a:r>
-              <a:rPr lang="en-US" sz="1950" dirty="0">
+              <a:rPr lang="en-US" sz="1900" dirty="0">
                 <a:solidFill>
                   <a:srgbClr val="000000"/>
                 </a:solidFill>
@@ -23683,7 +23804,7 @@
               </a:rPr>
               <a:t xml:space="preserve"> from Lesson 1. Extend it like the example, adapted to you.</a:t>
             </a:r>
-            <a:endParaRPr lang="en-US" sz="1950" dirty="0"/>
+            <a:endParaRPr lang="en-US" sz="1900" dirty="0"/>
           </a:p>
         </p:txBody>
       </p:sp>
@@ -23717,7 +23838,7 @@
               <a:buNone/>
             </a:pPr>
             <a:r>
-              <a:rPr lang="en-US" sz="2250" b="1" dirty="0">
+              <a:rPr lang="en-US" sz="2200" b="1" dirty="0">
                 <a:solidFill>
                   <a:srgbClr val="1F6FB2"/>
                 </a:solidFill>
@@ -23727,7 +23848,7 @@
               </a:rPr>
               <a:t>2</a:t>
             </a:r>
-            <a:endParaRPr lang="en-US" sz="2250" dirty="0"/>
+            <a:endParaRPr lang="en-US" sz="2200" dirty="0"/>
           </a:p>
         </p:txBody>
       </p:sp>
@@ -23761,7 +23882,7 @@
               <a:buNone/>
             </a:pPr>
             <a:r>
-              <a:rPr lang="en-US" sz="1950" dirty="0">
+              <a:rPr lang="en-US" sz="1900" dirty="0">
                 <a:solidFill>
                   <a:srgbClr val="000000"/>
                 </a:solidFill>
@@ -23772,7 +23893,7 @@
               <a:t xml:space="preserve">Keep the </a:t>
             </a:r>
             <a:r>
-              <a:rPr lang="en-US" sz="1950" b="1" dirty="0">
+              <a:rPr lang="en-US" sz="1900" b="1" dirty="0">
                 <a:solidFill>
                   <a:srgbClr val="000000"/>
                 </a:solidFill>
@@ -23783,7 +23904,7 @@
               <a:t>Environment and checks</a:t>
             </a:r>
             <a:r>
-              <a:rPr lang="en-US" sz="1950" dirty="0">
+              <a:rPr lang="en-US" sz="1900" dirty="0">
                 <a:solidFill>
                   <a:srgbClr val="000000"/>
                 </a:solidFill>
@@ -23793,7 +23914,7 @@
               </a:rPr>
               <a:t> section: it tells Codex what it can’t verify.</a:t>
             </a:r>
-            <a:endParaRPr lang="en-US" sz="1950" dirty="0"/>
+            <a:endParaRPr lang="en-US" sz="1900" dirty="0"/>
           </a:p>
         </p:txBody>
       </p:sp>
@@ -23827,7 +23948,7 @@
               <a:buNone/>
             </a:pPr>
             <a:r>
-              <a:rPr lang="en-US" sz="2250" b="1" dirty="0">
+              <a:rPr lang="en-US" sz="2200" b="1" dirty="0">
                 <a:solidFill>
                   <a:srgbClr val="1F6FB2"/>
                 </a:solidFill>
@@ -23837,7 +23958,7 @@
               </a:rPr>
               <a:t>3</a:t>
             </a:r>
-            <a:endParaRPr lang="en-US" sz="2250" dirty="0"/>
+            <a:endParaRPr lang="en-US" sz="2200" dirty="0"/>
           </a:p>
         </p:txBody>
       </p:sp>
@@ -23871,7 +23992,7 @@
               <a:buNone/>
             </a:pPr>
             <a:r>
-              <a:rPr lang="en-US" sz="1950" dirty="0">
+              <a:rPr lang="en-US" sz="1900" dirty="0">
                 <a:solidFill>
                   <a:srgbClr val="000000"/>
                 </a:solidFill>
@@ -23882,7 +24003,7 @@
               <a:t xml:space="preserve">Commit to main: </a:t>
             </a:r>
             <a:r>
-              <a:rPr lang="en-US" sz="1950" i="1" dirty="0">
+              <a:rPr lang="en-US" sz="1900" i="1" dirty="0">
                 <a:solidFill>
                   <a:srgbClr val="000000"/>
                 </a:solidFill>
@@ -23893,7 +24014,7 @@
               <a:t>Update AGENTS.md</a:t>
             </a:r>
             <a:r>
-              <a:rPr lang="en-US" sz="1950" dirty="0">
+              <a:rPr lang="en-US" sz="1900" dirty="0">
                 <a:solidFill>
                   <a:srgbClr val="000000"/>
                 </a:solidFill>
@@ -23904,7 +24025,7 @@
               <a:t xml:space="preserve">. </a:t>
             </a:r>
             <a:r>
-              <a:rPr lang="en-US" sz="1950" b="1" dirty="0">
+              <a:rPr lang="en-US" sz="1900" b="1" dirty="0">
                 <a:solidFill>
                   <a:srgbClr val="000000"/>
                 </a:solidFill>
@@ -23915,7 +24036,7 @@
               <a:t>Push origin</a:t>
             </a:r>
             <a:r>
-              <a:rPr lang="en-US" sz="1950" dirty="0">
+              <a:rPr lang="en-US" sz="1900" dirty="0">
                 <a:solidFill>
                   <a:srgbClr val="000000"/>
                 </a:solidFill>
@@ -23925,7 +24046,7 @@
               </a:rPr>
               <a:t>.</a:t>
             </a:r>
-            <a:endParaRPr lang="en-US" sz="1950" dirty="0"/>
+            <a:endParaRPr lang="en-US" sz="1900" dirty="0"/>
           </a:p>
         </p:txBody>
       </p:sp>
@@ -24020,7 +24141,7 @@
         <p:spPr>
           <a:xfrm>
             <a:off x="133350" y="3524250"/>
-            <a:ext cx="1442184" cy="381000"/>
+            <a:ext cx="1409700" cy="381000"/>
           </a:xfrm>
           <a:prstGeom prst="rect">
             <a:avLst/>
@@ -24210,7 +24331,7 @@
               <a:buNone/>
             </a:pPr>
             <a:r>
-              <a:rPr lang="en-US" sz="2250" b="1" dirty="0">
+              <a:rPr lang="en-US" sz="2200" b="1" dirty="0">
                 <a:solidFill>
                   <a:srgbClr val="000000"/>
                 </a:solidFill>
@@ -24220,7 +24341,7 @@
               </a:rPr>
               <a:t>Codex cloud</a:t>
             </a:r>
-            <a:endParaRPr lang="en-US" sz="2250" dirty="0"/>
+            <a:endParaRPr lang="en-US" sz="2200" dirty="0"/>
           </a:p>
         </p:txBody>
       </p:sp>
@@ -24345,7 +24466,7 @@
               <a:buNone/>
             </a:pPr>
             <a:r>
-              <a:rPr lang="en-US" sz="2250" b="1" dirty="0">
+              <a:rPr lang="en-US" sz="2200" b="1" dirty="0">
                 <a:solidFill>
                   <a:srgbClr val="000000"/>
                 </a:solidFill>
@@ -24355,7 +24476,7 @@
               </a:rPr>
               <a:t>GitHub repo</a:t>
             </a:r>
-            <a:endParaRPr lang="en-US" sz="2250" dirty="0"/>
+            <a:endParaRPr lang="en-US" sz="2200" dirty="0"/>
           </a:p>
         </p:txBody>
       </p:sp>
@@ -24480,7 +24601,7 @@
               <a:buNone/>
             </a:pPr>
             <a:r>
-              <a:rPr lang="en-US" sz="2250" b="1" dirty="0">
+              <a:rPr lang="en-US" sz="2200" b="1" dirty="0">
                 <a:solidFill>
                   <a:srgbClr val="000000"/>
                 </a:solidFill>
@@ -24490,7 +24611,7 @@
               </a:rPr>
               <a:t>Your laptop</a:t>
             </a:r>
-            <a:endParaRPr lang="en-US" sz="2250" dirty="0"/>
+            <a:endParaRPr lang="en-US" sz="2200" dirty="0"/>
           </a:p>
         </p:txBody>
       </p:sp>
@@ -24562,7 +24683,7 @@
               <a:buNone/>
             </a:pPr>
             <a:r>
-              <a:rPr lang="en-US" sz="1950" dirty="0">
+              <a:rPr lang="en-US" sz="1900" dirty="0">
                 <a:solidFill>
                   <a:srgbClr val="404040"/>
                 </a:solidFill>
@@ -24572,7 +24693,7 @@
               </a:rPr>
               <a:t>A Codex task can read and change your repo. It cannot reach your laptop, your MATLAB license, or any file outside the repo.</a:t>
             </a:r>
-            <a:endParaRPr lang="en-US" sz="1950" dirty="0"/>
+            <a:endParaRPr lang="en-US" sz="1900" dirty="0"/>
           </a:p>
         </p:txBody>
       </p:sp>
@@ -24673,7 +24794,7 @@
               <a:buNone/>
             </a:pPr>
             <a:r>
-              <a:rPr lang="en-US" sz="2250" b="1" dirty="0">
+              <a:rPr lang="en-US" sz="2200" b="1" dirty="0">
                 <a:solidFill>
                   <a:srgbClr val="1F6FB2"/>
                 </a:solidFill>
@@ -24683,7 +24804,7 @@
               </a:rPr>
               <a:t>1</a:t>
             </a:r>
-            <a:endParaRPr lang="en-US" sz="2250" dirty="0"/>
+            <a:endParaRPr lang="en-US" sz="2200" dirty="0"/>
           </a:p>
         </p:txBody>
       </p:sp>
@@ -24717,7 +24838,7 @@
               <a:buNone/>
             </a:pPr>
             <a:r>
-              <a:rPr lang="en-US" sz="1950" dirty="0">
+              <a:rPr lang="en-US" sz="1900" dirty="0">
                 <a:solidFill>
                   <a:srgbClr val="000000"/>
                 </a:solidFill>
@@ -24728,7 +24849,7 @@
               <a:t xml:space="preserve">Go to </a:t>
             </a:r>
             <a:r>
-              <a:rPr lang="en-US" sz="1950" b="1" dirty="0">
+              <a:rPr lang="en-US" sz="1900" b="1" dirty="0">
                 <a:solidFill>
                   <a:srgbClr val="000000"/>
                 </a:solidFill>
@@ -24739,7 +24860,7 @@
               <a:t>chatgpt.com/codex</a:t>
             </a:r>
             <a:r>
-              <a:rPr lang="en-US" sz="1950" dirty="0">
+              <a:rPr lang="en-US" sz="1900" dirty="0">
                 <a:solidFill>
                   <a:srgbClr val="000000"/>
                 </a:solidFill>
@@ -24749,7 +24870,7 @@
               </a:rPr>
               <a:t xml:space="preserve"> and sign in.</a:t>
             </a:r>
-            <a:endParaRPr lang="en-US" sz="1950" dirty="0"/>
+            <a:endParaRPr lang="en-US" sz="1900" dirty="0"/>
           </a:p>
         </p:txBody>
       </p:sp>
@@ -24783,7 +24904,7 @@
               <a:buNone/>
             </a:pPr>
             <a:r>
-              <a:rPr lang="en-US" sz="2250" b="1" dirty="0">
+              <a:rPr lang="en-US" sz="2200" b="1" dirty="0">
                 <a:solidFill>
                   <a:srgbClr val="1F6FB2"/>
                 </a:solidFill>
@@ -24793,7 +24914,7 @@
               </a:rPr>
               <a:t>2</a:t>
             </a:r>
-            <a:endParaRPr lang="en-US" sz="2250" dirty="0"/>
+            <a:endParaRPr lang="en-US" sz="2200" dirty="0"/>
           </a:p>
         </p:txBody>
       </p:sp>
@@ -24827,7 +24948,7 @@
               <a:buNone/>
             </a:pPr>
             <a:r>
-              <a:rPr lang="en-US" sz="1950" dirty="0">
+              <a:rPr lang="en-US" sz="1900" dirty="0">
                 <a:solidFill>
                   <a:srgbClr val="000000"/>
                 </a:solidFill>
@@ -24838,7 +24959,7 @@
               <a:t xml:space="preserve">Connect GitHub when prompted. Give it access to </a:t>
             </a:r>
             <a:r>
-              <a:rPr lang="en-US" sz="1950" b="1" dirty="0">
+              <a:rPr lang="en-US" sz="1900" b="1" dirty="0">
                 <a:solidFill>
                   <a:srgbClr val="000000"/>
                 </a:solidFill>
@@ -24849,7 +24970,7 @@
               <a:t>your beam-calc repo only</a:t>
             </a:r>
             <a:r>
-              <a:rPr lang="en-US" sz="1950" dirty="0">
+              <a:rPr lang="en-US" sz="1900" dirty="0">
                 <a:solidFill>
                   <a:srgbClr val="000000"/>
                 </a:solidFill>
@@ -24859,7 +24980,7 @@
               </a:rPr>
               <a:t>.</a:t>
             </a:r>
-            <a:endParaRPr lang="en-US" sz="1950" dirty="0"/>
+            <a:endParaRPr lang="en-US" sz="1900" dirty="0"/>
           </a:p>
         </p:txBody>
       </p:sp>
@@ -24893,7 +25014,7 @@
               <a:buNone/>
             </a:pPr>
             <a:r>
-              <a:rPr lang="en-US" sz="2250" b="1" dirty="0">
+              <a:rPr lang="en-US" sz="2200" b="1" dirty="0">
                 <a:solidFill>
                   <a:srgbClr val="1F6FB2"/>
                 </a:solidFill>
@@ -24903,7 +25024,7 @@
               </a:rPr>
               <a:t>3</a:t>
             </a:r>
-            <a:endParaRPr lang="en-US" sz="2250" dirty="0"/>
+            <a:endParaRPr lang="en-US" sz="2200" dirty="0"/>
           </a:p>
         </p:txBody>
       </p:sp>
@@ -24937,7 +25058,7 @@
               <a:buNone/>
             </a:pPr>
             <a:r>
-              <a:rPr lang="en-US" sz="1950" dirty="0">
+              <a:rPr lang="en-US" sz="1900" dirty="0">
                 <a:solidFill>
                   <a:srgbClr val="000000"/>
                 </a:solidFill>
@@ -24948,7 +25069,7 @@
               <a:t xml:space="preserve">Create an </a:t>
             </a:r>
             <a:r>
-              <a:rPr lang="en-US" sz="1950" b="1" dirty="0">
+              <a:rPr lang="en-US" sz="1900" b="1" dirty="0">
                 <a:solidFill>
                   <a:srgbClr val="000000"/>
                 </a:solidFill>
@@ -24959,7 +25080,7 @@
               <a:t>environment</a:t>
             </a:r>
             <a:r>
-              <a:rPr lang="en-US" sz="1950" dirty="0">
+              <a:rPr lang="en-US" sz="1900" dirty="0">
                 <a:solidFill>
                   <a:srgbClr val="000000"/>
                 </a:solidFill>
@@ -24969,7 +25090,7 @@
               </a:rPr>
               <a:t xml:space="preserve"> for beam-calc. Leave agent internet access off.</a:t>
             </a:r>
-            <a:endParaRPr lang="en-US" sz="1950" dirty="0"/>
+            <a:endParaRPr lang="en-US" sz="1900" dirty="0"/>
           </a:p>
         </p:txBody>
       </p:sp>
@@ -25003,7 +25124,7 @@
               <a:buNone/>
             </a:pPr>
             <a:r>
-              <a:rPr lang="en-US" sz="2250" b="1" dirty="0">
+              <a:rPr lang="en-US" sz="2200" b="1" dirty="0">
                 <a:solidFill>
                   <a:srgbClr val="1F6FB2"/>
                 </a:solidFill>
@@ -25013,7 +25134,7 @@
               </a:rPr>
               <a:t>4</a:t>
             </a:r>
-            <a:endParaRPr lang="en-US" sz="2250" dirty="0"/>
+            <a:endParaRPr lang="en-US" sz="2200" dirty="0"/>
           </a:p>
         </p:txBody>
       </p:sp>
@@ -25047,7 +25168,7 @@
               <a:buNone/>
             </a:pPr>
             <a:r>
-              <a:rPr lang="en-US" sz="1950" dirty="0">
+              <a:rPr lang="en-US" sz="1900" dirty="0">
                 <a:solidFill>
                   <a:srgbClr val="000000"/>
                 </a:solidFill>
@@ -25058,7 +25179,7 @@
               <a:t xml:space="preserve">Start a task on </a:t>
             </a:r>
             <a:r>
-              <a:rPr lang="en-US" sz="1950" b="1" dirty="0">
+              <a:rPr lang="en-US" sz="1900" b="1" dirty="0">
                 <a:solidFill>
                   <a:srgbClr val="000000"/>
                 </a:solidFill>
@@ -25069,7 +25190,7 @@
               <a:t>beam-calc</a:t>
             </a:r>
             <a:r>
-              <a:rPr lang="en-US" sz="1950" dirty="0">
+              <a:rPr lang="en-US" sz="1900" dirty="0">
                 <a:solidFill>
                   <a:srgbClr val="000000"/>
                 </a:solidFill>
@@ -25080,7 +25201,7 @@
               <a:t xml:space="preserve"> and the </a:t>
             </a:r>
             <a:r>
-              <a:rPr lang="en-US" sz="1950" b="1" dirty="0">
+              <a:rPr lang="en-US" sz="1900" b="1" dirty="0">
                 <a:solidFill>
                   <a:srgbClr val="000000"/>
                 </a:solidFill>
@@ -25091,7 +25212,7 @@
               <a:t>main</a:t>
             </a:r>
             <a:r>
-              <a:rPr lang="en-US" sz="1950" dirty="0">
+              <a:rPr lang="en-US" sz="1900" dirty="0">
                 <a:solidFill>
                   <a:srgbClr val="000000"/>
                 </a:solidFill>
@@ -25101,7 +25222,7 @@
               </a:rPr>
               <a:t xml:space="preserve"> branch. Codex reads AGENTS.md automatically.</a:t>
             </a:r>
-            <a:endParaRPr lang="en-US" sz="1950" dirty="0"/>
+            <a:endParaRPr lang="en-US" sz="1900" dirty="0"/>
           </a:p>
         </p:txBody>
       </p:sp>
@@ -25114,7 +25235,7 @@
         <p:spPr>
           <a:xfrm>
             <a:off x="133350" y="3524250"/>
-            <a:ext cx="1442184" cy="381000"/>
+            <a:ext cx="1409700" cy="381000"/>
           </a:xfrm>
           <a:prstGeom prst="rect">
             <a:avLst/>
@@ -25200,6 +25321,30 @@
           </a:p>
         </p:txBody>
       </p:sp>
+      <p:pic>
+        <p:nvPicPr>
+          <p:cNvPr id="28" name="Screenshot placeholder" descr="Screenshot to add: Codex cloud: environment setup for beam-calc, repository selected and agent internet access off"/>
+          <p:cNvPicPr>
+            <a:picLocks noChangeAspect="1"/>
+          </p:cNvPicPr>
+          <p:nvPr/>
+        </p:nvPicPr>
+        <p:blipFill>
+          <a:blip r:embed="rId3"/>
+          <a:stretch>
+            <a:fillRect/>
+          </a:stretch>
+        </p:blipFill>
+        <p:spPr>
+          <a:xfrm>
+            <a:off x="1810512" y="7086600"/>
+            <a:ext cx="6949440" cy="2377440"/>
+          </a:xfrm>
+          <a:prstGeom prst="rect">
+            <a:avLst/>
+          </a:prstGeom>
+        </p:spPr>
+      </p:pic>
     </p:spTree>
   </p:cSld>
   <p:clrMapOvr>

</xml_diff>

<commit_message>
Lesson 2 method diagram: Iterate returns to Specify, Generate, and Implement
Replace the single loop back to Generate (loose rectangles and a
triangle) with a feedback line from Adjudicate and three arrow
connectors up to each earlier step. Speaker notes explain when to go
back to each one.

Co-Authored-By: Claude Opus 5.5 <noreply@anthropic.com>
Claude-Session: https://claude.ai/code/session_01EceYBcFXTaBjFSFEfqpJfg
</commit_message>
<xml_diff>
--- a/Lesson Material/LSN 2 - Introduction to Agentic AI for Coding/Agentic_AI_for_Engineering_Lesson_2.pptx
+++ b/Lesson Material/LSN 2 - Introduction to Agentic AI for Coding/Agentic_AI_for_Engineering_Lesson_2.pptx
@@ -1536,6 +1536,11 @@
             <a:r>
               <a:rPr lang="en-US" dirty="0"/>
               <a:t>Specify, Generate, Implement, Adjudicate, then Iterate. The agent is good at Generate. Specify and Adjudicate stay with the engineer; Implement means trusted tools (MATLAB, the compiler, test suites, hardware) turn the proposal into evidence. The five steps are the mechanics; every remaining slide maps to one of them.</a:t>
+            </a:r>
+          </a:p>
+          <a:p>
+            <a:r>
+              <a:t>Adjudication can send work back to any earlier step: re-specify when the requirement was wrong, regenerate when the design was, or fix the implementation when the build or tests were.</a:t>
             </a:r>
           </a:p>
         </p:txBody>
@@ -20127,167 +20132,6 @@
       </p:sp>
       <p:sp xmlns:p="http://schemas.openxmlformats.org/presentationml/2006/main" xmlns:a="http://schemas.openxmlformats.org/drawingml/2006/main" xmlns:r="http://schemas.openxmlformats.org/officeDocument/2006/relationships">
         <p:nvSpPr>
-          <p:cNvPr id="18" name="Shape 35"/>
-          <p:cNvSpPr/>
-          <p:nvPr/>
-        </p:nvSpPr>
-        <p:spPr>
-          <a:xfrm>
-            <a:off x="12051792" y="2761488"/>
-            <a:ext cx="36576" cy="384048"/>
-          </a:xfrm>
-          <a:prstGeom prst="rect">
-            <a:avLst/>
-          </a:prstGeom>
-          <a:solidFill>
-            <a:srgbClr val="595959"/>
-          </a:solidFill>
-          <a:ln/>
-        </p:spPr>
-        <p:txBody>
-          <a:bodyPr/>
-          <a:p/>
-        </p:txBody>
-      </p:sp>
-      <p:sp xmlns:p="http://schemas.openxmlformats.org/presentationml/2006/main" xmlns:a="http://schemas.openxmlformats.org/drawingml/2006/main" xmlns:r="http://schemas.openxmlformats.org/officeDocument/2006/relationships">
-        <p:nvSpPr>
-          <p:cNvPr id="19" name="Shape 36"/>
-          <p:cNvSpPr/>
-          <p:nvPr/>
-        </p:nvSpPr>
-        <p:spPr>
-          <a:xfrm>
-            <a:off x="6071616" y="3127248"/>
-            <a:ext cx="6016752" cy="36576"/>
-          </a:xfrm>
-          <a:prstGeom prst="rect">
-            <a:avLst/>
-          </a:prstGeom>
-          <a:solidFill>
-            <a:srgbClr val="595959"/>
-          </a:solidFill>
-          <a:ln/>
-        </p:spPr>
-        <p:txBody>
-          <a:bodyPr/>
-          <a:p/>
-        </p:txBody>
-      </p:sp>
-      <p:sp xmlns:p="http://schemas.openxmlformats.org/presentationml/2006/main" xmlns:a="http://schemas.openxmlformats.org/drawingml/2006/main" xmlns:r="http://schemas.openxmlformats.org/officeDocument/2006/relationships">
-        <p:nvSpPr>
-          <p:cNvPr id="20" name="Shape 37"/>
-          <p:cNvSpPr/>
-          <p:nvPr/>
-        </p:nvSpPr>
-        <p:spPr>
-          <a:xfrm>
-            <a:off x="6071616" y="2834640"/>
-            <a:ext cx="36576" cy="310896"/>
-          </a:xfrm>
-          <a:prstGeom prst="rect">
-            <a:avLst/>
-          </a:prstGeom>
-          <a:solidFill>
-            <a:srgbClr val="595959"/>
-          </a:solidFill>
-          <a:ln/>
-        </p:spPr>
-        <p:txBody>
-          <a:bodyPr/>
-          <a:p/>
-        </p:txBody>
-      </p:sp>
-      <p:sp xmlns:p="http://schemas.openxmlformats.org/presentationml/2006/main" xmlns:a="http://schemas.openxmlformats.org/drawingml/2006/main" xmlns:r="http://schemas.openxmlformats.org/officeDocument/2006/relationships">
-        <p:nvSpPr>
-          <p:cNvPr id="21" name="Shape 38"/>
-          <p:cNvSpPr/>
-          <p:nvPr/>
-        </p:nvSpPr>
-        <p:spPr>
-          <a:xfrm>
-            <a:off x="5971032" y="2770632"/>
-            <a:ext cx="237744" cy="155448"/>
-          </a:xfrm>
-          <a:prstGeom prst="triangle">
-            <a:avLst/>
-          </a:prstGeom>
-          <a:solidFill>
-            <a:srgbClr val="595959"/>
-          </a:solidFill>
-          <a:ln/>
-        </p:spPr>
-        <p:txBody>
-          <a:bodyPr/>
-          <a:p/>
-        </p:txBody>
-      </p:sp>
-      <p:sp xmlns:p="http://schemas.openxmlformats.org/presentationml/2006/main" xmlns:a="http://schemas.openxmlformats.org/drawingml/2006/main" xmlns:r="http://schemas.openxmlformats.org/officeDocument/2006/relationships">
-        <p:nvSpPr>
-          <p:cNvPr id="22" name="Shape 39"/>
-          <p:cNvSpPr/>
-          <p:nvPr/>
-        </p:nvSpPr>
-        <p:spPr>
-          <a:xfrm>
-            <a:off x="7269480" y="2971800"/>
-            <a:ext cx="1463040" cy="347472"/>
-          </a:xfrm>
-          <a:prstGeom prst="rect">
-            <a:avLst/>
-          </a:prstGeom>
-          <a:solidFill>
-            <a:srgbClr val="FFFFFF"/>
-          </a:solidFill>
-          <a:ln/>
-        </p:spPr>
-        <p:txBody>
-          <a:bodyPr/>
-          <a:p/>
-        </p:txBody>
-      </p:sp>
-      <p:sp xmlns:p="http://schemas.openxmlformats.org/presentationml/2006/main" xmlns:a="http://schemas.openxmlformats.org/drawingml/2006/main" xmlns:r="http://schemas.openxmlformats.org/officeDocument/2006/relationships">
-        <p:nvSpPr>
-          <p:cNvPr id="23" name="Text 40"/>
-          <p:cNvSpPr txBox="1"/>
-          <p:nvPr/>
-        </p:nvSpPr>
-        <p:spPr>
-          <a:xfrm>
-            <a:off x="7269480" y="2971800"/>
-            <a:ext cx="1463040" cy="347472"/>
-          </a:xfrm>
-          <a:prstGeom prst="rect">
-            <a:avLst/>
-          </a:prstGeom>
-          <a:noFill/>
-          <a:ln/>
-        </p:spPr>
-        <p:txBody>
-          <a:bodyPr wrap="square" lIns="25400" tIns="25400" rIns="25400" bIns="25400" rtlCol="0" anchor="t">
-            <a:noAutofit/>
-          </a:bodyPr>
-          <a:lstStyle/>
-          <a:p>
-            <a:pPr algn="ctr" indent="0" marL="0">
-              <a:buNone/>
-            </a:pPr>
-            <a:r>
-              <a:rPr lang="en-US" sz="1600" b="1" dirty="0">
-                <a:solidFill>
-                  <a:srgbClr val="595959"/>
-                </a:solidFill>
-                <a:latin typeface="+mn-lt"/>
-                <a:ea typeface="+mn-ea"/>
-                <a:cs typeface="+mn-cs"/>
-              </a:rPr>
-              <a:t>ITERATE</a:t>
-            </a:r>
-            <a:endParaRPr lang="en-US" sz="1600" dirty="0"/>
-          </a:p>
-        </p:txBody>
-      </p:sp>
-      <p:sp xmlns:p="http://schemas.openxmlformats.org/presentationml/2006/main" xmlns:a="http://schemas.openxmlformats.org/drawingml/2006/main" xmlns:r="http://schemas.openxmlformats.org/officeDocument/2006/relationships">
-        <p:nvSpPr>
           <p:cNvPr id="24" name="Text 41"/>
           <p:cNvSpPr txBox="1"/>
           <p:nvPr/>
@@ -20870,6 +20714,218 @@
               <a:t>‹#›</a:t>
             </a:fld>
             <a:endParaRPr lang="en-US"/>
+          </a:p>
+        </p:txBody>
+      </p:sp>
+      <p:cxnSp>
+        <p:nvCxnSpPr>
+          <p:cNvPr id="38" name="Iterate drop"/>
+          <p:cNvCxnSpPr/>
+          <p:nvPr/>
+        </p:nvCxnSpPr>
+        <p:spPr>
+          <a:xfrm>
+            <a:off x="12070080" y="2761488"/>
+            <a:ext cx="0" cy="384048"/>
+          </a:xfrm>
+          <a:prstGeom prst="line">
+            <a:avLst/>
+          </a:prstGeom>
+          <a:ln w="31750">
+            <a:solidFill>
+              <a:srgbClr val="595959"/>
+            </a:solidFill>
+          </a:ln>
+        </p:spPr>
+        <p:style>
+          <a:lnRef idx="2">
+            <a:schemeClr val="accent1"/>
+          </a:lnRef>
+          <a:fillRef idx="0">
+            <a:schemeClr val="accent1"/>
+          </a:fillRef>
+          <a:effectRef idx="1">
+            <a:schemeClr val="accent1"/>
+          </a:effectRef>
+          <a:fontRef idx="minor">
+            <a:schemeClr val="tx1"/>
+          </a:fontRef>
+        </p:style>
+      </p:cxnSp>
+      <p:cxnSp>
+        <p:nvCxnSpPr>
+          <p:cNvPr id="39" name="Iterate bus"/>
+          <p:cNvCxnSpPr/>
+          <p:nvPr/>
+        </p:nvCxnSpPr>
+        <p:spPr>
+          <a:xfrm flipH="1">
+            <a:off x="3099816" y="3145536"/>
+            <a:ext cx="8970264" cy="0"/>
+          </a:xfrm>
+          <a:prstGeom prst="line">
+            <a:avLst/>
+          </a:prstGeom>
+          <a:ln w="31750">
+            <a:solidFill>
+              <a:srgbClr val="595959"/>
+            </a:solidFill>
+          </a:ln>
+        </p:spPr>
+        <p:style>
+          <a:lnRef idx="2">
+            <a:schemeClr val="accent1"/>
+          </a:lnRef>
+          <a:fillRef idx="0">
+            <a:schemeClr val="accent1"/>
+          </a:fillRef>
+          <a:effectRef idx="1">
+            <a:schemeClr val="accent1"/>
+          </a:effectRef>
+          <a:fontRef idx="minor">
+            <a:schemeClr val="tx1"/>
+          </a:fontRef>
+        </p:style>
+      </p:cxnSp>
+      <p:cxnSp>
+        <p:nvCxnSpPr>
+          <p:cNvPr id="40" name="Iterate to Specify"/>
+          <p:cNvCxnSpPr/>
+          <p:nvPr/>
+        </p:nvCxnSpPr>
+        <p:spPr>
+          <a:xfrm flipV="1">
+            <a:off x="3099816" y="2779776"/>
+            <a:ext cx="0" cy="365760"/>
+          </a:xfrm>
+          <a:prstGeom prst="line">
+            <a:avLst/>
+          </a:prstGeom>
+          <a:ln w="31750">
+            <a:solidFill>
+              <a:srgbClr val="595959"/>
+            </a:solidFill>
+            <a:tailEnd type="triangle" w="lg" len="med"/>
+          </a:ln>
+        </p:spPr>
+        <p:style>
+          <a:lnRef idx="2">
+            <a:schemeClr val="accent1"/>
+          </a:lnRef>
+          <a:fillRef idx="0">
+            <a:schemeClr val="accent1"/>
+          </a:fillRef>
+          <a:effectRef idx="1">
+            <a:schemeClr val="accent1"/>
+          </a:effectRef>
+          <a:fontRef idx="minor">
+            <a:schemeClr val="tx1"/>
+          </a:fontRef>
+        </p:style>
+      </p:cxnSp>
+      <p:cxnSp>
+        <p:nvCxnSpPr>
+          <p:cNvPr id="41" name="Iterate to Generate"/>
+          <p:cNvCxnSpPr/>
+          <p:nvPr/>
+        </p:nvCxnSpPr>
+        <p:spPr>
+          <a:xfrm flipV="1">
+            <a:off x="6089904" y="2779776"/>
+            <a:ext cx="0" cy="365760"/>
+          </a:xfrm>
+          <a:prstGeom prst="line">
+            <a:avLst/>
+          </a:prstGeom>
+          <a:ln w="31750">
+            <a:solidFill>
+              <a:srgbClr val="595959"/>
+            </a:solidFill>
+            <a:tailEnd type="triangle" w="lg" len="med"/>
+          </a:ln>
+        </p:spPr>
+        <p:style>
+          <a:lnRef idx="2">
+            <a:schemeClr val="accent1"/>
+          </a:lnRef>
+          <a:fillRef idx="0">
+            <a:schemeClr val="accent1"/>
+          </a:fillRef>
+          <a:effectRef idx="1">
+            <a:schemeClr val="accent1"/>
+          </a:effectRef>
+          <a:fontRef idx="minor">
+            <a:schemeClr val="tx1"/>
+          </a:fontRef>
+        </p:style>
+      </p:cxnSp>
+      <p:cxnSp>
+        <p:nvCxnSpPr>
+          <p:cNvPr id="42" name="Iterate to Implement"/>
+          <p:cNvCxnSpPr/>
+          <p:nvPr/>
+        </p:nvCxnSpPr>
+        <p:spPr>
+          <a:xfrm flipV="1">
+            <a:off x="9079992" y="2779776"/>
+            <a:ext cx="0" cy="365760"/>
+          </a:xfrm>
+          <a:prstGeom prst="line">
+            <a:avLst/>
+          </a:prstGeom>
+          <a:ln w="31750">
+            <a:solidFill>
+              <a:srgbClr val="595959"/>
+            </a:solidFill>
+            <a:tailEnd type="triangle" w="lg" len="med"/>
+          </a:ln>
+        </p:spPr>
+        <p:style>
+          <a:lnRef idx="2">
+            <a:schemeClr val="accent1"/>
+          </a:lnRef>
+          <a:fillRef idx="0">
+            <a:schemeClr val="accent1"/>
+          </a:fillRef>
+          <a:effectRef idx="1">
+            <a:schemeClr val="accent1"/>
+          </a:effectRef>
+          <a:fontRef idx="minor">
+            <a:schemeClr val="tx1"/>
+          </a:fontRef>
+        </p:style>
+      </p:cxnSp>
+      <p:sp>
+        <p:nvSpPr>
+          <p:cNvPr id="43" name="Iterate label"/>
+          <p:cNvSpPr txBox="1"/>
+          <p:nvPr/>
+        </p:nvSpPr>
+        <p:spPr>
+          <a:xfrm>
+            <a:off x="9838944" y="3200400"/>
+            <a:ext cx="1463040" cy="310896"/>
+          </a:xfrm>
+          <a:prstGeom prst="rect">
+            <a:avLst/>
+          </a:prstGeom>
+          <a:noFill/>
+        </p:spPr>
+        <p:txBody>
+          <a:bodyPr wrap="none" lIns="0" rIns="0" tIns="0" bIns="0">
+            <a:spAutoFit/>
+          </a:bodyPr>
+          <a:lstStyle/>
+          <a:p>
+            <a:pPr algn="ctr"/>
+            <a:r>
+              <a:rPr sz="1600" b="1">
+                <a:solidFill>
+                  <a:srgbClr val="595959"/>
+                </a:solidFill>
+              </a:rPr>
+              <a:t>ITERATE</a:t>
+            </a:r>
           </a:p>
         </p:txBody>
       </p:sp>

</xml_diff>